<commit_message>
docs: refresh interim presentation results
</commit_message>
<xml_diff>
--- a/docs/presentation/fx-pulse-interim.pptx
+++ b/docs/presentation/fx-pulse-interim.pptx
@@ -2515,7 +2515,7 @@
                 <a:ea typeface="Arial" pitchFamily="34" charset="-122"/>
                 <a:cs typeface="Arial" pitchFamily="34" charset="-120"/>
               </a:rPr>
-              <a:t>РИСК РЕАЛИЗОВАЛСЯ</a:t>
+              <a:t>ГЛАВНЫЙ РИСК</a:t>
             </a:r>
             <a:endParaRPr lang="en-US" sz="1150" dirty="0"/>
           </a:p>
@@ -2554,7 +2554,7 @@
                 <a:ea typeface="Arial" pitchFamily="34" charset="-122"/>
                 <a:cs typeface="Arial" pitchFamily="34" charset="-120"/>
               </a:rPr>
-              <a:t>Устойчивый lift ≥ 1,3 не достигнут</a:t>
+              <a:t>Выбор победителя после 13 379 вариантов</a:t>
             </a:r>
             <a:endParaRPr lang="en-US" sz="1400" dirty="0"/>
           </a:p>
@@ -2596,7 +2596,7 @@
                 <a:ea typeface="Arial" pitchFamily="34" charset="-122"/>
                 <a:cs typeface="Arial" pitchFamily="34" charset="-120"/>
               </a:rPr>
-              <a:t>Позиция: не растягивать порог подгонкой окон, а честно предъявить отрицательный результат — постановка это прямо предусматривает. H1′ переходит из страховки в основной продуктовый сценарий: отсечка по стоимости не требует предсказуемости курса вообще.</a:t>
+              <a:t>Одна и та же OOT-история использовалась для сравнения моделей. Позиция: считать результат кандидатом, заранее заморозить признаки, модель и порог, а затем один раз проверить на новых датах или внешнем hold-out.</a:t>
             </a:r>
             <a:endParaRPr lang="en-US" sz="1150" dirty="0"/>
           </a:p>
@@ -2686,7 +2686,7 @@
                 <a:ea typeface="Arial" pitchFamily="34" charset="-122"/>
                 <a:cs typeface="Arial" pitchFamily="34" charset="-120"/>
               </a:rPr>
-              <a:t>РИСК ПОДГОНКИ</a:t>
+              <a:t>РАЗРЫВ С ПРОДУКТОМ</a:t>
             </a:r>
             <a:endParaRPr lang="en-US" sz="1150" dirty="0"/>
           </a:p>
@@ -2725,7 +2725,7 @@
                 <a:ea typeface="Arial" pitchFamily="34" charset="-122"/>
                 <a:cs typeface="Arial" pitchFamily="34" charset="-120"/>
               </a:rPr>
-              <a:t>Массовый перебор находит шум</a:t>
+              <a:t>Публичный курс ≠ курс клиента</a:t>
             </a:r>
             <a:endParaRPr lang="en-US" sz="1400" dirty="0"/>
           </a:p>
@@ -2767,7 +2767,7 @@
                 <a:ea typeface="Arial" pitchFamily="34" charset="-122"/>
                 <a:cs typeface="Arial" pitchFamily="34" charset="-120"/>
               </a:rPr>
-              <a:t>Лечение введено до прогона: сетка регистрируется заранее, SHA-256 конфига пишется в run_meta до интерпретации результата, block-bootstrap на интервалы, отчёт по всей сетке, а не по выжившим.</a:t>
+              <a:t>В данных нет bid/ask приложения, спреда, комиссии и суммы перевода. Позиция: не обещать клиентскую выгоду до пересчёта на исполнимой цене; сначала подключить банковский поток в закрытом контуре.</a:t>
             </a:r>
             <a:endParaRPr lang="en-US" sz="1150" dirty="0"/>
           </a:p>
@@ -2896,7 +2896,7 @@
                 <a:ea typeface="Arial" pitchFamily="34" charset="-122"/>
                 <a:cs typeface="Arial" pitchFamily="34" charset="-120"/>
               </a:rPr>
-              <a:t>Курс ЦБ — не курс исполнения</a:t>
+              <a:t>Строгая устойчивость ниже цели</a:t>
             </a:r>
             <a:endParaRPr lang="en-US" sz="1200" dirty="0"/>
           </a:p>
@@ -2938,7 +2938,7 @@
                 <a:ea typeface="Arial" pitchFamily="34" charset="-122"/>
                 <a:cs typeface="Arial" pitchFamily="34" charset="-120"/>
               </a:rPr>
-              <a:t>Клиент переводит по курсу приложения: реальное время, поставщики ликвидности. Все метрики посчитаны на публичном ряду</a:t>
+              <a:t>Same-week lift 1,18–1,23, худший год 1,19–1,26: raw lift выше 1,3 не равен готовому доказательству</a:t>
             </a:r>
             <a:endParaRPr lang="en-US" sz="1050" dirty="0"/>
           </a:p>
@@ -2977,7 +2977,7 @@
                 <a:ea typeface="Arial" pitchFamily="34" charset="-122"/>
                 <a:cs typeface="Arial" pitchFamily="34" charset="-120"/>
               </a:rPr>
-              <a:t>Формула подтверждена на одном коридоре</a:t>
+              <a:t>Нет клиентских логов</a:t>
             </a:r>
             <a:endParaRPr lang="en-US" sz="1200" dirty="0"/>
           </a:p>
@@ -3019,7 +3019,7 @@
                 <a:ea typeface="Arial" pitchFamily="34" charset="-122"/>
                 <a:cs typeface="Arial" pitchFamily="34" charset="-120"/>
               </a:rPr>
-              <a:t>п. 3.3 сверен на Казахстане за 4 месяца. Нацбанки по-разному датируют публикацию — у НБ КР дата уже указывает на завтра</a:t>
+              <a:t>Нельзя проверить causal-эффект пуша, конверсию, раздражение и оптимальную частоту без пилота</a:t>
             </a:r>
             <a:endParaRPr lang="en-US" sz="1050" dirty="0"/>
           </a:p>
@@ -3058,7 +3058,7 @@
                 <a:ea typeface="Arial" pitchFamily="34" charset="-122"/>
                 <a:cs typeface="Arial" pitchFamily="34" charset="-120"/>
               </a:rPr>
-              <a:t>Ликвидность KZT на MOEX обвалилась</a:t>
+              <a:t>Часть источников недоступна</a:t>
             </a:r>
             <a:endParaRPr lang="en-US" sz="1200" dirty="0"/>
           </a:p>
@@ -3100,7 +3100,7 @@
                 <a:ea typeface="Arial" pitchFamily="34" charset="-122"/>
                 <a:cs typeface="Arial" pitchFamily="34" charset="-120"/>
               </a:rPr>
-              <a:t>1125 сделок в день в 2023 → 72 в 2025 → 45 в 2026. Биржевые выводы опираются на период до 2025 года</a:t>
+              <a:t>Исторический order flow MOEX требует доступа; независимые ноги AMD/KGS/TJS заблокированы сетью/TLS</a:t>
             </a:r>
             <a:endParaRPr lang="en-US" sz="1050" dirty="0"/>
           </a:p>
@@ -3139,7 +3139,7 @@
                 <a:ea typeface="Arial" pitchFamily="34" charset="-122"/>
                 <a:cs typeface="Arial" pitchFamily="34" charset="-120"/>
               </a:rPr>
-              <a:t>Клиентских данных нет</a:t>
+              <a:t>Новости исключены</a:t>
             </a:r>
             <a:endParaRPr lang="en-US" sz="1200" dirty="0"/>
           </a:p>
@@ -3181,7 +3181,7 @@
                 <a:ea typeface="Arial" pitchFamily="34" charset="-122"/>
                 <a:cs typeface="Arial" pitchFamily="34" charset="-120"/>
               </a:rPr>
-              <a:t>Сквозной сценарий строится на обоснованном портрете аудитории или синтетическом потоке</a:t>
+              <a:t>Сознательное ограничение текущего этапа: сначала проверены более дешёвые и воспроизводимые числовые факторы</a:t>
             </a:r>
             <a:endParaRPr lang="en-US" sz="1050" dirty="0"/>
           </a:p>
@@ -3499,7 +3499,7 @@
                 <a:ea typeface="Arial" pitchFamily="34" charset="-122"/>
                 <a:cs typeface="Arial" pitchFamily="34" charset="-120"/>
               </a:rPr>
-              <a:t>Прогон по пяти коридорам кейса</a:t>
+              <a:t>Заморозить один пайплайн</a:t>
             </a:r>
             <a:endParaRPr lang="en-US" sz="1150" dirty="0"/>
           </a:p>
@@ -3577,7 +3577,7 @@
                 <a:ea typeface="Arial" pitchFamily="34" charset="-122"/>
                 <a:cs typeface="Arial" pitchFamily="34" charset="-120"/>
               </a:rPr>
-              <a:t>Обязательный результат — матрица «индикатор × коридор × метрики». Сейчас её не существует</a:t>
+              <a:t>Цель, признаки, модель, порог и критерии успеха фиксируются до следующего результата</a:t>
             </a:r>
             <a:endParaRPr lang="en-US" sz="1050" dirty="0"/>
           </a:p>
@@ -3677,7 +3677,7 @@
                 <a:ea typeface="Arial" pitchFamily="34" charset="-122"/>
                 <a:cs typeface="Arial" pitchFamily="34" charset="-120"/>
               </a:rPr>
-              <a:t>Полная матрица горизонтов 1/3/5/10/20</a:t>
+              <a:t>Новый честный hold-out</a:t>
             </a:r>
             <a:endParaRPr lang="en-US" sz="1150" dirty="0"/>
           </a:p>
@@ -3755,7 +3755,7 @@
                 <a:ea typeface="Arial" pitchFamily="34" charset="-122"/>
                 <a:cs typeface="Arial" pitchFamily="34" charset="-120"/>
               </a:rPr>
-              <a:t>Базовая частота падает с 0,51 до 0,16: на h = 20 для lift 1,3 нужен вчетверо меньший прирост в п.п.</a:t>
+              <a:t>Один запуск на новых датах или внешней выборке без повторного выбора победителя</a:t>
             </a:r>
             <a:endParaRPr lang="en-US" sz="1050" dirty="0"/>
           </a:p>
@@ -3855,7 +3855,7 @@
                 <a:ea typeface="Arial" pitchFamily="34" charset="-122"/>
                 <a:cs typeface="Arial" pitchFamily="34" charset="-120"/>
               </a:rPr>
-              <a:t>Цена ожидания в базисных пунктах</a:t>
+              <a:t>Курс приложения и экономика</a:t>
             </a:r>
             <a:endParaRPr lang="en-US" sz="1150" dirty="0"/>
           </a:p>
@@ -3894,7 +3894,7 @@
                 <a:ea typeface="Arial" pitchFamily="34" charset="-122"/>
                 <a:cs typeface="Arial" pitchFamily="34" charset="-120"/>
               </a:rPr>
-              <a:t>ML</a:t>
+              <a:t>ML + банк</a:t>
             </a:r>
             <a:endParaRPr lang="en-US" sz="1000" dirty="0"/>
           </a:p>
@@ -3933,7 +3933,7 @@
                 <a:ea typeface="Arial" pitchFamily="34" charset="-122"/>
                 <a:cs typeface="Arial" pitchFamily="34" charset="-120"/>
               </a:rPr>
-              <a:t>Пункт 6 постановки, «ключевой вопрос кейса». Единственный обязательный пункт, где у нас ноль</a:t>
+              <a:t>Bid/ask, спред, комиссия, сумма; выгода и regret на реально исполнимой цене</a:t>
             </a:r>
             <a:endParaRPr lang="en-US" sz="1050" dirty="0"/>
           </a:p>
@@ -4033,7 +4033,7 @@
                 <a:ea typeface="Arial" pitchFamily="34" charset="-122"/>
                 <a:cs typeface="Arial" pitchFamily="34" charset="-120"/>
               </a:rPr>
-              <a:t>Сезонность и праздники стран-получателей</a:t>
+              <a:t>Закрыть пробелы в данных</a:t>
             </a:r>
             <a:endParaRPr lang="en-US" sz="1150" dirty="0"/>
           </a:p>
@@ -4111,7 +4111,7 @@
                 <a:ea typeface="Arial" pitchFamily="34" charset="-122"/>
                 <a:cs typeface="Arial" pitchFamily="34" charset="-120"/>
               </a:rPr>
-              <a:t>Прямо в списке базовых индикаторов ТЗ; индикатор написан, календари не загружены</a:t>
+              <a:t>Order flow MOEX и независимые ноги AMD/KGS/TJS — если кейсодатель даст доступ</a:t>
             </a:r>
             <a:endParaRPr lang="en-US" sz="1050" dirty="0"/>
           </a:p>
@@ -4211,7 +4211,7 @@
                 <a:ea typeface="Arial" pitchFamily="34" charset="-122"/>
                 <a:cs typeface="Arial" pitchFamily="34" charset="-120"/>
               </a:rPr>
-              <a:t>H1′: бэктест заявок по целевому курсу</a:t>
+              <a:t>Горизонты h = 1 и 20</a:t>
             </a:r>
             <a:endParaRPr lang="en-US" sz="1150" dirty="0"/>
           </a:p>
@@ -4250,7 +4250,7 @@
                 <a:ea typeface="Arial" pitchFamily="34" charset="-122"/>
                 <a:cs typeface="Arial" pitchFamily="34" charset="-120"/>
               </a:rPr>
-              <a:t>ML + продакт</a:t>
+              <a:t>ML</a:t>
             </a:r>
             <a:endParaRPr lang="en-US" sz="1000" dirty="0"/>
           </a:p>
@@ -4289,7 +4289,7 @@
                 <a:ea typeface="Arial" pitchFamily="34" charset="-122"/>
                 <a:cs typeface="Arial" pitchFamily="34" charset="-120"/>
               </a:rPr>
-              <a:t>Сетка порогов и сроков; доля исполнения и выгода против «перевести сегодня»</a:t>
+              <a:t>Дополнить итоговую матрицу; h = 3/5/10 уже закрыты</a:t>
             </a:r>
             <a:endParaRPr lang="en-US" sz="1050" dirty="0"/>
           </a:p>
@@ -4389,7 +4389,7 @@
                 <a:ea typeface="Arial" pitchFamily="34" charset="-122"/>
                 <a:cs typeface="Arial" pitchFamily="34" charset="-120"/>
               </a:rPr>
-              <a:t>Библиотека текстов и запрещённых формулировок</a:t>
+              <a:t>Тексты и защита клиента</a:t>
             </a:r>
             <a:endParaRPr lang="en-US" sz="1150" dirty="0"/>
           </a:p>
@@ -4467,7 +4467,7 @@
                 <a:ea typeface="Arial" pitchFamily="34" charset="-122"/>
                 <a:cs typeface="Arial" pitchFamily="34" charset="-120"/>
               </a:rPr>
-              <a:t>Пункт 8 ТЗ: сценарий → формулировка, плюс механизм каждого запрета</a:t>
+              <a:t>Сценарий → объяснение сигнала; запрещённые обещания и контроль частоты</a:t>
             </a:r>
             <a:endParaRPr lang="en-US" sz="1050" dirty="0"/>
           </a:p>
@@ -4567,7 +4567,7 @@
                 <a:ea typeface="Arial" pitchFamily="34" charset="-122"/>
                 <a:cs typeface="Arial" pitchFamily="34" charset="-120"/>
               </a:rPr>
-              <a:t>План пилота и арифметика событий</a:t>
+              <a:t>Дизайн ограниченного A/B</a:t>
             </a:r>
             <a:endParaRPr lang="en-US" sz="1150" dirty="0"/>
           </a:p>
@@ -4645,7 +4645,7 @@
                 <a:ea typeface="Arial" pitchFamily="34" charset="-122"/>
                 <a:cs typeface="Arial" pitchFamily="34" charset="-120"/>
               </a:rPr>
-              <a:t>Что нужно от банка, какие метрики, за какой срок наберутся события при нашей частоте</a:t>
+              <a:t>Конверсия, выгода, отключение пушей, длительность и минимальный размер выборки</a:t>
             </a:r>
             <a:endParaRPr lang="en-US" sz="1050" dirty="0"/>
           </a:p>
@@ -4745,7 +4745,7 @@
                 <a:ea typeface="Arial" pitchFamily="34" charset="-122"/>
                 <a:cs typeface="Arial" pitchFamily="34" charset="-120"/>
               </a:rPr>
-              <a:t>Инструкция по запуску и раздел ограничений</a:t>
+              <a:t>Финальный пакет</a:t>
             </a:r>
             <a:endParaRPr lang="en-US" sz="1150" dirty="0"/>
           </a:p>
@@ -4823,7 +4823,7 @@
                 <a:ea typeface="Arial" pitchFamily="34" charset="-122"/>
                 <a:cs typeface="Arial" pitchFamily="34" charset="-120"/>
               </a:rPr>
-              <a:t>Критерий организаторов: посторонний человек повторяет результат одной командой</a:t>
+              <a:t>Демо, инструкция запуска, ограничения, презентация и воспроизводимые таблицы</a:t>
             </a:r>
             <a:endParaRPr lang="en-US" sz="1050" dirty="0"/>
           </a:p>
@@ -5575,7 +5575,7 @@
                 <a:ea typeface="Arial" pitchFamily="34" charset="-122"/>
                 <a:cs typeface="Arial" pitchFamily="34" charset="-120"/>
               </a:rPr>
-              <a:t>Каркас репозитория, слой загрузки данных, воспроизводимый запуск, дизайн конвейера ML</a:t>
+              <a:t>Каркас репозитория, загрузка и кэширование данных, воспроизводимый ML-конвейер и расширенный эксперимент</a:t>
             </a:r>
             <a:endParaRPr lang="en-US" sz="1050" dirty="0"/>
           </a:p>
@@ -5660,7 +5660,7 @@
                 <a:ea typeface="Arial" pitchFamily="34" charset="-122"/>
                 <a:cs typeface="Arial" pitchFamily="34" charset="-120"/>
               </a:rPr>
-              <a:t>Сигнальный конвейер целиком: панель, индикаторы, разметка, бэктест, перебор</a:t>
+              <a:t>Панель пяти коридоров и автоматическая разметка</a:t>
             </a:r>
             <a:endParaRPr lang="en-US" sz="1000" dirty="0"/>
           </a:p>
@@ -5684,7 +5684,7 @@
                 <a:ea typeface="Arial" pitchFamily="34" charset="-122"/>
                 <a:cs typeface="Arial" pitchFamily="34" charset="-120"/>
               </a:rPr>
-              <a:t>signals_as_of(T) и тест на утечку</a:t>
+              <a:t>39 крупных проверок, 25 таблиц и 13 379 вариантов</a:t>
             </a:r>
             <a:endParaRPr lang="en-US" sz="1000" dirty="0"/>
           </a:p>
@@ -5708,7 +5708,7 @@
                 <a:ea typeface="Arial" pitchFamily="34" charset="-122"/>
                 <a:cs typeface="Arial" pitchFamily="34" charset="-120"/>
               </a:rPr>
-              <a:t>Реестр 15 гипотез, аудит качества данных</a:t>
+              <a:t>Итоговые модели для h = 3/5/10</a:t>
             </a:r>
             <a:endParaRPr lang="en-US" sz="1000" dirty="0"/>
           </a:p>
@@ -5732,7 +5732,7 @@
                 <a:ea typeface="Arial" pitchFamily="34" charset="-122"/>
                 <a:cs typeface="Arial" pitchFamily="34" charset="-120"/>
               </a:rPr>
-              <a:t>13 файлов тестов, 12 конфигов</a:t>
+              <a:t>signals_as_of(T), защита от утечки и 101 тест</a:t>
             </a:r>
             <a:endParaRPr lang="en-US" sz="1000" dirty="0"/>
           </a:p>
@@ -5796,7 +5796,7 @@
                 <a:ea typeface="Arial" pitchFamily="34" charset="-122"/>
                 <a:cs typeface="Arial" pitchFamily="34" charset="-120"/>
               </a:rPr>
-              <a:t>Полная занятость. Сейчас: прогон по коридорам, матрица горизонтов</a:t>
+              <a:t>Полная занятость. Сейчас: заморозка кандидата, hold-out и финальный отчёт</a:t>
             </a:r>
             <a:endParaRPr lang="en-US" sz="1000" dirty="0"/>
           </a:p>
@@ -6188,7 +6188,7 @@
                 <a:ea typeface="Arial" pitchFamily="34" charset="-122"/>
                 <a:cs typeface="Arial" pitchFamily="34" charset="-120"/>
               </a:rPr>
-              <a:t>Полная занятость. Сейчас: перенос целей на другой коридор и интрадей</a:t>
+              <a:t>Полная занятость. Сейчас: проверка устойчивости и финальный выбор кандидата</a:t>
             </a:r>
             <a:endParaRPr lang="en-US" sz="1000" dirty="0"/>
           </a:p>
@@ -9126,7 +9126,7 @@
                 <a:ea typeface="Arial" pitchFamily="34" charset="-122"/>
                 <a:cs typeface="Arial" pitchFamily="34" charset="-120"/>
               </a:rPr>
-              <a:t>H2  Лид-лаг мажоров</a:t>
+              <a:t>Regret / triple barrier</a:t>
             </a:r>
             <a:endParaRPr lang="en-US" sz="1150" dirty="0"/>
           </a:p>
@@ -9165,7 +9165,7 @@
                 <a:ea typeface="Arial" pitchFamily="34" charset="-122"/>
                 <a:cs typeface="Arial" pitchFamily="34" charset="-120"/>
               </a:rPr>
-              <a:t>опровергнута</a:t>
+              <a:t>рабочая цель</a:t>
             </a:r>
             <a:endParaRPr lang="en-US" sz="1000" dirty="0"/>
           </a:p>
@@ -9204,7 +9204,7 @@
                 <a:ea typeface="Arial" pitchFamily="34" charset="-122"/>
                 <a:cs typeface="Arial" pitchFamily="34" charset="-120"/>
               </a:rPr>
-              <a:t>H3  Базовые индикаторы ТЗ</a:t>
+              <a:t>Длинная история</a:t>
             </a:r>
             <a:endParaRPr lang="en-US" sz="1150" dirty="0"/>
           </a:p>
@@ -9243,7 +9243,7 @@
                 <a:ea typeface="Arial" pitchFamily="34" charset="-122"/>
                 <a:cs typeface="Arial" pitchFamily="34" charset="-120"/>
               </a:rPr>
-              <a:t>отрицательный</a:t>
+              <a:t>помогла h = 5</a:t>
             </a:r>
             <a:endParaRPr lang="en-US" sz="1000" dirty="0"/>
           </a:p>
@@ -9282,7 +9282,7 @@
                 <a:ea typeface="Arial" pitchFamily="34" charset="-122"/>
                 <a:cs typeface="Arial" pitchFamily="34" charset="-120"/>
               </a:rPr>
-              <a:t>H4  Перенос из смежных сфер</a:t>
+              <a:t>Selective prediction</a:t>
             </a:r>
             <a:endParaRPr lang="en-US" sz="1150" dirty="0"/>
           </a:p>
@@ -9321,7 +9321,7 @@
                 <a:ea typeface="Arial" pitchFamily="34" charset="-122"/>
                 <a:cs typeface="Arial" pitchFamily="34" charset="-120"/>
               </a:rPr>
-              <a:t>отрицательный</a:t>
+              <a:t>нужная частота</a:t>
             </a:r>
             <a:endParaRPr lang="en-US" sz="1000" dirty="0"/>
           </a:p>
@@ -9360,7 +9360,7 @@
                 <a:ea typeface="Arial" pitchFamily="34" charset="-122"/>
                 <a:cs typeface="Arial" pitchFamily="34" charset="-120"/>
               </a:rPr>
-              <a:t>H5  Эвристики из HFT</a:t>
+              <a:t>Режимы / GARCH</a:t>
             </a:r>
             <a:endParaRPr lang="en-US" sz="1150" dirty="0"/>
           </a:p>
@@ -9399,7 +9399,7 @@
                 <a:ea typeface="Arial" pitchFamily="34" charset="-122"/>
                 <a:cs typeface="Arial" pitchFamily="34" charset="-120"/>
               </a:rPr>
-              <a:t>частично</a:t>
+              <a:t>сигнал слишком редок</a:t>
             </a:r>
             <a:endParaRPr lang="en-US" sz="1000" dirty="0"/>
           </a:p>
@@ -9438,7 +9438,7 @@
                 <a:ea typeface="Arial" pitchFamily="34" charset="-122"/>
                 <a:cs typeface="Arial" pitchFamily="34" charset="-120"/>
               </a:rPr>
-              <a:t>H6  Трендовые сценарии</a:t>
+              <a:t>Внешние факторы</a:t>
             </a:r>
             <a:endParaRPr lang="en-US" sz="1150" dirty="0"/>
           </a:p>
@@ -9477,7 +9477,7 @@
                 <a:ea typeface="Arial" pitchFamily="34" charset="-122"/>
                 <a:cs typeface="Arial" pitchFamily="34" charset="-120"/>
               </a:rPr>
-              <a:t>направление верно</a:t>
+              <a:t>Brent полезен локально</a:t>
             </a:r>
             <a:endParaRPr lang="en-US" sz="1000" dirty="0"/>
           </a:p>
@@ -9516,7 +9516,7 @@
                 <a:ea typeface="Arial" pitchFamily="34" charset="-122"/>
                 <a:cs typeface="Arial" pitchFamily="34" charset="-120"/>
               </a:rPr>
-              <a:t>H7  Волатильность</a:t>
+              <a:t>Pooled-коридоры</a:t>
             </a:r>
             <a:endParaRPr lang="en-US" sz="1150" dirty="0"/>
           </a:p>
@@ -9555,7 +9555,7 @@
                 <a:ea typeface="Arial" pitchFamily="34" charset="-122"/>
                 <a:cs typeface="Arial" pitchFamily="34" charset="-120"/>
               </a:rPr>
-              <a:t>частично</a:t>
+              <a:t>общей прибавки нет</a:t>
             </a:r>
             <a:endParaRPr lang="en-US" sz="1000" dirty="0"/>
           </a:p>
@@ -9594,7 +9594,7 @@
                 <a:ea typeface="Arial" pitchFamily="34" charset="-122"/>
                 <a:cs typeface="Arial" pitchFamily="34" charset="-120"/>
               </a:rPr>
-              <a:t>H8  Rule-based против ML</a:t>
+              <a:t>Правила / meta-labeling</a:t>
             </a:r>
             <a:endParaRPr lang="en-US" sz="1150" dirty="0"/>
           </a:p>
@@ -9633,7 +9633,7 @@
                 <a:ea typeface="Arial" pitchFamily="34" charset="-122"/>
                 <a:cs typeface="Arial" pitchFamily="34" charset="-120"/>
               </a:rPr>
-              <a:t>проверены оба</a:t>
+              <a:t>уступили бустингу</a:t>
             </a:r>
             <a:endParaRPr lang="en-US" sz="1000" dirty="0"/>
           </a:p>
@@ -9672,7 +9672,7 @@
                 <a:ea typeface="Arial" pitchFamily="34" charset="-122"/>
                 <a:cs typeface="Arial" pitchFamily="34" charset="-120"/>
               </a:rPr>
-              <a:t>H10  Сырьевые рынки</a:t>
+              <a:t>Аномалии / календарь</a:t>
             </a:r>
             <a:endParaRPr lang="en-US" sz="1150" dirty="0"/>
           </a:p>
@@ -9711,7 +9711,7 @@
                 <a:ea typeface="Arial" pitchFamily="34" charset="-122"/>
                 <a:cs typeface="Arial" pitchFamily="34" charset="-120"/>
               </a:rPr>
-              <a:t>вердикта нет</a:t>
+              <a:t>общей прибавки нет</a:t>
             </a:r>
             <a:endParaRPr lang="en-US" sz="1000" dirty="0"/>
           </a:p>
@@ -10894,7 +10894,7 @@
                 <a:ea typeface="Arial" pitchFamily="34" charset="-122"/>
                 <a:cs typeface="Arial" pitchFamily="34" charset="-120"/>
               </a:rPr>
-              <a:t>21 модуль</a:t>
+              <a:t>50 модулей</a:t>
             </a:r>
             <a:endParaRPr lang="en-US" sz="1900" dirty="0"/>
           </a:p>
@@ -10933,7 +10933,7 @@
                 <a:ea typeface="Arial" pitchFamily="34" charset="-122"/>
                 <a:cs typeface="Arial" pitchFamily="34" charset="-120"/>
               </a:rPr>
-              <a:t>13 файлов тестов</a:t>
+              <a:t>101 тест</a:t>
             </a:r>
             <a:endParaRPr lang="en-US" sz="1900" dirty="0"/>
           </a:p>
@@ -10972,7 +10972,7 @@
                 <a:ea typeface="Arial" pitchFamily="34" charset="-122"/>
                 <a:cs typeface="Arial" pitchFamily="34" charset="-120"/>
               </a:rPr>
-              <a:t>12 конфигов</a:t>
+              <a:t>39 проверок</a:t>
             </a:r>
             <a:endParaRPr lang="en-US" sz="1900" dirty="0"/>
           </a:p>
@@ -11053,7 +11053,7 @@
                 <a:ea typeface="Arial" pitchFamily="34" charset="-122"/>
                 <a:cs typeface="Arial" pitchFamily="34" charset="-120"/>
               </a:rPr>
-              <a:t>в src/fxpulse — от загрузки до сигналов</a:t>
+              <a:t>Python: от загрузки до сигналов</a:t>
             </a:r>
             <a:endParaRPr lang="en-US" sz="1000" dirty="0"/>
           </a:p>
@@ -11095,7 +11095,7 @@
                 <a:ea typeface="Arial" pitchFamily="34" charset="-122"/>
                 <a:cs typeface="Arial" pitchFamily="34" charset="-120"/>
               </a:rPr>
-              <a:t>загрузчики, панель, индикаторы, бэктест</a:t>
+              <a:t>проверяют данные, метки и отсутствие утечки</a:t>
             </a:r>
             <a:endParaRPr lang="en-US" sz="1000" dirty="0"/>
           </a:p>
@@ -11137,7 +11137,7 @@
                 <a:ea typeface="Arial" pitchFamily="34" charset="-122"/>
                 <a:cs typeface="Arial" pitchFamily="34" charset="-120"/>
               </a:rPr>
-              <a:t>сетка зарегистрирована заранее</a:t>
+              <a:t>25 таблиц, 13 379 вариантов</a:t>
             </a:r>
             <a:endParaRPr lang="en-US" sz="1000" dirty="0"/>
           </a:p>
@@ -11179,7 +11179,7 @@
                 <a:ea typeface="Arial" pitchFamily="34" charset="-122"/>
                 <a:cs typeface="Arial" pitchFamily="34" charset="-120"/>
               </a:rPr>
-              <a:t>хеш конфига пишется до чтения результата</a:t>
+              <a:t>хеш конфига хранится с результатом</a:t>
             </a:r>
             <a:endParaRPr lang="en-US" sz="1000" dirty="0"/>
           </a:p>
@@ -11247,7 +11247,7 @@
                 <a:ea typeface="Arial" pitchFamily="34" charset="-122"/>
                 <a:cs typeface="Arial" pitchFamily="34" charset="-120"/>
               </a:rPr>
-              <a:t>Ряд данных: живой рынок, а не фиксинг ЦБ</a:t>
+              <a:t>Панель данных: пять коридоров + рыночный контекст</a:t>
             </a:r>
             <a:endParaRPr lang="en-US" sz="1300" dirty="0"/>
           </a:p>
@@ -11289,7 +11289,7 @@
                 <a:ea typeface="Arial" pitchFamily="34" charset="-122"/>
                 <a:cs typeface="Arial" pitchFamily="34" charset="-120"/>
               </a:rPr>
-              <a:t>Якорь — CNY/RUB TOM по ценам закрытия плюс 10 внешних факторов MOEX со сдвигом на сессию. Причина — на следующем слайде.</a:t>
+              <a:t>Курсы ЦБ с 2010 года, дневные и часовые свечи MOEX, рублёвый якорь, Brent, металлы, ставка, праздники и доступные ноги валют.</a:t>
             </a:r>
             <a:endParaRPr lang="en-US" sz="1100" dirty="0"/>
           </a:p>
@@ -12180,7 +12180,7 @@
                 <a:ea typeface="Arial" pitchFamily="34" charset="-122"/>
                 <a:cs typeface="Arial" pitchFamily="34" charset="-120"/>
               </a:rPr>
-              <a:t> и что осталось</a:t>
+              <a:t> и следующий честный шаг</a:t>
             </a:r>
             <a:endParaRPr lang="en-US" sz="3000" dirty="0"/>
           </a:p>
@@ -12316,7 +12316,7 @@
                 <a:ea typeface="Arial" pitchFamily="34" charset="-122"/>
                 <a:cs typeface="Arial" pitchFamily="34" charset="-120"/>
               </a:rPr>
-              <a:t>Датасет собран и прошёл аудит качества: ЦБ РФ 2136 дат по 8 валютам, снимок MOEX за 5 лет, 10-минутные свечи</a:t>
+              <a:t>Собрана панель пяти коридоров за 2010–2026 годы: 20 581 строка</a:t>
             </a:r>
             <a:endParaRPr lang="en-US" sz="1150" dirty="0"/>
           </a:p>
@@ -12340,7 +12340,7 @@
                 <a:ea typeface="Arial" pitchFamily="34" charset="-122"/>
                 <a:cs typeface="Arial" pitchFamily="34" charset="-120"/>
               </a:rPr>
-              <a:t>Сигнальный конвейер целиком: панель, индикаторы, разметка, бэктест, перебор сетки</a:t>
+              <a:t>Сохранены дневные и часовые свечи MOEX, Brent, ставка, праздники и доступные ноги валют</a:t>
             </a:r>
             <a:endParaRPr lang="en-US" sz="1150" dirty="0"/>
           </a:p>
@@ -12364,7 +12364,7 @@
                 <a:ea typeface="Arial" pitchFamily="34" charset="-122"/>
                 <a:cs typeface="Arial" pitchFamily="34" charset="-120"/>
               </a:rPr>
-              <a:t>signals_as_of(T) с проверкой границы информационного множества — дисквалифицирующее требование закрыто</a:t>
+              <a:t>Сигнальный конвейер целиком: признаки, автоматическая разметка, walk-forward, модели, порог и cooldown</a:t>
             </a:r>
             <a:endParaRPr lang="en-US" sz="1150" dirty="0"/>
           </a:p>
@@ -12388,7 +12388,7 @@
                 <a:ea typeface="Arial" pitchFamily="34" charset="-122"/>
                 <a:cs typeface="Arial" pitchFamily="34" charset="-120"/>
               </a:rPr>
-              <a:t>Walk-forward с purging; кучность, частота, выгода и lift считаются штатно</a:t>
+              <a:t>signals_as_of(T) и purging защищают от чтения будущего</a:t>
             </a:r>
             <a:endParaRPr lang="en-US" sz="1150" dirty="0"/>
           </a:p>
@@ -12412,7 +12412,7 @@
                 <a:ea typeface="Arial" pitchFamily="34" charset="-122"/>
                 <a:cs typeface="Arial" pitchFamily="34" charset="-120"/>
               </a:rPr>
-              <a:t>Проверено 15 сигнальных правил и 6 семейств моделей</a:t>
+              <a:t>Закрыто 39 крупных проверок: 25 таблиц и 13 379 сравнимых вариантов</a:t>
             </a:r>
             <a:endParaRPr lang="en-US" sz="1150" dirty="0"/>
           </a:p>
@@ -12436,7 +12436,7 @@
                 <a:ea typeface="Arial" pitchFamily="34" charset="-122"/>
                 <a:cs typeface="Arial" pitchFamily="34" charset="-120"/>
               </a:rPr>
-              <a:t>Regret-метрика вместо строгого минимума: метка перестала считать ошибку в 1 бп и в 100 бп одинаковой</a:t>
+              <a:t>Проверены горизонты 3/5/10 дней, пять коридоров, правила, бустинги, режимы, GARCH и abstention</a:t>
             </a:r>
             <a:endParaRPr lang="en-US" sz="1150" dirty="0"/>
           </a:p>
@@ -12460,7 +12460,7 @@
                 <a:ea typeface="Arial" pitchFamily="34" charset="-122"/>
                 <a:cs typeface="Arial" pitchFamily="34" charset="-120"/>
               </a:rPr>
-              <a:t>Калибровка проверена: raw score лучше sigmoid и isotonic в 20 задачах из 20</a:t>
+              <a:t>Для каждого сигнала сохраняются дата, скор, признаки и причина</a:t>
             </a:r>
             <a:endParaRPr lang="en-US" sz="1150" dirty="0"/>
           </a:p>
@@ -12484,10 +12484,122 @@
                 <a:ea typeface="Arial" pitchFamily="34" charset="-122"/>
                 <a:cs typeface="Arial" pitchFamily="34" charset="-120"/>
               </a:rPr>
-              <a:t>Matched-random baseline — строже, чем требует постановка</a:t>
+              <a:t>Весь код проходит 101 автоматический тест</a:t>
             </a:r>
             <a:endParaRPr lang="en-US" sz="1150" dirty="0"/>
           </a:p>
+        </p:txBody>
+      </p:sp>
+      <p:sp>
+        <p:nvSpPr>
+          <p:cNvPr id="10" name="Shape 8"/>
+          <p:cNvSpPr/>
+          <p:nvPr/>
+        </p:nvSpPr>
+        <p:spPr>
+          <a:xfrm>
+            <a:off x="6199632" y="1234440"/>
+            <a:ext cx="5532120" cy="5166360"/>
+          </a:xfrm>
+          <a:prstGeom prst="roundRect">
+            <a:avLst>
+              <a:gd name="adj" fmla="val 2478"/>
+            </a:avLst>
+          </a:prstGeom>
+          <a:solidFill>
+            <a:srgbClr val="FDEAE8"/>
+          </a:solidFill>
+          <a:ln/>
+          <a:effectLst>
+            <a:outerShdw sx="100000" sy="100000" kx="0" ky="0" algn="bl" rotWithShape="0" blurRad="101600" dist="12700" dir="5400000">
+              <a:srgbClr val="9A9A9A">
+                <a:alpha val="18000"/>
+              </a:srgbClr>
+            </a:outerShdw>
+          </a:effectLst>
+        </p:spPr>
+      </p:sp>
+      <p:sp>
+        <p:nvSpPr>
+          <p:cNvPr id="11" name="Shape 9"/>
+          <p:cNvSpPr/>
+          <p:nvPr/>
+        </p:nvSpPr>
+        <p:spPr>
+          <a:xfrm>
+            <a:off x="6428232" y="1444752"/>
+            <a:ext cx="3154680" cy="310896"/>
+          </a:xfrm>
+          <a:prstGeom prst="roundRect">
+            <a:avLst>
+              <a:gd name="adj" fmla="val 50000"/>
+            </a:avLst>
+          </a:prstGeom>
+          <a:solidFill>
+            <a:srgbClr val="EF3124"/>
+          </a:solidFill>
+          <a:ln/>
+        </p:spPr>
+      </p:sp>
+      <p:sp>
+        <p:nvSpPr>
+          <p:cNvPr id="12" name="Text 10"/>
+          <p:cNvSpPr txBox="1"/>
+          <p:nvPr/>
+        </p:nvSpPr>
+        <p:spPr>
+          <a:xfrm>
+            <a:off x="6428232" y="1444752"/>
+            <a:ext cx="3154680" cy="310896"/>
+          </a:xfrm>
+          <a:prstGeom prst="rect">
+            <a:avLst/>
+          </a:prstGeom>
+          <a:noFill/>
+          <a:ln/>
+        </p:spPr>
+        <p:txBody>
+          <a:bodyPr wrap="square" lIns="0" tIns="0" rIns="0" bIns="0" rtlCol="0" anchor="ctr"/>
+          <a:lstStyle/>
+          <a:p>
+            <a:pPr algn="ctr" indent="0" marL="0">
+              <a:buNone/>
+            </a:pPr>
+            <a:r>
+              <a:rPr lang="en-US" sz="1150" b="1" dirty="0">
+                <a:solidFill>
+                  <a:srgbClr val="FFFFFF"/>
+                </a:solidFill>
+                <a:latin typeface="Arial" pitchFamily="34" charset="0"/>
+                <a:ea typeface="Arial" pitchFamily="34" charset="-122"/>
+                <a:cs typeface="Arial" pitchFamily="34" charset="-120"/>
+              </a:rPr>
+              <a:t>ДО ГОТОВОГО ПИЛОТА</a:t>
+            </a:r>
+            <a:endParaRPr lang="en-US" sz="1150" dirty="0"/>
+          </a:p>
+        </p:txBody>
+      </p:sp>
+      <p:sp>
+        <p:nvSpPr>
+          <p:cNvPr id="13" name="Text 11"/>
+          <p:cNvSpPr txBox="1"/>
+          <p:nvPr/>
+        </p:nvSpPr>
+        <p:spPr>
+          <a:xfrm>
+            <a:off x="6428232" y="1901952"/>
+            <a:ext cx="5074920" cy="4297680"/>
+          </a:xfrm>
+          <a:prstGeom prst="rect">
+            <a:avLst/>
+          </a:prstGeom>
+          <a:noFill/>
+          <a:ln/>
+        </p:spPr>
+        <p:txBody>
+          <a:bodyPr wrap="square" lIns="0" tIns="0" rIns="0" bIns="0" rtlCol="0" anchor="t"/>
+          <a:lstStyle/>
           <a:p>
             <a:pPr marL="342900" indent="-342900">
               <a:lnSpc>
@@ -12508,122 +12620,10 @@
                 <a:ea typeface="Arial" pitchFamily="34" charset="-122"/>
                 <a:cs typeface="Arial" pitchFamily="34" charset="-120"/>
               </a:rPr>
-              <a:t>Обзор смежных отраслей и два раунда вопросов кейсодателю</a:t>
+              <a:t>Заморозить один пайплайн и заранее записать критерии успеха</a:t>
             </a:r>
             <a:endParaRPr lang="en-US" sz="1150" dirty="0"/>
           </a:p>
-        </p:txBody>
-      </p:sp>
-      <p:sp>
-        <p:nvSpPr>
-          <p:cNvPr id="10" name="Shape 8"/>
-          <p:cNvSpPr/>
-          <p:nvPr/>
-        </p:nvSpPr>
-        <p:spPr>
-          <a:xfrm>
-            <a:off x="6199632" y="1234440"/>
-            <a:ext cx="5532120" cy="5166360"/>
-          </a:xfrm>
-          <a:prstGeom prst="roundRect">
-            <a:avLst>
-              <a:gd name="adj" fmla="val 2478"/>
-            </a:avLst>
-          </a:prstGeom>
-          <a:solidFill>
-            <a:srgbClr val="FDEAE8"/>
-          </a:solidFill>
-          <a:ln/>
-          <a:effectLst>
-            <a:outerShdw sx="100000" sy="100000" kx="0" ky="0" algn="bl" rotWithShape="0" blurRad="101600" dist="12700" dir="5400000">
-              <a:srgbClr val="9A9A9A">
-                <a:alpha val="18000"/>
-              </a:srgbClr>
-            </a:outerShdw>
-          </a:effectLst>
-        </p:spPr>
-      </p:sp>
-      <p:sp>
-        <p:nvSpPr>
-          <p:cNvPr id="11" name="Shape 9"/>
-          <p:cNvSpPr/>
-          <p:nvPr/>
-        </p:nvSpPr>
-        <p:spPr>
-          <a:xfrm>
-            <a:off x="6428232" y="1444752"/>
-            <a:ext cx="2651760" cy="310896"/>
-          </a:xfrm>
-          <a:prstGeom prst="roundRect">
-            <a:avLst>
-              <a:gd name="adj" fmla="val 50000"/>
-            </a:avLst>
-          </a:prstGeom>
-          <a:solidFill>
-            <a:srgbClr val="EF3124"/>
-          </a:solidFill>
-          <a:ln/>
-        </p:spPr>
-      </p:sp>
-      <p:sp>
-        <p:nvSpPr>
-          <p:cNvPr id="12" name="Text 10"/>
-          <p:cNvSpPr txBox="1"/>
-          <p:nvPr/>
-        </p:nvSpPr>
-        <p:spPr>
-          <a:xfrm>
-            <a:off x="6428232" y="1444752"/>
-            <a:ext cx="2651760" cy="310896"/>
-          </a:xfrm>
-          <a:prstGeom prst="rect">
-            <a:avLst/>
-          </a:prstGeom>
-          <a:noFill/>
-          <a:ln/>
-        </p:spPr>
-        <p:txBody>
-          <a:bodyPr wrap="square" lIns="0" tIns="0" rIns="0" bIns="0" rtlCol="0" anchor="ctr"/>
-          <a:lstStyle/>
-          <a:p>
-            <a:pPr algn="ctr" indent="0" marL="0">
-              <a:buNone/>
-            </a:pPr>
-            <a:r>
-              <a:rPr lang="en-US" sz="1150" b="1" dirty="0">
-                <a:solidFill>
-                  <a:srgbClr val="FFFFFF"/>
-                </a:solidFill>
-                <a:latin typeface="Arial" pitchFamily="34" charset="0"/>
-                <a:ea typeface="Arial" pitchFamily="34" charset="-122"/>
-                <a:cs typeface="Arial" pitchFamily="34" charset="-120"/>
-              </a:rPr>
-              <a:t>ОСТАЛОСЬ ОБЯЗАТЕЛЬНОГО</a:t>
-            </a:r>
-            <a:endParaRPr lang="en-US" sz="1150" dirty="0"/>
-          </a:p>
-        </p:txBody>
-      </p:sp>
-      <p:sp>
-        <p:nvSpPr>
-          <p:cNvPr id="13" name="Text 11"/>
-          <p:cNvSpPr txBox="1"/>
-          <p:nvPr/>
-        </p:nvSpPr>
-        <p:spPr>
-          <a:xfrm>
-            <a:off x="6428232" y="1901952"/>
-            <a:ext cx="5074920" cy="4297680"/>
-          </a:xfrm>
-          <a:prstGeom prst="rect">
-            <a:avLst/>
-          </a:prstGeom>
-          <a:noFill/>
-          <a:ln/>
-        </p:spPr>
-        <p:txBody>
-          <a:bodyPr wrap="square" lIns="0" tIns="0" rIns="0" bIns="0" rtlCol="0" anchor="t"/>
-          <a:lstStyle/>
           <a:p>
             <a:pPr marL="342900" indent="-342900">
               <a:lnSpc>
@@ -12644,7 +12644,7 @@
                 <a:ea typeface="Arial" pitchFamily="34" charset="-122"/>
                 <a:cs typeface="Arial" pitchFamily="34" charset="-120"/>
               </a:rPr>
-              <a:t>Прогон по пяти коридорам кейса. Все числа получены на CNY/RUB; TJS, UZS, KGS, AMD и KZT загружены и проверены, но не прогнаны — матрицы «индикатор × коридор» пока нет</a:t>
+              <a:t>Проверить его один раз на новых датах или внешнем hold-out без выбора победителя постфактум</a:t>
             </a:r>
             <a:endParaRPr lang="en-US" sz="1150" dirty="0"/>
           </a:p>
@@ -12668,7 +12668,7 @@
                 <a:ea typeface="Arial" pitchFamily="34" charset="-122"/>
                 <a:cs typeface="Arial" pitchFamily="34" charset="-120"/>
               </a:rPr>
-              <a:t>Полная матрица горизонтов 1/3/5/10/20 — сейчас главный срез только h = 5</a:t>
+              <a:t>Пересчитать экономику на реальном bid/ask приложения с учётом спреда, комиссии и суммы</a:t>
             </a:r>
             <a:endParaRPr lang="en-US" sz="1150" dirty="0"/>
           </a:p>
@@ -12692,7 +12692,7 @@
                 <a:ea typeface="Arial" pitchFamily="34" charset="-122"/>
                 <a:cs typeface="Arial" pitchFamily="34" charset="-120"/>
               </a:rPr>
-              <a:t>Цена ожидания в базисных пунктах — п. 6 постановки, названный «ключевым вопросом кейса». Поле speed в схеме есть, измерения нет</a:t>
+              <a:t>Получить клиентские логи и проверить не только качество курса, но и реакцию на пуш</a:t>
             </a:r>
             <a:endParaRPr lang="en-US" sz="1150" dirty="0"/>
           </a:p>
@@ -12716,7 +12716,7 @@
                 <a:ea typeface="Arial" pitchFamily="34" charset="-122"/>
                 <a:cs typeface="Arial" pitchFamily="34" charset="-120"/>
               </a:rPr>
-              <a:t>Сезонность с праздниками стран-получателей: индикатор написан, календари не загружены</a:t>
+              <a:t>При доступе добавить order flow MOEX и независимые ноги AMD/KGS/TJS</a:t>
             </a:r>
             <a:endParaRPr lang="en-US" sz="1150" dirty="0"/>
           </a:p>
@@ -12740,7 +12740,7 @@
                 <a:ea typeface="Arial" pitchFamily="34" charset="-122"/>
                 <a:cs typeface="Arial" pitchFamily="34" charset="-120"/>
               </a:rPr>
-              <a:t>Библиотека текстов пушей и список запрещённых формулировок</a:t>
+              <a:t>Подготовить тексты пушей, запрещённые формулировки и дизайн A/B-пилота</a:t>
             </a:r>
             <a:endParaRPr lang="en-US" sz="1150" dirty="0"/>
           </a:p>
@@ -12764,7 +12764,7 @@
                 <a:ea typeface="Arial" pitchFamily="34" charset="-122"/>
                 <a:cs typeface="Arial" pitchFamily="34" charset="-120"/>
               </a:rPr>
-              <a:t>План пилота, инструкция по запуску, раздел ограничений и компромиссов</a:t>
+              <a:t>Закрыть h = 1/20 и собрать финальный воспроизводимый пакет</a:t>
             </a:r>
             <a:endParaRPr lang="en-US" sz="1150" dirty="0"/>
           </a:p>
@@ -12953,7 +12953,7 @@
                 <a:ea typeface="Arial" pitchFamily="34" charset="-122"/>
                 <a:cs typeface="Arial" pitchFamily="34" charset="-120"/>
               </a:rPr>
-              <a:t> ни одна конфигурация не проходит все ворота</a:t>
+              <a:t> на h = 3/5/10 есть кандидаты с lift ≥ 1,3</a:t>
             </a:r>
             <a:endParaRPr lang="en-US" sz="3000" dirty="0"/>
           </a:p>
@@ -12968,7 +12968,7 @@
         <p:spPr>
           <a:xfrm>
             <a:off x="457200" y="1207008"/>
-            <a:ext cx="3108960" cy="310896"/>
+            <a:ext cx="3246120" cy="310896"/>
           </a:xfrm>
           <a:prstGeom prst="roundRect">
             <a:avLst>
@@ -12990,7 +12990,7 @@
         <p:spPr>
           <a:xfrm>
             <a:off x="457200" y="1207008"/>
-            <a:ext cx="3108960" cy="310896"/>
+            <a:ext cx="3246120" cy="310896"/>
           </a:xfrm>
           <a:prstGeom prst="rect">
             <a:avLst/>
@@ -13014,7 +13014,7 @@
                 <a:ea typeface="Arial" pitchFamily="34" charset="-122"/>
                 <a:cs typeface="Arial" pitchFamily="34" charset="-120"/>
               </a:rPr>
-              <a:t>ПРАВИЛА И СЦЕНАРИИ</a:t>
+              <a:t>ЛУЧШИЕ ПО ГОРИЗОНТАМ</a:t>
             </a:r>
             <a:endParaRPr lang="en-US" sz="1150" dirty="0"/>
           </a:p>
@@ -13036,18 +13036,20 @@
         </p:nvGraphicFramePr>
         <p:xfrm>
           <a:off x="457200" y="1609344"/>
-          <a:ext cx="5532120" cy="914400"/>
+          <a:ext cx="11274552" cy="914400"/>
         </p:xfrm>
         <a:graphic>
           <a:graphicData uri="http://schemas.openxmlformats.org/drawingml/2006/table">
             <a:tbl>
               <a:tblPr/>
               <a:tblGrid>
-                <a:gridCol w="1600200"/>
-                <a:gridCol w="868680"/>
-                <a:gridCol w="868680"/>
-                <a:gridCol w="1097280"/>
-                <a:gridCol w="1097280"/>
+                <a:gridCol w="914400"/>
+                <a:gridCol w="3840480"/>
+                <a:gridCol w="1005840"/>
+                <a:gridCol w="914400"/>
+                <a:gridCol w="1143000"/>
+                <a:gridCol w="1143000"/>
+                <a:gridCol w="1143000"/>
               </a:tblGrid>
               <a:tr h="274320">
                 <a:tc>
@@ -13059,7 +13061,7 @@
                         <a:buNone/>
                       </a:pPr>
                       <a:r>
-                        <a:rPr lang="en-US" sz="1000" b="1" dirty="0">
+                        <a:rPr lang="en-US" sz="1050" b="1" dirty="0">
                           <a:solidFill>
                             <a:srgbClr val="FFFFFF"/>
                           </a:solidFill>
@@ -13067,9 +13069,9 @@
                           <a:ea typeface="Arial" pitchFamily="34" charset="-122"/>
                           <a:cs typeface="Arial" pitchFamily="34" charset="-120"/>
                         </a:rPr>
-                        <a:t>Правило</a:t>
+                        <a:t>Горизонт</a:t>
                       </a:r>
-                      <a:endParaRPr lang="en-US" sz="1000" dirty="0">
+                      <a:endParaRPr lang="en-US" sz="1050" dirty="0">
                         <a:latin typeface="Arial" charset="0"/>
                         <a:ea typeface="Arial" charset="0"/>
                         <a:cs typeface="Arial" charset="0"/>
@@ -13127,7 +13129,7 @@
                         <a:buNone/>
                       </a:pPr>
                       <a:r>
-                        <a:rPr lang="en-US" sz="1000" b="1" dirty="0">
+                        <a:rPr lang="en-US" sz="1050" b="1" dirty="0">
                           <a:solidFill>
                             <a:srgbClr val="FFFFFF"/>
                           </a:solidFill>
@@ -13135,9 +13137,9 @@
                           <a:ea typeface="Arial" pitchFamily="34" charset="-122"/>
                           <a:cs typeface="Arial" pitchFamily="34" charset="-120"/>
                         </a:rPr>
-                        <a:t>Направл.</a:t>
+                        <a:t>Коридор и модель</a:t>
                       </a:r>
-                      <a:endParaRPr lang="en-US" sz="1000" dirty="0">
+                      <a:endParaRPr lang="en-US" sz="1050" dirty="0">
                         <a:latin typeface="Arial" charset="0"/>
                         <a:ea typeface="Arial" charset="0"/>
                         <a:cs typeface="Arial" charset="0"/>
@@ -13195,7 +13197,7 @@
                         <a:buNone/>
                       </a:pPr>
                       <a:r>
-                        <a:rPr lang="en-US" sz="1000" b="1" dirty="0">
+                        <a:rPr lang="en-US" sz="1050" b="1" dirty="0">
                           <a:solidFill>
                             <a:srgbClr val="FFFFFF"/>
                           </a:solidFill>
@@ -13203,9 +13205,9 @@
                           <a:ea typeface="Arial" pitchFamily="34" charset="-122"/>
                           <a:cs typeface="Arial" pitchFamily="34" charset="-120"/>
                         </a:rPr>
-                        <a:t>Lift</a:t>
+                        <a:t>Сигналы</a:t>
                       </a:r>
-                      <a:endParaRPr lang="en-US" sz="1000" dirty="0">
+                      <a:endParaRPr lang="en-US" sz="1050" dirty="0">
                         <a:latin typeface="Arial" charset="0"/>
                         <a:ea typeface="Arial" charset="0"/>
                         <a:cs typeface="Arial" charset="0"/>
@@ -13263,7 +13265,7 @@
                         <a:buNone/>
                       </a:pPr>
                       <a:r>
-                        <a:rPr lang="en-US" sz="1000" b="1" dirty="0">
+                        <a:rPr lang="en-US" sz="1050" b="1" dirty="0">
                           <a:solidFill>
                             <a:srgbClr val="FFFFFF"/>
                           </a:solidFill>
@@ -13271,9 +13273,9 @@
                           <a:ea typeface="Arial" pitchFamily="34" charset="-122"/>
                           <a:cs typeface="Arial" pitchFamily="34" charset="-120"/>
                         </a:rPr>
-                        <a:t>Выгода, бп</a:t>
+                        <a:t>Lift</a:t>
                       </a:r>
-                      <a:endParaRPr lang="en-US" sz="1000" dirty="0">
+                      <a:endParaRPr lang="en-US" sz="1050" dirty="0">
                         <a:latin typeface="Arial" charset="0"/>
                         <a:ea typeface="Arial" charset="0"/>
                         <a:cs typeface="Arial" charset="0"/>
@@ -13331,7 +13333,7 @@
                         <a:buNone/>
                       </a:pPr>
                       <a:r>
-                        <a:rPr lang="en-US" sz="1000" b="1" dirty="0">
+                        <a:rPr lang="en-US" sz="1050" b="1" dirty="0">
                           <a:solidFill>
                             <a:srgbClr val="FFFFFF"/>
                           </a:solidFill>
@@ -13341,7 +13343,143 @@
                         </a:rPr>
                         <a:t>Сигн./нед</a:t>
                       </a:r>
-                      <a:endParaRPr lang="en-US" sz="1000" dirty="0">
+                      <a:endParaRPr lang="en-US" sz="1050" dirty="0">
+                        <a:latin typeface="Arial" charset="0"/>
+                        <a:ea typeface="Arial" charset="0"/>
+                        <a:cs typeface="Arial" charset="0"/>
+                      </a:endParaRPr>
+                    </a:p>
+                  </a:txBody>
+                  <a:tcPr marL="63500" marR="63500" marT="63500" marB="63500" anchor="ctr">
+                    <a:lnL w="6350" cap="flat" cmpd="sng" algn="ctr">
+                      <a:solidFill>
+                        <a:srgbClr val="DCDCDC"/>
+                      </a:solidFill>
+                      <a:prstDash val="solid"/>
+                      <a:round/>
+                      <a:headEnd type="none" w="med" len="med"/>
+                      <a:tailEnd type="none" w="med" len="med"/>
+                    </a:lnL>
+                    <a:lnR w="6350" cap="flat" cmpd="sng" algn="ctr">
+                      <a:solidFill>
+                        <a:srgbClr val="DCDCDC"/>
+                      </a:solidFill>
+                      <a:prstDash val="solid"/>
+                      <a:round/>
+                      <a:headEnd type="none" w="med" len="med"/>
+                      <a:tailEnd type="none" w="med" len="med"/>
+                    </a:lnR>
+                    <a:lnT w="6350" cap="flat" cmpd="sng" algn="ctr">
+                      <a:solidFill>
+                        <a:srgbClr val="DCDCDC"/>
+                      </a:solidFill>
+                      <a:prstDash val="solid"/>
+                      <a:round/>
+                      <a:headEnd type="none" w="med" len="med"/>
+                      <a:tailEnd type="none" w="med" len="med"/>
+                    </a:lnT>
+                    <a:lnB w="6350" cap="flat" cmpd="sng" algn="ctr">
+                      <a:solidFill>
+                        <a:srgbClr val="DCDCDC"/>
+                      </a:solidFill>
+                      <a:prstDash val="solid"/>
+                      <a:round/>
+                      <a:headEnd type="none" w="med" len="med"/>
+                      <a:tailEnd type="none" w="med" len="med"/>
+                    </a:lnB>
+                    <a:solidFill>
+                      <a:srgbClr val="111111"/>
+                    </a:solidFill>
+                  </a:tcPr>
+                </a:tc>
+                <a:tc>
+                  <a:txBody>
+                    <a:bodyPr/>
+                    <a:lstStyle/>
+                    <a:p>
+                      <a:pPr indent="0" marL="0">
+                        <a:buNone/>
+                      </a:pPr>
+                      <a:r>
+                        <a:rPr lang="en-US" sz="1050" b="1" dirty="0">
+                          <a:solidFill>
+                            <a:srgbClr val="FFFFFF"/>
+                          </a:solidFill>
+                          <a:latin typeface="Arial" pitchFamily="34" charset="0"/>
+                          <a:ea typeface="Arial" pitchFamily="34" charset="-122"/>
+                          <a:cs typeface="Arial" pitchFamily="34" charset="-120"/>
+                        </a:rPr>
+                        <a:t>Same-week</a:t>
+                      </a:r>
+                      <a:endParaRPr lang="en-US" sz="1050" dirty="0">
+                        <a:latin typeface="Arial" charset="0"/>
+                        <a:ea typeface="Arial" charset="0"/>
+                        <a:cs typeface="Arial" charset="0"/>
+                      </a:endParaRPr>
+                    </a:p>
+                  </a:txBody>
+                  <a:tcPr marL="63500" marR="63500" marT="63500" marB="63500" anchor="ctr">
+                    <a:lnL w="6350" cap="flat" cmpd="sng" algn="ctr">
+                      <a:solidFill>
+                        <a:srgbClr val="DCDCDC"/>
+                      </a:solidFill>
+                      <a:prstDash val="solid"/>
+                      <a:round/>
+                      <a:headEnd type="none" w="med" len="med"/>
+                      <a:tailEnd type="none" w="med" len="med"/>
+                    </a:lnL>
+                    <a:lnR w="6350" cap="flat" cmpd="sng" algn="ctr">
+                      <a:solidFill>
+                        <a:srgbClr val="DCDCDC"/>
+                      </a:solidFill>
+                      <a:prstDash val="solid"/>
+                      <a:round/>
+                      <a:headEnd type="none" w="med" len="med"/>
+                      <a:tailEnd type="none" w="med" len="med"/>
+                    </a:lnR>
+                    <a:lnT w="6350" cap="flat" cmpd="sng" algn="ctr">
+                      <a:solidFill>
+                        <a:srgbClr val="DCDCDC"/>
+                      </a:solidFill>
+                      <a:prstDash val="solid"/>
+                      <a:round/>
+                      <a:headEnd type="none" w="med" len="med"/>
+                      <a:tailEnd type="none" w="med" len="med"/>
+                    </a:lnT>
+                    <a:lnB w="6350" cap="flat" cmpd="sng" algn="ctr">
+                      <a:solidFill>
+                        <a:srgbClr val="DCDCDC"/>
+                      </a:solidFill>
+                      <a:prstDash val="solid"/>
+                      <a:round/>
+                      <a:headEnd type="none" w="med" len="med"/>
+                      <a:tailEnd type="none" w="med" len="med"/>
+                    </a:lnB>
+                    <a:solidFill>
+                      <a:srgbClr val="111111"/>
+                    </a:solidFill>
+                  </a:tcPr>
+                </a:tc>
+                <a:tc>
+                  <a:txBody>
+                    <a:bodyPr/>
+                    <a:lstStyle/>
+                    <a:p>
+                      <a:pPr indent="0" marL="0">
+                        <a:buNone/>
+                      </a:pPr>
+                      <a:r>
+                        <a:rPr lang="en-US" sz="1050" b="1" dirty="0">
+                          <a:solidFill>
+                            <a:srgbClr val="FFFFFF"/>
+                          </a:solidFill>
+                          <a:latin typeface="Arial" pitchFamily="34" charset="0"/>
+                          <a:ea typeface="Arial" pitchFamily="34" charset="-122"/>
+                          <a:cs typeface="Arial" pitchFamily="34" charset="-120"/>
+                        </a:rPr>
+                        <a:t>Худший год</a:t>
+                      </a:r>
+                      <a:endParaRPr lang="en-US" sz="1050" dirty="0">
                         <a:latin typeface="Arial" charset="0"/>
                         <a:ea typeface="Arial" charset="0"/>
                         <a:cs typeface="Arial" charset="0"/>
@@ -13401,7 +13539,7 @@
                         <a:buNone/>
                       </a:pPr>
                       <a:r>
-                        <a:rPr lang="en-US" sz="1000" dirty="0">
+                        <a:rPr lang="en-US" sz="1050" dirty="0">
                           <a:solidFill>
                             <a:srgbClr val="222222"/>
                           </a:solidFill>
@@ -13409,9 +13547,9 @@
                           <a:ea typeface="Arial" pitchFamily="34" charset="-122"/>
                           <a:cs typeface="Arial" pitchFamily="34" charset="-120"/>
                         </a:rPr>
-                        <a:t>H9  пробой вверх</a:t>
+                        <a:t>3 дня</a:t>
                       </a:r>
-                      <a:endParaRPr lang="en-US" sz="1000" dirty="0">
+                      <a:endParaRPr lang="en-US" sz="1050" dirty="0">
                         <a:latin typeface="Arial" charset="0"/>
                         <a:ea typeface="Arial" charset="0"/>
                         <a:cs typeface="Arial" charset="0"/>
@@ -13469,7 +13607,7 @@
                         <a:buNone/>
                       </a:pPr>
                       <a:r>
-                        <a:rPr lang="en-US" sz="1000" dirty="0">
+                        <a:rPr lang="en-US" sz="1050" dirty="0">
                           <a:solidFill>
                             <a:srgbClr val="222222"/>
                           </a:solidFill>
@@ -13477,9 +13615,9 @@
                           <a:ea typeface="Arial" pitchFamily="34" charset="-122"/>
                           <a:cs typeface="Arial" pitchFamily="34" charset="-120"/>
                         </a:rPr>
-                        <a:t>closing</a:t>
+                        <a:t>AMD · XGBoost + явные лаги</a:t>
                       </a:r>
-                      <a:endParaRPr lang="en-US" sz="1000" dirty="0">
+                      <a:endParaRPr lang="en-US" sz="1050" dirty="0">
                         <a:latin typeface="Arial" charset="0"/>
                         <a:ea typeface="Arial" charset="0"/>
                         <a:cs typeface="Arial" charset="0"/>
@@ -13537,7 +13675,7 @@
                         <a:buNone/>
                       </a:pPr>
                       <a:r>
-                        <a:rPr lang="en-US" sz="1000" b="1" dirty="0">
+                        <a:rPr lang="en-US" sz="1050" dirty="0">
                           <a:solidFill>
                             <a:srgbClr val="222222"/>
                           </a:solidFill>
@@ -13545,9 +13683,9 @@
                           <a:ea typeface="Arial" pitchFamily="34" charset="-122"/>
                           <a:cs typeface="Arial" pitchFamily="34" charset="-120"/>
                         </a:rPr>
-                        <a:t>1,18</a:t>
+                        <a:t>248</a:t>
                       </a:r>
-                      <a:endParaRPr lang="en-US" sz="1000" dirty="0">
+                      <a:endParaRPr lang="en-US" sz="1050" dirty="0">
                         <a:latin typeface="Arial" charset="0"/>
                         <a:ea typeface="Arial" charset="0"/>
                         <a:cs typeface="Arial" charset="0"/>
@@ -13605,7 +13743,7 @@
                         <a:buNone/>
                       </a:pPr>
                       <a:r>
-                        <a:rPr lang="en-US" sz="1000" b="1" dirty="0">
+                        <a:rPr lang="en-US" sz="1050" b="1" dirty="0">
                           <a:solidFill>
                             <a:srgbClr val="1B7F3B"/>
                           </a:solidFill>
@@ -13613,9 +13751,9 @@
                           <a:ea typeface="Arial" pitchFamily="34" charset="-122"/>
                           <a:cs typeface="Arial" pitchFamily="34" charset="-120"/>
                         </a:rPr>
-                        <a:t>+91,2</a:t>
+                        <a:t>1,36</a:t>
                       </a:r>
-                      <a:endParaRPr lang="en-US" sz="1000" dirty="0">
+                      <a:endParaRPr lang="en-US" sz="1050" dirty="0">
                         <a:latin typeface="Arial" charset="0"/>
                         <a:ea typeface="Arial" charset="0"/>
                         <a:cs typeface="Arial" charset="0"/>
@@ -13673,7 +13811,7 @@
                         <a:buNone/>
                       </a:pPr>
                       <a:r>
-                        <a:rPr lang="en-US" sz="1000" dirty="0">
+                        <a:rPr lang="en-US" sz="1050" dirty="0">
                           <a:solidFill>
                             <a:srgbClr val="222222"/>
                           </a:solidFill>
@@ -13681,9 +13819,145 @@
                           <a:ea typeface="Arial" pitchFamily="34" charset="-122"/>
                           <a:cs typeface="Arial" pitchFamily="34" charset="-120"/>
                         </a:rPr>
-                        <a:t>0,52</a:t>
+                        <a:t>1,06</a:t>
                       </a:r>
-                      <a:endParaRPr lang="en-US" sz="1000" dirty="0">
+                      <a:endParaRPr lang="en-US" sz="1050" dirty="0">
+                        <a:latin typeface="Arial" charset="0"/>
+                        <a:ea typeface="Arial" charset="0"/>
+                        <a:cs typeface="Arial" charset="0"/>
+                      </a:endParaRPr>
+                    </a:p>
+                  </a:txBody>
+                  <a:tcPr marL="63500" marR="63500" marT="63500" marB="63500" anchor="ctr">
+                    <a:lnL w="6350" cap="flat" cmpd="sng" algn="ctr">
+                      <a:solidFill>
+                        <a:srgbClr val="DCDCDC"/>
+                      </a:solidFill>
+                      <a:prstDash val="solid"/>
+                      <a:round/>
+                      <a:headEnd type="none" w="med" len="med"/>
+                      <a:tailEnd type="none" w="med" len="med"/>
+                    </a:lnL>
+                    <a:lnR w="6350" cap="flat" cmpd="sng" algn="ctr">
+                      <a:solidFill>
+                        <a:srgbClr val="DCDCDC"/>
+                      </a:solidFill>
+                      <a:prstDash val="solid"/>
+                      <a:round/>
+                      <a:headEnd type="none" w="med" len="med"/>
+                      <a:tailEnd type="none" w="med" len="med"/>
+                    </a:lnR>
+                    <a:lnT w="6350" cap="flat" cmpd="sng" algn="ctr">
+                      <a:solidFill>
+                        <a:srgbClr val="DCDCDC"/>
+                      </a:solidFill>
+                      <a:prstDash val="solid"/>
+                      <a:round/>
+                      <a:headEnd type="none" w="med" len="med"/>
+                      <a:tailEnd type="none" w="med" len="med"/>
+                    </a:lnT>
+                    <a:lnB w="6350" cap="flat" cmpd="sng" algn="ctr">
+                      <a:solidFill>
+                        <a:srgbClr val="DCDCDC"/>
+                      </a:solidFill>
+                      <a:prstDash val="solid"/>
+                      <a:round/>
+                      <a:headEnd type="none" w="med" len="med"/>
+                      <a:tailEnd type="none" w="med" len="med"/>
+                    </a:lnB>
+                    <a:solidFill>
+                      <a:srgbClr val="FFFFFF"/>
+                    </a:solidFill>
+                  </a:tcPr>
+                </a:tc>
+                <a:tc>
+                  <a:txBody>
+                    <a:bodyPr/>
+                    <a:lstStyle/>
+                    <a:p>
+                      <a:pPr indent="0" marL="0">
+                        <a:buNone/>
+                      </a:pPr>
+                      <a:r>
+                        <a:rPr lang="en-US" sz="1050" dirty="0">
+                          <a:solidFill>
+                            <a:srgbClr val="222222"/>
+                          </a:solidFill>
+                          <a:latin typeface="Arial" pitchFamily="34" charset="0"/>
+                          <a:ea typeface="Arial" pitchFamily="34" charset="-122"/>
+                          <a:cs typeface="Arial" pitchFamily="34" charset="-120"/>
+                        </a:rPr>
+                        <a:t>1,18</a:t>
+                      </a:r>
+                      <a:endParaRPr lang="en-US" sz="1050" dirty="0">
+                        <a:latin typeface="Arial" charset="0"/>
+                        <a:ea typeface="Arial" charset="0"/>
+                        <a:cs typeface="Arial" charset="0"/>
+                      </a:endParaRPr>
+                    </a:p>
+                  </a:txBody>
+                  <a:tcPr marL="63500" marR="63500" marT="63500" marB="63500" anchor="ctr">
+                    <a:lnL w="6350" cap="flat" cmpd="sng" algn="ctr">
+                      <a:solidFill>
+                        <a:srgbClr val="DCDCDC"/>
+                      </a:solidFill>
+                      <a:prstDash val="solid"/>
+                      <a:round/>
+                      <a:headEnd type="none" w="med" len="med"/>
+                      <a:tailEnd type="none" w="med" len="med"/>
+                    </a:lnL>
+                    <a:lnR w="6350" cap="flat" cmpd="sng" algn="ctr">
+                      <a:solidFill>
+                        <a:srgbClr val="DCDCDC"/>
+                      </a:solidFill>
+                      <a:prstDash val="solid"/>
+                      <a:round/>
+                      <a:headEnd type="none" w="med" len="med"/>
+                      <a:tailEnd type="none" w="med" len="med"/>
+                    </a:lnR>
+                    <a:lnT w="6350" cap="flat" cmpd="sng" algn="ctr">
+                      <a:solidFill>
+                        <a:srgbClr val="DCDCDC"/>
+                      </a:solidFill>
+                      <a:prstDash val="solid"/>
+                      <a:round/>
+                      <a:headEnd type="none" w="med" len="med"/>
+                      <a:tailEnd type="none" w="med" len="med"/>
+                    </a:lnT>
+                    <a:lnB w="6350" cap="flat" cmpd="sng" algn="ctr">
+                      <a:solidFill>
+                        <a:srgbClr val="DCDCDC"/>
+                      </a:solidFill>
+                      <a:prstDash val="solid"/>
+                      <a:round/>
+                      <a:headEnd type="none" w="med" len="med"/>
+                      <a:tailEnd type="none" w="med" len="med"/>
+                    </a:lnB>
+                    <a:solidFill>
+                      <a:srgbClr val="FFFFFF"/>
+                    </a:solidFill>
+                  </a:tcPr>
+                </a:tc>
+                <a:tc>
+                  <a:txBody>
+                    <a:bodyPr/>
+                    <a:lstStyle/>
+                    <a:p>
+                      <a:pPr indent="0" marL="0">
+                        <a:buNone/>
+                      </a:pPr>
+                      <a:r>
+                        <a:rPr lang="en-US" sz="1050" dirty="0">
+                          <a:solidFill>
+                            <a:srgbClr val="222222"/>
+                          </a:solidFill>
+                          <a:latin typeface="Arial" pitchFamily="34" charset="0"/>
+                          <a:ea typeface="Arial" pitchFamily="34" charset="-122"/>
+                          <a:cs typeface="Arial" pitchFamily="34" charset="-120"/>
+                        </a:rPr>
+                        <a:t>1,26</a:t>
+                      </a:r>
+                      <a:endParaRPr lang="en-US" sz="1050" dirty="0">
                         <a:latin typeface="Arial" charset="0"/>
                         <a:ea typeface="Arial" charset="0"/>
                         <a:cs typeface="Arial" charset="0"/>
@@ -13743,7 +14017,7 @@
                         <a:buNone/>
                       </a:pPr>
                       <a:r>
-                        <a:rPr lang="en-US" sz="1000" dirty="0">
+                        <a:rPr lang="en-US" sz="1050" dirty="0">
                           <a:solidFill>
                             <a:srgbClr val="222222"/>
                           </a:solidFill>
@@ -13751,9 +14025,9 @@
                           <a:ea typeface="Arial" pitchFamily="34" charset="-122"/>
                           <a:cs typeface="Arial" pitchFamily="34" charset="-120"/>
                         </a:rPr>
-                        <a:t>H1  разворот</a:t>
+                        <a:t>5 дней</a:t>
                       </a:r>
-                      <a:endParaRPr lang="en-US" sz="1000" dirty="0">
+                      <a:endParaRPr lang="en-US" sz="1050" dirty="0">
                         <a:latin typeface="Arial" charset="0"/>
                         <a:ea typeface="Arial" charset="0"/>
                         <a:cs typeface="Arial" charset="0"/>
@@ -13811,7 +14085,7 @@
                         <a:buNone/>
                       </a:pPr>
                       <a:r>
-                        <a:rPr lang="en-US" sz="1000" dirty="0">
+                        <a:rPr lang="en-US" sz="1050" dirty="0">
                           <a:solidFill>
                             <a:srgbClr val="222222"/>
                           </a:solidFill>
@@ -13819,9 +14093,9 @@
                           <a:ea typeface="Arial" pitchFamily="34" charset="-122"/>
                           <a:cs typeface="Arial" pitchFamily="34" charset="-120"/>
                         </a:rPr>
-                        <a:t>closing</a:t>
+                        <a:t>AMD · CatBoost + triple barrier + история с 2010</a:t>
                       </a:r>
-                      <a:endParaRPr lang="en-US" sz="1000" dirty="0">
+                      <a:endParaRPr lang="en-US" sz="1050" dirty="0">
                         <a:latin typeface="Arial" charset="0"/>
                         <a:ea typeface="Arial" charset="0"/>
                         <a:cs typeface="Arial" charset="0"/>
@@ -13879,7 +14153,7 @@
                         <a:buNone/>
                       </a:pPr>
                       <a:r>
-                        <a:rPr lang="en-US" sz="1000" dirty="0">
+                        <a:rPr lang="en-US" sz="1050" dirty="0">
                           <a:solidFill>
                             <a:srgbClr val="222222"/>
                           </a:solidFill>
@@ -13887,9 +14161,9 @@
                           <a:ea typeface="Arial" pitchFamily="34" charset="-122"/>
                           <a:cs typeface="Arial" pitchFamily="34" charset="-120"/>
                         </a:rPr>
-                        <a:t>1,11</a:t>
+                        <a:t>240</a:t>
                       </a:r>
-                      <a:endParaRPr lang="en-US" sz="1000" dirty="0">
+                      <a:endParaRPr lang="en-US" sz="1050" dirty="0">
                         <a:latin typeface="Arial" charset="0"/>
                         <a:ea typeface="Arial" charset="0"/>
                         <a:cs typeface="Arial" charset="0"/>
@@ -13947,7 +14221,7 @@
                         <a:buNone/>
                       </a:pPr>
                       <a:r>
-                        <a:rPr lang="en-US" sz="1000" dirty="0">
+                        <a:rPr lang="en-US" sz="1050" b="1" dirty="0">
                           <a:solidFill>
                             <a:srgbClr val="1B7F3B"/>
                           </a:solidFill>
@@ -13955,9 +14229,9 @@
                           <a:ea typeface="Arial" pitchFamily="34" charset="-122"/>
                           <a:cs typeface="Arial" pitchFamily="34" charset="-120"/>
                         </a:rPr>
-                        <a:t>+42,3</a:t>
+                        <a:t>1,41</a:t>
                       </a:r>
-                      <a:endParaRPr lang="en-US" sz="1000" dirty="0">
+                      <a:endParaRPr lang="en-US" sz="1050" dirty="0">
                         <a:latin typeface="Arial" charset="0"/>
                         <a:ea typeface="Arial" charset="0"/>
                         <a:cs typeface="Arial" charset="0"/>
@@ -14015,7 +14289,143 @@
                         <a:buNone/>
                       </a:pPr>
                       <a:r>
-                        <a:rPr lang="en-US" sz="1000" dirty="0">
+                        <a:rPr lang="en-US" sz="1050" dirty="0">
+                          <a:solidFill>
+                            <a:srgbClr val="222222"/>
+                          </a:solidFill>
+                          <a:latin typeface="Arial" pitchFamily="34" charset="0"/>
+                          <a:ea typeface="Arial" pitchFamily="34" charset="-122"/>
+                          <a:cs typeface="Arial" pitchFamily="34" charset="-120"/>
+                        </a:rPr>
+                        <a:t>1,02</a:t>
+                      </a:r>
+                      <a:endParaRPr lang="en-US" sz="1050" dirty="0">
+                        <a:latin typeface="Arial" charset="0"/>
+                        <a:ea typeface="Arial" charset="0"/>
+                        <a:cs typeface="Arial" charset="0"/>
+                      </a:endParaRPr>
+                    </a:p>
+                  </a:txBody>
+                  <a:tcPr marL="63500" marR="63500" marT="63500" marB="63500" anchor="ctr">
+                    <a:lnL w="6350" cap="flat" cmpd="sng" algn="ctr">
+                      <a:solidFill>
+                        <a:srgbClr val="DCDCDC"/>
+                      </a:solidFill>
+                      <a:prstDash val="solid"/>
+                      <a:round/>
+                      <a:headEnd type="none" w="med" len="med"/>
+                      <a:tailEnd type="none" w="med" len="med"/>
+                    </a:lnL>
+                    <a:lnR w="6350" cap="flat" cmpd="sng" algn="ctr">
+                      <a:solidFill>
+                        <a:srgbClr val="DCDCDC"/>
+                      </a:solidFill>
+                      <a:prstDash val="solid"/>
+                      <a:round/>
+                      <a:headEnd type="none" w="med" len="med"/>
+                      <a:tailEnd type="none" w="med" len="med"/>
+                    </a:lnR>
+                    <a:lnT w="6350" cap="flat" cmpd="sng" algn="ctr">
+                      <a:solidFill>
+                        <a:srgbClr val="DCDCDC"/>
+                      </a:solidFill>
+                      <a:prstDash val="solid"/>
+                      <a:round/>
+                      <a:headEnd type="none" w="med" len="med"/>
+                      <a:tailEnd type="none" w="med" len="med"/>
+                    </a:lnT>
+                    <a:lnB w="6350" cap="flat" cmpd="sng" algn="ctr">
+                      <a:solidFill>
+                        <a:srgbClr val="DCDCDC"/>
+                      </a:solidFill>
+                      <a:prstDash val="solid"/>
+                      <a:round/>
+                      <a:headEnd type="none" w="med" len="med"/>
+                      <a:tailEnd type="none" w="med" len="med"/>
+                    </a:lnB>
+                    <a:solidFill>
+                      <a:srgbClr val="FFFFFF"/>
+                    </a:solidFill>
+                  </a:tcPr>
+                </a:tc>
+                <a:tc>
+                  <a:txBody>
+                    <a:bodyPr/>
+                    <a:lstStyle/>
+                    <a:p>
+                      <a:pPr indent="0" marL="0">
+                        <a:buNone/>
+                      </a:pPr>
+                      <a:r>
+                        <a:rPr lang="en-US" sz="1050" dirty="0">
+                          <a:solidFill>
+                            <a:srgbClr val="222222"/>
+                          </a:solidFill>
+                          <a:latin typeface="Arial" pitchFamily="34" charset="0"/>
+                          <a:ea typeface="Arial" pitchFamily="34" charset="-122"/>
+                          <a:cs typeface="Arial" pitchFamily="34" charset="-120"/>
+                        </a:rPr>
+                        <a:t>1,18</a:t>
+                      </a:r>
+                      <a:endParaRPr lang="en-US" sz="1050" dirty="0">
+                        <a:latin typeface="Arial" charset="0"/>
+                        <a:ea typeface="Arial" charset="0"/>
+                        <a:cs typeface="Arial" charset="0"/>
+                      </a:endParaRPr>
+                    </a:p>
+                  </a:txBody>
+                  <a:tcPr marL="63500" marR="63500" marT="63500" marB="63500" anchor="ctr">
+                    <a:lnL w="6350" cap="flat" cmpd="sng" algn="ctr">
+                      <a:solidFill>
+                        <a:srgbClr val="DCDCDC"/>
+                      </a:solidFill>
+                      <a:prstDash val="solid"/>
+                      <a:round/>
+                      <a:headEnd type="none" w="med" len="med"/>
+                      <a:tailEnd type="none" w="med" len="med"/>
+                    </a:lnL>
+                    <a:lnR w="6350" cap="flat" cmpd="sng" algn="ctr">
+                      <a:solidFill>
+                        <a:srgbClr val="DCDCDC"/>
+                      </a:solidFill>
+                      <a:prstDash val="solid"/>
+                      <a:round/>
+                      <a:headEnd type="none" w="med" len="med"/>
+                      <a:tailEnd type="none" w="med" len="med"/>
+                    </a:lnR>
+                    <a:lnT w="6350" cap="flat" cmpd="sng" algn="ctr">
+                      <a:solidFill>
+                        <a:srgbClr val="DCDCDC"/>
+                      </a:solidFill>
+                      <a:prstDash val="solid"/>
+                      <a:round/>
+                      <a:headEnd type="none" w="med" len="med"/>
+                      <a:tailEnd type="none" w="med" len="med"/>
+                    </a:lnT>
+                    <a:lnB w="6350" cap="flat" cmpd="sng" algn="ctr">
+                      <a:solidFill>
+                        <a:srgbClr val="DCDCDC"/>
+                      </a:solidFill>
+                      <a:prstDash val="solid"/>
+                      <a:round/>
+                      <a:headEnd type="none" w="med" len="med"/>
+                      <a:tailEnd type="none" w="med" len="med"/>
+                    </a:lnB>
+                    <a:solidFill>
+                      <a:srgbClr val="FFFFFF"/>
+                    </a:solidFill>
+                  </a:tcPr>
+                </a:tc>
+                <a:tc>
+                  <a:txBody>
+                    <a:bodyPr/>
+                    <a:lstStyle/>
+                    <a:p>
+                      <a:pPr indent="0" marL="0">
+                        <a:buNone/>
+                      </a:pPr>
+                      <a:r>
+                        <a:rPr lang="en-US" sz="1050" dirty="0">
                           <a:solidFill>
                             <a:srgbClr val="222222"/>
                           </a:solidFill>
@@ -14025,7 +14435,7 @@
                         </a:rPr>
                         <a:t>1,26</a:t>
                       </a:r>
-                      <a:endParaRPr lang="en-US" sz="1000" dirty="0">
+                      <a:endParaRPr lang="en-US" sz="1050" dirty="0">
                         <a:latin typeface="Arial" charset="0"/>
                         <a:ea typeface="Arial" charset="0"/>
                         <a:cs typeface="Arial" charset="0"/>
@@ -14085,7 +14495,7 @@
                         <a:buNone/>
                       </a:pPr>
                       <a:r>
-                        <a:rPr lang="en-US" sz="1000" dirty="0">
+                        <a:rPr lang="en-US" sz="1050" dirty="0">
                           <a:solidFill>
                             <a:srgbClr val="222222"/>
                           </a:solidFill>
@@ -14093,9 +14503,9 @@
                           <a:ea typeface="Arial" pitchFamily="34" charset="-122"/>
                           <a:cs typeface="Arial" pitchFamily="34" charset="-120"/>
                         </a:rPr>
-                        <a:t>H4  интрадей</a:t>
+                        <a:t>10 дней</a:t>
                       </a:r>
-                      <a:endParaRPr lang="en-US" sz="1000" dirty="0">
+                      <a:endParaRPr lang="en-US" sz="1050" dirty="0">
                         <a:latin typeface="Arial" charset="0"/>
                         <a:ea typeface="Arial" charset="0"/>
                         <a:cs typeface="Arial" charset="0"/>
@@ -14153,7 +14563,7 @@
                         <a:buNone/>
                       </a:pPr>
                       <a:r>
-                        <a:rPr lang="en-US" sz="1000" dirty="0">
+                        <a:rPr lang="en-US" sz="1050" dirty="0">
                           <a:solidFill>
                             <a:srgbClr val="222222"/>
                           </a:solidFill>
@@ -14161,9 +14571,9 @@
                           <a:ea typeface="Arial" pitchFamily="34" charset="-122"/>
                           <a:cs typeface="Arial" pitchFamily="34" charset="-120"/>
                         </a:rPr>
-                        <a:t>closing</a:t>
+                        <a:t>TJS · CatBoost + triple barrier + Brent lag 7d</a:t>
                       </a:r>
-                      <a:endParaRPr lang="en-US" sz="1000" dirty="0">
+                      <a:endParaRPr lang="en-US" sz="1050" dirty="0">
                         <a:latin typeface="Arial" charset="0"/>
                         <a:ea typeface="Arial" charset="0"/>
                         <a:cs typeface="Arial" charset="0"/>
@@ -14221,7 +14631,7 @@
                         <a:buNone/>
                       </a:pPr>
                       <a:r>
-                        <a:rPr lang="en-US" sz="1000" dirty="0">
+                        <a:rPr lang="en-US" sz="1050" dirty="0">
                           <a:solidFill>
                             <a:srgbClr val="222222"/>
                           </a:solidFill>
@@ -14229,9 +14639,9 @@
                           <a:ea typeface="Arial" pitchFamily="34" charset="-122"/>
                           <a:cs typeface="Arial" pitchFamily="34" charset="-120"/>
                         </a:rPr>
-                        <a:t>1,19</a:t>
+                        <a:t>248</a:t>
                       </a:r>
-                      <a:endParaRPr lang="en-US" sz="1000" dirty="0">
+                      <a:endParaRPr lang="en-US" sz="1050" dirty="0">
                         <a:latin typeface="Arial" charset="0"/>
                         <a:ea typeface="Arial" charset="0"/>
                         <a:cs typeface="Arial" charset="0"/>
@@ -14289,17 +14699,17 @@
                         <a:buNone/>
                       </a:pPr>
                       <a:r>
-                        <a:rPr lang="en-US" sz="1000" dirty="0">
+                        <a:rPr lang="en-US" sz="1050" b="1" dirty="0">
                           <a:solidFill>
-                            <a:srgbClr val="222222"/>
+                            <a:srgbClr val="1B7F3B"/>
                           </a:solidFill>
                           <a:latin typeface="Arial" pitchFamily="34" charset="0"/>
                           <a:ea typeface="Arial" pitchFamily="34" charset="-122"/>
                           <a:cs typeface="Arial" pitchFamily="34" charset="-120"/>
                         </a:rPr>
-                        <a:t>+2,6</a:t>
+                        <a:t>1,45</a:t>
                       </a:r>
-                      <a:endParaRPr lang="en-US" sz="1000" dirty="0">
+                      <a:endParaRPr lang="en-US" sz="1050" dirty="0">
                         <a:latin typeface="Arial" charset="0"/>
                         <a:ea typeface="Arial" charset="0"/>
                         <a:cs typeface="Arial" charset="0"/>
@@ -14357,7 +14767,7 @@
                         <a:buNone/>
                       </a:pPr>
                       <a:r>
-                        <a:rPr lang="en-US" sz="1000" b="1" dirty="0">
+                        <a:rPr lang="en-US" sz="1050" dirty="0">
                           <a:solidFill>
                             <a:srgbClr val="222222"/>
                           </a:solidFill>
@@ -14365,79 +14775,9 @@
                           <a:ea typeface="Arial" pitchFamily="34" charset="-122"/>
                           <a:cs typeface="Arial" pitchFamily="34" charset="-120"/>
                         </a:rPr>
-                        <a:t>1,92</a:t>
+                        <a:t>1,06</a:t>
                       </a:r>
-                      <a:endParaRPr lang="en-US" sz="1000" dirty="0">
-                        <a:latin typeface="Arial" charset="0"/>
-                        <a:ea typeface="Arial" charset="0"/>
-                        <a:cs typeface="Arial" charset="0"/>
-                      </a:endParaRPr>
-                    </a:p>
-                  </a:txBody>
-                  <a:tcPr marL="63500" marR="63500" marT="63500" marB="63500" anchor="ctr">
-                    <a:lnL w="6350" cap="flat" cmpd="sng" algn="ctr">
-                      <a:solidFill>
-                        <a:srgbClr val="DCDCDC"/>
-                      </a:solidFill>
-                      <a:prstDash val="solid"/>
-                      <a:round/>
-                      <a:headEnd type="none" w="med" len="med"/>
-                      <a:tailEnd type="none" w="med" len="med"/>
-                    </a:lnL>
-                    <a:lnR w="6350" cap="flat" cmpd="sng" algn="ctr">
-                      <a:solidFill>
-                        <a:srgbClr val="DCDCDC"/>
-                      </a:solidFill>
-                      <a:prstDash val="solid"/>
-                      <a:round/>
-                      <a:headEnd type="none" w="med" len="med"/>
-                      <a:tailEnd type="none" w="med" len="med"/>
-                    </a:lnR>
-                    <a:lnT w="6350" cap="flat" cmpd="sng" algn="ctr">
-                      <a:solidFill>
-                        <a:srgbClr val="DCDCDC"/>
-                      </a:solidFill>
-                      <a:prstDash val="solid"/>
-                      <a:round/>
-                      <a:headEnd type="none" w="med" len="med"/>
-                      <a:tailEnd type="none" w="med" len="med"/>
-                    </a:lnT>
-                    <a:lnB w="6350" cap="flat" cmpd="sng" algn="ctr">
-                      <a:solidFill>
-                        <a:srgbClr val="DCDCDC"/>
-                      </a:solidFill>
-                      <a:prstDash val="solid"/>
-                      <a:round/>
-                      <a:headEnd type="none" w="med" len="med"/>
-                      <a:tailEnd type="none" w="med" len="med"/>
-                    </a:lnB>
-                    <a:solidFill>
-                      <a:srgbClr val="FFFFFF"/>
-                    </a:solidFill>
-                  </a:tcPr>
-                </a:tc>
-              </a:tr>
-              <a:tr h="274320">
-                <a:tc>
-                  <a:txBody>
-                    <a:bodyPr/>
-                    <a:lstStyle/>
-                    <a:p>
-                      <a:pPr indent="0" marL="0">
-                        <a:buNone/>
-                      </a:pPr>
-                      <a:r>
-                        <a:rPr lang="en-US" sz="1000" dirty="0">
-                          <a:solidFill>
-                            <a:srgbClr val="222222"/>
-                          </a:solidFill>
-                          <a:latin typeface="Arial" pitchFamily="34" charset="0"/>
-                          <a:ea typeface="Arial" pitchFamily="34" charset="-122"/>
-                          <a:cs typeface="Arial" pitchFamily="34" charset="-120"/>
-                        </a:rPr>
-                        <a:t>H8  нижний дециль</a:t>
-                      </a:r>
-                      <a:endParaRPr lang="en-US" sz="1000" dirty="0">
+                      <a:endParaRPr lang="en-US" sz="1050" dirty="0">
                         <a:latin typeface="Arial" charset="0"/>
                         <a:ea typeface="Arial" charset="0"/>
                         <a:cs typeface="Arial" charset="0"/>
@@ -14495,7 +14835,7 @@
                         <a:buNone/>
                       </a:pPr>
                       <a:r>
-                        <a:rPr lang="en-US" sz="1000" dirty="0">
+                        <a:rPr lang="en-US" sz="1050" dirty="0">
                           <a:solidFill>
                             <a:srgbClr val="222222"/>
                           </a:solidFill>
@@ -14503,9 +14843,9 @@
                           <a:ea typeface="Arial" pitchFamily="34" charset="-122"/>
                           <a:cs typeface="Arial" pitchFamily="34" charset="-120"/>
                         </a:rPr>
-                        <a:t>favorable</a:t>
+                        <a:t>1,23</a:t>
                       </a:r>
-                      <a:endParaRPr lang="en-US" sz="1000" dirty="0">
+                      <a:endParaRPr lang="en-US" sz="1050" dirty="0">
                         <a:latin typeface="Arial" charset="0"/>
                         <a:ea typeface="Arial" charset="0"/>
                         <a:cs typeface="Arial" charset="0"/>
@@ -14563,7 +14903,7 @@
                         <a:buNone/>
                       </a:pPr>
                       <a:r>
-                        <a:rPr lang="en-US" sz="1000" dirty="0">
+                        <a:rPr lang="en-US" sz="1050" dirty="0">
                           <a:solidFill>
                             <a:srgbClr val="222222"/>
                           </a:solidFill>
@@ -14571,829 +14911,9 @@
                           <a:ea typeface="Arial" pitchFamily="34" charset="-122"/>
                           <a:cs typeface="Arial" pitchFamily="34" charset="-120"/>
                         </a:rPr>
-                        <a:t>1,03</a:t>
+                        <a:t>1,19</a:t>
                       </a:r>
-                      <a:endParaRPr lang="en-US" sz="1000" dirty="0">
-                        <a:latin typeface="Arial" charset="0"/>
-                        <a:ea typeface="Arial" charset="0"/>
-                        <a:cs typeface="Arial" charset="0"/>
-                      </a:endParaRPr>
-                    </a:p>
-                  </a:txBody>
-                  <a:tcPr marL="63500" marR="63500" marT="63500" marB="63500" anchor="ctr">
-                    <a:lnL w="6350" cap="flat" cmpd="sng" algn="ctr">
-                      <a:solidFill>
-                        <a:srgbClr val="DCDCDC"/>
-                      </a:solidFill>
-                      <a:prstDash val="solid"/>
-                      <a:round/>
-                      <a:headEnd type="none" w="med" len="med"/>
-                      <a:tailEnd type="none" w="med" len="med"/>
-                    </a:lnL>
-                    <a:lnR w="6350" cap="flat" cmpd="sng" algn="ctr">
-                      <a:solidFill>
-                        <a:srgbClr val="DCDCDC"/>
-                      </a:solidFill>
-                      <a:prstDash val="solid"/>
-                      <a:round/>
-                      <a:headEnd type="none" w="med" len="med"/>
-                      <a:tailEnd type="none" w="med" len="med"/>
-                    </a:lnR>
-                    <a:lnT w="6350" cap="flat" cmpd="sng" algn="ctr">
-                      <a:solidFill>
-                        <a:srgbClr val="DCDCDC"/>
-                      </a:solidFill>
-                      <a:prstDash val="solid"/>
-                      <a:round/>
-                      <a:headEnd type="none" w="med" len="med"/>
-                      <a:tailEnd type="none" w="med" len="med"/>
-                    </a:lnT>
-                    <a:lnB w="6350" cap="flat" cmpd="sng" algn="ctr">
-                      <a:solidFill>
-                        <a:srgbClr val="DCDCDC"/>
-                      </a:solidFill>
-                      <a:prstDash val="solid"/>
-                      <a:round/>
-                      <a:headEnd type="none" w="med" len="med"/>
-                      <a:tailEnd type="none" w="med" len="med"/>
-                    </a:lnB>
-                    <a:solidFill>
-                      <a:srgbClr val="FFFFFF"/>
-                    </a:solidFill>
-                  </a:tcPr>
-                </a:tc>
-                <a:tc>
-                  <a:txBody>
-                    <a:bodyPr/>
-                    <a:lstStyle/>
-                    <a:p>
-                      <a:pPr indent="0" marL="0">
-                        <a:buNone/>
-                      </a:pPr>
-                      <a:r>
-                        <a:rPr lang="en-US" sz="1000" dirty="0">
-                          <a:solidFill>
-                            <a:srgbClr val="EF3124"/>
-                          </a:solidFill>
-                          <a:latin typeface="Arial" pitchFamily="34" charset="0"/>
-                          <a:ea typeface="Arial" pitchFamily="34" charset="-122"/>
-                          <a:cs typeface="Arial" pitchFamily="34" charset="-120"/>
-                        </a:rPr>
-                        <a:t>−10,9</a:t>
-                      </a:r>
-                      <a:endParaRPr lang="en-US" sz="1000" dirty="0">
-                        <a:latin typeface="Arial" charset="0"/>
-                        <a:ea typeface="Arial" charset="0"/>
-                        <a:cs typeface="Arial" charset="0"/>
-                      </a:endParaRPr>
-                    </a:p>
-                  </a:txBody>
-                  <a:tcPr marL="63500" marR="63500" marT="63500" marB="63500" anchor="ctr">
-                    <a:lnL w="6350" cap="flat" cmpd="sng" algn="ctr">
-                      <a:solidFill>
-                        <a:srgbClr val="DCDCDC"/>
-                      </a:solidFill>
-                      <a:prstDash val="solid"/>
-                      <a:round/>
-                      <a:headEnd type="none" w="med" len="med"/>
-                      <a:tailEnd type="none" w="med" len="med"/>
-                    </a:lnL>
-                    <a:lnR w="6350" cap="flat" cmpd="sng" algn="ctr">
-                      <a:solidFill>
-                        <a:srgbClr val="DCDCDC"/>
-                      </a:solidFill>
-                      <a:prstDash val="solid"/>
-                      <a:round/>
-                      <a:headEnd type="none" w="med" len="med"/>
-                      <a:tailEnd type="none" w="med" len="med"/>
-                    </a:lnR>
-                    <a:lnT w="6350" cap="flat" cmpd="sng" algn="ctr">
-                      <a:solidFill>
-                        <a:srgbClr val="DCDCDC"/>
-                      </a:solidFill>
-                      <a:prstDash val="solid"/>
-                      <a:round/>
-                      <a:headEnd type="none" w="med" len="med"/>
-                      <a:tailEnd type="none" w="med" len="med"/>
-                    </a:lnT>
-                    <a:lnB w="6350" cap="flat" cmpd="sng" algn="ctr">
-                      <a:solidFill>
-                        <a:srgbClr val="DCDCDC"/>
-                      </a:solidFill>
-                      <a:prstDash val="solid"/>
-                      <a:round/>
-                      <a:headEnd type="none" w="med" len="med"/>
-                      <a:tailEnd type="none" w="med" len="med"/>
-                    </a:lnB>
-                    <a:solidFill>
-                      <a:srgbClr val="FFFFFF"/>
-                    </a:solidFill>
-                  </a:tcPr>
-                </a:tc>
-                <a:tc>
-                  <a:txBody>
-                    <a:bodyPr/>
-                    <a:lstStyle/>
-                    <a:p>
-                      <a:pPr indent="0" marL="0">
-                        <a:buNone/>
-                      </a:pPr>
-                      <a:r>
-                        <a:rPr lang="en-US" sz="1000" dirty="0">
-                          <a:solidFill>
-                            <a:srgbClr val="222222"/>
-                          </a:solidFill>
-                          <a:latin typeface="Arial" pitchFamily="34" charset="0"/>
-                          <a:ea typeface="Arial" pitchFamily="34" charset="-122"/>
-                          <a:cs typeface="Arial" pitchFamily="34" charset="-120"/>
-                        </a:rPr>
-                        <a:t>0,38</a:t>
-                      </a:r>
-                      <a:endParaRPr lang="en-US" sz="1000" dirty="0">
-                        <a:latin typeface="Arial" charset="0"/>
-                        <a:ea typeface="Arial" charset="0"/>
-                        <a:cs typeface="Arial" charset="0"/>
-                      </a:endParaRPr>
-                    </a:p>
-                  </a:txBody>
-                  <a:tcPr marL="63500" marR="63500" marT="63500" marB="63500" anchor="ctr">
-                    <a:lnL w="6350" cap="flat" cmpd="sng" algn="ctr">
-                      <a:solidFill>
-                        <a:srgbClr val="DCDCDC"/>
-                      </a:solidFill>
-                      <a:prstDash val="solid"/>
-                      <a:round/>
-                      <a:headEnd type="none" w="med" len="med"/>
-                      <a:tailEnd type="none" w="med" len="med"/>
-                    </a:lnL>
-                    <a:lnR w="6350" cap="flat" cmpd="sng" algn="ctr">
-                      <a:solidFill>
-                        <a:srgbClr val="DCDCDC"/>
-                      </a:solidFill>
-                      <a:prstDash val="solid"/>
-                      <a:round/>
-                      <a:headEnd type="none" w="med" len="med"/>
-                      <a:tailEnd type="none" w="med" len="med"/>
-                    </a:lnR>
-                    <a:lnT w="6350" cap="flat" cmpd="sng" algn="ctr">
-                      <a:solidFill>
-                        <a:srgbClr val="DCDCDC"/>
-                      </a:solidFill>
-                      <a:prstDash val="solid"/>
-                      <a:round/>
-                      <a:headEnd type="none" w="med" len="med"/>
-                      <a:tailEnd type="none" w="med" len="med"/>
-                    </a:lnT>
-                    <a:lnB w="6350" cap="flat" cmpd="sng" algn="ctr">
-                      <a:solidFill>
-                        <a:srgbClr val="DCDCDC"/>
-                      </a:solidFill>
-                      <a:prstDash val="solid"/>
-                      <a:round/>
-                      <a:headEnd type="none" w="med" len="med"/>
-                      <a:tailEnd type="none" w="med" len="med"/>
-                    </a:lnB>
-                    <a:solidFill>
-                      <a:srgbClr val="FFFFFF"/>
-                    </a:solidFill>
-                  </a:tcPr>
-                </a:tc>
-              </a:tr>
-              <a:tr h="274320">
-                <a:tc>
-                  <a:txBody>
-                    <a:bodyPr/>
-                    <a:lstStyle/>
-                    <a:p>
-                      <a:pPr indent="0" marL="0">
-                        <a:buNone/>
-                      </a:pPr>
-                      <a:r>
-                        <a:rPr lang="en-US" sz="1000" dirty="0">
-                          <a:solidFill>
-                            <a:srgbClr val="222222"/>
-                          </a:solidFill>
-                          <a:latin typeface="Arial" pitchFamily="34" charset="0"/>
-                          <a:ea typeface="Arial" pitchFamily="34" charset="-122"/>
-                          <a:cs typeface="Arial" pitchFamily="34" charset="-120"/>
-                        </a:rPr>
-                        <a:t>H10 Боллинджер</a:t>
-                      </a:r>
-                      <a:endParaRPr lang="en-US" sz="1000" dirty="0">
-                        <a:latin typeface="Arial" charset="0"/>
-                        <a:ea typeface="Arial" charset="0"/>
-                        <a:cs typeface="Arial" charset="0"/>
-                      </a:endParaRPr>
-                    </a:p>
-                  </a:txBody>
-                  <a:tcPr marL="63500" marR="63500" marT="63500" marB="63500" anchor="ctr">
-                    <a:lnL w="6350" cap="flat" cmpd="sng" algn="ctr">
-                      <a:solidFill>
-                        <a:srgbClr val="DCDCDC"/>
-                      </a:solidFill>
-                      <a:prstDash val="solid"/>
-                      <a:round/>
-                      <a:headEnd type="none" w="med" len="med"/>
-                      <a:tailEnd type="none" w="med" len="med"/>
-                    </a:lnL>
-                    <a:lnR w="6350" cap="flat" cmpd="sng" algn="ctr">
-                      <a:solidFill>
-                        <a:srgbClr val="DCDCDC"/>
-                      </a:solidFill>
-                      <a:prstDash val="solid"/>
-                      <a:round/>
-                      <a:headEnd type="none" w="med" len="med"/>
-                      <a:tailEnd type="none" w="med" len="med"/>
-                    </a:lnR>
-                    <a:lnT w="6350" cap="flat" cmpd="sng" algn="ctr">
-                      <a:solidFill>
-                        <a:srgbClr val="DCDCDC"/>
-                      </a:solidFill>
-                      <a:prstDash val="solid"/>
-                      <a:round/>
-                      <a:headEnd type="none" w="med" len="med"/>
-                      <a:tailEnd type="none" w="med" len="med"/>
-                    </a:lnT>
-                    <a:lnB w="6350" cap="flat" cmpd="sng" algn="ctr">
-                      <a:solidFill>
-                        <a:srgbClr val="DCDCDC"/>
-                      </a:solidFill>
-                      <a:prstDash val="solid"/>
-                      <a:round/>
-                      <a:headEnd type="none" w="med" len="med"/>
-                      <a:tailEnd type="none" w="med" len="med"/>
-                    </a:lnB>
-                    <a:solidFill>
-                      <a:srgbClr val="FFFFFF"/>
-                    </a:solidFill>
-                  </a:tcPr>
-                </a:tc>
-                <a:tc>
-                  <a:txBody>
-                    <a:bodyPr/>
-                    <a:lstStyle/>
-                    <a:p>
-                      <a:pPr indent="0" marL="0">
-                        <a:buNone/>
-                      </a:pPr>
-                      <a:r>
-                        <a:rPr lang="en-US" sz="1000" dirty="0">
-                          <a:solidFill>
-                            <a:srgbClr val="222222"/>
-                          </a:solidFill>
-                          <a:latin typeface="Arial" pitchFamily="34" charset="0"/>
-                          <a:ea typeface="Arial" pitchFamily="34" charset="-122"/>
-                          <a:cs typeface="Arial" pitchFamily="34" charset="-120"/>
-                        </a:rPr>
-                        <a:t>favorable</a:t>
-                      </a:r>
-                      <a:endParaRPr lang="en-US" sz="1000" dirty="0">
-                        <a:latin typeface="Arial" charset="0"/>
-                        <a:ea typeface="Arial" charset="0"/>
-                        <a:cs typeface="Arial" charset="0"/>
-                      </a:endParaRPr>
-                    </a:p>
-                  </a:txBody>
-                  <a:tcPr marL="63500" marR="63500" marT="63500" marB="63500" anchor="ctr">
-                    <a:lnL w="6350" cap="flat" cmpd="sng" algn="ctr">
-                      <a:solidFill>
-                        <a:srgbClr val="DCDCDC"/>
-                      </a:solidFill>
-                      <a:prstDash val="solid"/>
-                      <a:round/>
-                      <a:headEnd type="none" w="med" len="med"/>
-                      <a:tailEnd type="none" w="med" len="med"/>
-                    </a:lnL>
-                    <a:lnR w="6350" cap="flat" cmpd="sng" algn="ctr">
-                      <a:solidFill>
-                        <a:srgbClr val="DCDCDC"/>
-                      </a:solidFill>
-                      <a:prstDash val="solid"/>
-                      <a:round/>
-                      <a:headEnd type="none" w="med" len="med"/>
-                      <a:tailEnd type="none" w="med" len="med"/>
-                    </a:lnR>
-                    <a:lnT w="6350" cap="flat" cmpd="sng" algn="ctr">
-                      <a:solidFill>
-                        <a:srgbClr val="DCDCDC"/>
-                      </a:solidFill>
-                      <a:prstDash val="solid"/>
-                      <a:round/>
-                      <a:headEnd type="none" w="med" len="med"/>
-                      <a:tailEnd type="none" w="med" len="med"/>
-                    </a:lnT>
-                    <a:lnB w="6350" cap="flat" cmpd="sng" algn="ctr">
-                      <a:solidFill>
-                        <a:srgbClr val="DCDCDC"/>
-                      </a:solidFill>
-                      <a:prstDash val="solid"/>
-                      <a:round/>
-                      <a:headEnd type="none" w="med" len="med"/>
-                      <a:tailEnd type="none" w="med" len="med"/>
-                    </a:lnB>
-                    <a:solidFill>
-                      <a:srgbClr val="FFFFFF"/>
-                    </a:solidFill>
-                  </a:tcPr>
-                </a:tc>
-                <a:tc>
-                  <a:txBody>
-                    <a:bodyPr/>
-                    <a:lstStyle/>
-                    <a:p>
-                      <a:pPr indent="0" marL="0">
-                        <a:buNone/>
-                      </a:pPr>
-                      <a:r>
-                        <a:rPr lang="en-US" sz="1000" dirty="0">
-                          <a:solidFill>
-                            <a:srgbClr val="EF3124"/>
-                          </a:solidFill>
-                          <a:latin typeface="Arial" pitchFamily="34" charset="0"/>
-                          <a:ea typeface="Arial" pitchFamily="34" charset="-122"/>
-                          <a:cs typeface="Arial" pitchFamily="34" charset="-120"/>
-                        </a:rPr>
-                        <a:t>0,79</a:t>
-                      </a:r>
-                      <a:endParaRPr lang="en-US" sz="1000" dirty="0">
-                        <a:latin typeface="Arial" charset="0"/>
-                        <a:ea typeface="Arial" charset="0"/>
-                        <a:cs typeface="Arial" charset="0"/>
-                      </a:endParaRPr>
-                    </a:p>
-                  </a:txBody>
-                  <a:tcPr marL="63500" marR="63500" marT="63500" marB="63500" anchor="ctr">
-                    <a:lnL w="6350" cap="flat" cmpd="sng" algn="ctr">
-                      <a:solidFill>
-                        <a:srgbClr val="DCDCDC"/>
-                      </a:solidFill>
-                      <a:prstDash val="solid"/>
-                      <a:round/>
-                      <a:headEnd type="none" w="med" len="med"/>
-                      <a:tailEnd type="none" w="med" len="med"/>
-                    </a:lnL>
-                    <a:lnR w="6350" cap="flat" cmpd="sng" algn="ctr">
-                      <a:solidFill>
-                        <a:srgbClr val="DCDCDC"/>
-                      </a:solidFill>
-                      <a:prstDash val="solid"/>
-                      <a:round/>
-                      <a:headEnd type="none" w="med" len="med"/>
-                      <a:tailEnd type="none" w="med" len="med"/>
-                    </a:lnR>
-                    <a:lnT w="6350" cap="flat" cmpd="sng" algn="ctr">
-                      <a:solidFill>
-                        <a:srgbClr val="DCDCDC"/>
-                      </a:solidFill>
-                      <a:prstDash val="solid"/>
-                      <a:round/>
-                      <a:headEnd type="none" w="med" len="med"/>
-                      <a:tailEnd type="none" w="med" len="med"/>
-                    </a:lnT>
-                    <a:lnB w="6350" cap="flat" cmpd="sng" algn="ctr">
-                      <a:solidFill>
-                        <a:srgbClr val="DCDCDC"/>
-                      </a:solidFill>
-                      <a:prstDash val="solid"/>
-                      <a:round/>
-                      <a:headEnd type="none" w="med" len="med"/>
-                      <a:tailEnd type="none" w="med" len="med"/>
-                    </a:lnB>
-                    <a:solidFill>
-                      <a:srgbClr val="FFFFFF"/>
-                    </a:solidFill>
-                  </a:tcPr>
-                </a:tc>
-                <a:tc>
-                  <a:txBody>
-                    <a:bodyPr/>
-                    <a:lstStyle/>
-                    <a:p>
-                      <a:pPr indent="0" marL="0">
-                        <a:buNone/>
-                      </a:pPr>
-                      <a:r>
-                        <a:rPr lang="en-US" sz="1000" dirty="0">
-                          <a:solidFill>
-                            <a:srgbClr val="EF3124"/>
-                          </a:solidFill>
-                          <a:latin typeface="Arial" pitchFamily="34" charset="0"/>
-                          <a:ea typeface="Arial" pitchFamily="34" charset="-122"/>
-                          <a:cs typeface="Arial" pitchFamily="34" charset="-120"/>
-                        </a:rPr>
-                        <a:t>−5,5</a:t>
-                      </a:r>
-                      <a:endParaRPr lang="en-US" sz="1000" dirty="0">
-                        <a:latin typeface="Arial" charset="0"/>
-                        <a:ea typeface="Arial" charset="0"/>
-                        <a:cs typeface="Arial" charset="0"/>
-                      </a:endParaRPr>
-                    </a:p>
-                  </a:txBody>
-                  <a:tcPr marL="63500" marR="63500" marT="63500" marB="63500" anchor="ctr">
-                    <a:lnL w="6350" cap="flat" cmpd="sng" algn="ctr">
-                      <a:solidFill>
-                        <a:srgbClr val="DCDCDC"/>
-                      </a:solidFill>
-                      <a:prstDash val="solid"/>
-                      <a:round/>
-                      <a:headEnd type="none" w="med" len="med"/>
-                      <a:tailEnd type="none" w="med" len="med"/>
-                    </a:lnL>
-                    <a:lnR w="6350" cap="flat" cmpd="sng" algn="ctr">
-                      <a:solidFill>
-                        <a:srgbClr val="DCDCDC"/>
-                      </a:solidFill>
-                      <a:prstDash val="solid"/>
-                      <a:round/>
-                      <a:headEnd type="none" w="med" len="med"/>
-                      <a:tailEnd type="none" w="med" len="med"/>
-                    </a:lnR>
-                    <a:lnT w="6350" cap="flat" cmpd="sng" algn="ctr">
-                      <a:solidFill>
-                        <a:srgbClr val="DCDCDC"/>
-                      </a:solidFill>
-                      <a:prstDash val="solid"/>
-                      <a:round/>
-                      <a:headEnd type="none" w="med" len="med"/>
-                      <a:tailEnd type="none" w="med" len="med"/>
-                    </a:lnT>
-                    <a:lnB w="6350" cap="flat" cmpd="sng" algn="ctr">
-                      <a:solidFill>
-                        <a:srgbClr val="DCDCDC"/>
-                      </a:solidFill>
-                      <a:prstDash val="solid"/>
-                      <a:round/>
-                      <a:headEnd type="none" w="med" len="med"/>
-                      <a:tailEnd type="none" w="med" len="med"/>
-                    </a:lnB>
-                    <a:solidFill>
-                      <a:srgbClr val="FFFFFF"/>
-                    </a:solidFill>
-                  </a:tcPr>
-                </a:tc>
-                <a:tc>
-                  <a:txBody>
-                    <a:bodyPr/>
-                    <a:lstStyle/>
-                    <a:p>
-                      <a:pPr indent="0" marL="0">
-                        <a:buNone/>
-                      </a:pPr>
-                      <a:r>
-                        <a:rPr lang="en-US" sz="1000" dirty="0">
-                          <a:solidFill>
-                            <a:srgbClr val="222222"/>
-                          </a:solidFill>
-                          <a:latin typeface="Arial" pitchFamily="34" charset="0"/>
-                          <a:ea typeface="Arial" pitchFamily="34" charset="-122"/>
-                          <a:cs typeface="Arial" pitchFamily="34" charset="-120"/>
-                        </a:rPr>
-                        <a:t>0,38</a:t>
-                      </a:r>
-                      <a:endParaRPr lang="en-US" sz="1000" dirty="0">
-                        <a:latin typeface="Arial" charset="0"/>
-                        <a:ea typeface="Arial" charset="0"/>
-                        <a:cs typeface="Arial" charset="0"/>
-                      </a:endParaRPr>
-                    </a:p>
-                  </a:txBody>
-                  <a:tcPr marL="63500" marR="63500" marT="63500" marB="63500" anchor="ctr">
-                    <a:lnL w="6350" cap="flat" cmpd="sng" algn="ctr">
-                      <a:solidFill>
-                        <a:srgbClr val="DCDCDC"/>
-                      </a:solidFill>
-                      <a:prstDash val="solid"/>
-                      <a:round/>
-                      <a:headEnd type="none" w="med" len="med"/>
-                      <a:tailEnd type="none" w="med" len="med"/>
-                    </a:lnL>
-                    <a:lnR w="6350" cap="flat" cmpd="sng" algn="ctr">
-                      <a:solidFill>
-                        <a:srgbClr val="DCDCDC"/>
-                      </a:solidFill>
-                      <a:prstDash val="solid"/>
-                      <a:round/>
-                      <a:headEnd type="none" w="med" len="med"/>
-                      <a:tailEnd type="none" w="med" len="med"/>
-                    </a:lnR>
-                    <a:lnT w="6350" cap="flat" cmpd="sng" algn="ctr">
-                      <a:solidFill>
-                        <a:srgbClr val="DCDCDC"/>
-                      </a:solidFill>
-                      <a:prstDash val="solid"/>
-                      <a:round/>
-                      <a:headEnd type="none" w="med" len="med"/>
-                      <a:tailEnd type="none" w="med" len="med"/>
-                    </a:lnT>
-                    <a:lnB w="6350" cap="flat" cmpd="sng" algn="ctr">
-                      <a:solidFill>
-                        <a:srgbClr val="DCDCDC"/>
-                      </a:solidFill>
-                      <a:prstDash val="solid"/>
-                      <a:round/>
-                      <a:headEnd type="none" w="med" len="med"/>
-                      <a:tailEnd type="none" w="med" len="med"/>
-                    </a:lnB>
-                    <a:solidFill>
-                      <a:srgbClr val="FFFFFF"/>
-                    </a:solidFill>
-                  </a:tcPr>
-                </a:tc>
-              </a:tr>
-              <a:tr h="274320">
-                <a:tc>
-                  <a:txBody>
-                    <a:bodyPr/>
-                    <a:lstStyle/>
-                    <a:p>
-                      <a:pPr indent="0" marL="0">
-                        <a:buNone/>
-                      </a:pPr>
-                      <a:r>
-                        <a:rPr lang="en-US" sz="1000" dirty="0">
-                          <a:solidFill>
-                            <a:srgbClr val="222222"/>
-                          </a:solidFill>
-                          <a:latin typeface="Arial" pitchFamily="34" charset="0"/>
-                          <a:ea typeface="Arial" pitchFamily="34" charset="-122"/>
-                          <a:cs typeface="Arial" pitchFamily="34" charset="-120"/>
-                        </a:rPr>
-                        <a:t>Моментум из ТЗ</a:t>
-                      </a:r>
-                      <a:endParaRPr lang="en-US" sz="1000" dirty="0">
-                        <a:latin typeface="Arial" charset="0"/>
-                        <a:ea typeface="Arial" charset="0"/>
-                        <a:cs typeface="Arial" charset="0"/>
-                      </a:endParaRPr>
-                    </a:p>
-                  </a:txBody>
-                  <a:tcPr marL="63500" marR="63500" marT="63500" marB="63500" anchor="ctr">
-                    <a:lnL w="6350" cap="flat" cmpd="sng" algn="ctr">
-                      <a:solidFill>
-                        <a:srgbClr val="DCDCDC"/>
-                      </a:solidFill>
-                      <a:prstDash val="solid"/>
-                      <a:round/>
-                      <a:headEnd type="none" w="med" len="med"/>
-                      <a:tailEnd type="none" w="med" len="med"/>
-                    </a:lnL>
-                    <a:lnR w="6350" cap="flat" cmpd="sng" algn="ctr">
-                      <a:solidFill>
-                        <a:srgbClr val="DCDCDC"/>
-                      </a:solidFill>
-                      <a:prstDash val="solid"/>
-                      <a:round/>
-                      <a:headEnd type="none" w="med" len="med"/>
-                      <a:tailEnd type="none" w="med" len="med"/>
-                    </a:lnR>
-                    <a:lnT w="6350" cap="flat" cmpd="sng" algn="ctr">
-                      <a:solidFill>
-                        <a:srgbClr val="DCDCDC"/>
-                      </a:solidFill>
-                      <a:prstDash val="solid"/>
-                      <a:round/>
-                      <a:headEnd type="none" w="med" len="med"/>
-                      <a:tailEnd type="none" w="med" len="med"/>
-                    </a:lnT>
-                    <a:lnB w="6350" cap="flat" cmpd="sng" algn="ctr">
-                      <a:solidFill>
-                        <a:srgbClr val="DCDCDC"/>
-                      </a:solidFill>
-                      <a:prstDash val="solid"/>
-                      <a:round/>
-                      <a:headEnd type="none" w="med" len="med"/>
-                      <a:tailEnd type="none" w="med" len="med"/>
-                    </a:lnB>
-                    <a:solidFill>
-                      <a:srgbClr val="FFFFFF"/>
-                    </a:solidFill>
-                  </a:tcPr>
-                </a:tc>
-                <a:tc>
-                  <a:txBody>
-                    <a:bodyPr/>
-                    <a:lstStyle/>
-                    <a:p>
-                      <a:pPr indent="0" marL="0">
-                        <a:buNone/>
-                      </a:pPr>
-                      <a:r>
-                        <a:rPr lang="en-US" sz="1000" dirty="0">
-                          <a:solidFill>
-                            <a:srgbClr val="222222"/>
-                          </a:solidFill>
-                          <a:latin typeface="Arial" pitchFamily="34" charset="0"/>
-                          <a:ea typeface="Arial" pitchFamily="34" charset="-122"/>
-                          <a:cs typeface="Arial" pitchFamily="34" charset="-120"/>
-                        </a:rPr>
-                        <a:t>favorable</a:t>
-                      </a:r>
-                      <a:endParaRPr lang="en-US" sz="1000" dirty="0">
-                        <a:latin typeface="Arial" charset="0"/>
-                        <a:ea typeface="Arial" charset="0"/>
-                        <a:cs typeface="Arial" charset="0"/>
-                      </a:endParaRPr>
-                    </a:p>
-                  </a:txBody>
-                  <a:tcPr marL="63500" marR="63500" marT="63500" marB="63500" anchor="ctr">
-                    <a:lnL w="6350" cap="flat" cmpd="sng" algn="ctr">
-                      <a:solidFill>
-                        <a:srgbClr val="DCDCDC"/>
-                      </a:solidFill>
-                      <a:prstDash val="solid"/>
-                      <a:round/>
-                      <a:headEnd type="none" w="med" len="med"/>
-                      <a:tailEnd type="none" w="med" len="med"/>
-                    </a:lnL>
-                    <a:lnR w="6350" cap="flat" cmpd="sng" algn="ctr">
-                      <a:solidFill>
-                        <a:srgbClr val="DCDCDC"/>
-                      </a:solidFill>
-                      <a:prstDash val="solid"/>
-                      <a:round/>
-                      <a:headEnd type="none" w="med" len="med"/>
-                      <a:tailEnd type="none" w="med" len="med"/>
-                    </a:lnR>
-                    <a:lnT w="6350" cap="flat" cmpd="sng" algn="ctr">
-                      <a:solidFill>
-                        <a:srgbClr val="DCDCDC"/>
-                      </a:solidFill>
-                      <a:prstDash val="solid"/>
-                      <a:round/>
-                      <a:headEnd type="none" w="med" len="med"/>
-                      <a:tailEnd type="none" w="med" len="med"/>
-                    </a:lnT>
-                    <a:lnB w="6350" cap="flat" cmpd="sng" algn="ctr">
-                      <a:solidFill>
-                        <a:srgbClr val="DCDCDC"/>
-                      </a:solidFill>
-                      <a:prstDash val="solid"/>
-                      <a:round/>
-                      <a:headEnd type="none" w="med" len="med"/>
-                      <a:tailEnd type="none" w="med" len="med"/>
-                    </a:lnB>
-                    <a:solidFill>
-                      <a:srgbClr val="FFFFFF"/>
-                    </a:solidFill>
-                  </a:tcPr>
-                </a:tc>
-                <a:tc>
-                  <a:txBody>
-                    <a:bodyPr/>
-                    <a:lstStyle/>
-                    <a:p>
-                      <a:pPr indent="0" marL="0">
-                        <a:buNone/>
-                      </a:pPr>
-                      <a:r>
-                        <a:rPr lang="en-US" sz="1000" dirty="0">
-                          <a:solidFill>
-                            <a:srgbClr val="EF3124"/>
-                          </a:solidFill>
-                          <a:latin typeface="Arial" pitchFamily="34" charset="0"/>
-                          <a:ea typeface="Arial" pitchFamily="34" charset="-122"/>
-                          <a:cs typeface="Arial" pitchFamily="34" charset="-120"/>
-                        </a:rPr>
-                        <a:t>0,69–1,05</a:t>
-                      </a:r>
-                      <a:endParaRPr lang="en-US" sz="1000" dirty="0">
-                        <a:latin typeface="Arial" charset="0"/>
-                        <a:ea typeface="Arial" charset="0"/>
-                        <a:cs typeface="Arial" charset="0"/>
-                      </a:endParaRPr>
-                    </a:p>
-                  </a:txBody>
-                  <a:tcPr marL="63500" marR="63500" marT="63500" marB="63500" anchor="ctr">
-                    <a:lnL w="6350" cap="flat" cmpd="sng" algn="ctr">
-                      <a:solidFill>
-                        <a:srgbClr val="DCDCDC"/>
-                      </a:solidFill>
-                      <a:prstDash val="solid"/>
-                      <a:round/>
-                      <a:headEnd type="none" w="med" len="med"/>
-                      <a:tailEnd type="none" w="med" len="med"/>
-                    </a:lnL>
-                    <a:lnR w="6350" cap="flat" cmpd="sng" algn="ctr">
-                      <a:solidFill>
-                        <a:srgbClr val="DCDCDC"/>
-                      </a:solidFill>
-                      <a:prstDash val="solid"/>
-                      <a:round/>
-                      <a:headEnd type="none" w="med" len="med"/>
-                      <a:tailEnd type="none" w="med" len="med"/>
-                    </a:lnR>
-                    <a:lnT w="6350" cap="flat" cmpd="sng" algn="ctr">
-                      <a:solidFill>
-                        <a:srgbClr val="DCDCDC"/>
-                      </a:solidFill>
-                      <a:prstDash val="solid"/>
-                      <a:round/>
-                      <a:headEnd type="none" w="med" len="med"/>
-                      <a:tailEnd type="none" w="med" len="med"/>
-                    </a:lnT>
-                    <a:lnB w="6350" cap="flat" cmpd="sng" algn="ctr">
-                      <a:solidFill>
-                        <a:srgbClr val="DCDCDC"/>
-                      </a:solidFill>
-                      <a:prstDash val="solid"/>
-                      <a:round/>
-                      <a:headEnd type="none" w="med" len="med"/>
-                      <a:tailEnd type="none" w="med" len="med"/>
-                    </a:lnB>
-                    <a:solidFill>
-                      <a:srgbClr val="FFFFFF"/>
-                    </a:solidFill>
-                  </a:tcPr>
-                </a:tc>
-                <a:tc>
-                  <a:txBody>
-                    <a:bodyPr/>
-                    <a:lstStyle/>
-                    <a:p>
-                      <a:pPr indent="0" marL="0">
-                        <a:buNone/>
-                      </a:pPr>
-                      <a:r>
-                        <a:rPr lang="en-US" sz="1000" dirty="0">
-                          <a:solidFill>
-                            <a:srgbClr val="EF3124"/>
-                          </a:solidFill>
-                          <a:latin typeface="Arial" pitchFamily="34" charset="0"/>
-                          <a:ea typeface="Arial" pitchFamily="34" charset="-122"/>
-                          <a:cs typeface="Arial" pitchFamily="34" charset="-120"/>
-                        </a:rPr>
-                        <a:t>отрицат.</a:t>
-                      </a:r>
-                      <a:endParaRPr lang="en-US" sz="1000" dirty="0">
-                        <a:latin typeface="Arial" charset="0"/>
-                        <a:ea typeface="Arial" charset="0"/>
-                        <a:cs typeface="Arial" charset="0"/>
-                      </a:endParaRPr>
-                    </a:p>
-                  </a:txBody>
-                  <a:tcPr marL="63500" marR="63500" marT="63500" marB="63500" anchor="ctr">
-                    <a:lnL w="6350" cap="flat" cmpd="sng" algn="ctr">
-                      <a:solidFill>
-                        <a:srgbClr val="DCDCDC"/>
-                      </a:solidFill>
-                      <a:prstDash val="solid"/>
-                      <a:round/>
-                      <a:headEnd type="none" w="med" len="med"/>
-                      <a:tailEnd type="none" w="med" len="med"/>
-                    </a:lnL>
-                    <a:lnR w="6350" cap="flat" cmpd="sng" algn="ctr">
-                      <a:solidFill>
-                        <a:srgbClr val="DCDCDC"/>
-                      </a:solidFill>
-                      <a:prstDash val="solid"/>
-                      <a:round/>
-                      <a:headEnd type="none" w="med" len="med"/>
-                      <a:tailEnd type="none" w="med" len="med"/>
-                    </a:lnR>
-                    <a:lnT w="6350" cap="flat" cmpd="sng" algn="ctr">
-                      <a:solidFill>
-                        <a:srgbClr val="DCDCDC"/>
-                      </a:solidFill>
-                      <a:prstDash val="solid"/>
-                      <a:round/>
-                      <a:headEnd type="none" w="med" len="med"/>
-                      <a:tailEnd type="none" w="med" len="med"/>
-                    </a:lnT>
-                    <a:lnB w="6350" cap="flat" cmpd="sng" algn="ctr">
-                      <a:solidFill>
-                        <a:srgbClr val="DCDCDC"/>
-                      </a:solidFill>
-                      <a:prstDash val="solid"/>
-                      <a:round/>
-                      <a:headEnd type="none" w="med" len="med"/>
-                      <a:tailEnd type="none" w="med" len="med"/>
-                    </a:lnB>
-                    <a:solidFill>
-                      <a:srgbClr val="FFFFFF"/>
-                    </a:solidFill>
-                  </a:tcPr>
-                </a:tc>
-                <a:tc>
-                  <a:txBody>
-                    <a:bodyPr/>
-                    <a:lstStyle/>
-                    <a:p>
-                      <a:pPr indent="0" marL="0">
-                        <a:buNone/>
-                      </a:pPr>
-                      <a:r>
-                        <a:rPr lang="en-US" sz="1000" dirty="0">
-                          <a:solidFill>
-                            <a:srgbClr val="222222"/>
-                          </a:solidFill>
-                          <a:latin typeface="Arial" pitchFamily="34" charset="0"/>
-                          <a:ea typeface="Arial" pitchFamily="34" charset="-122"/>
-                          <a:cs typeface="Arial" pitchFamily="34" charset="-120"/>
-                        </a:rPr>
-                        <a:t>—</a:t>
-                      </a:r>
-                      <a:endParaRPr lang="en-US" sz="1000" dirty="0">
+                      <a:endParaRPr lang="en-US" sz="1050" dirty="0">
                         <a:latin typeface="Arial" charset="0"/>
                         <a:ea typeface="Arial" charset="0"/>
                         <a:cs typeface="Arial" charset="0"/>
@@ -15455,935 +14975,16 @@
         </p:nvSpPr>
         <p:spPr>
           <a:xfrm>
-            <a:off x="6199632" y="1207008"/>
-            <a:ext cx="2286000" cy="310896"/>
+            <a:off x="457200" y="3246120"/>
+            <a:ext cx="3593592" cy="1874520"/>
           </a:xfrm>
           <a:prstGeom prst="roundRect">
             <a:avLst>
-              <a:gd name="adj" fmla="val 50000"/>
+              <a:gd name="adj" fmla="val 6829"/>
             </a:avLst>
           </a:prstGeom>
           <a:solidFill>
-            <a:srgbClr val="111111"/>
-          </a:solidFill>
-          <a:ln/>
-        </p:spPr>
-      </p:sp>
-      <p:sp>
-        <p:nvSpPr>
-          <p:cNvPr id="10" name="Text 7"/>
-          <p:cNvSpPr txBox="1"/>
-          <p:nvPr/>
-        </p:nvSpPr>
-        <p:spPr>
-          <a:xfrm>
-            <a:off x="6199632" y="1207008"/>
-            <a:ext cx="2286000" cy="310896"/>
-          </a:xfrm>
-          <a:prstGeom prst="rect">
-            <a:avLst/>
-          </a:prstGeom>
-          <a:noFill/>
-          <a:ln/>
-        </p:spPr>
-        <p:txBody>
-          <a:bodyPr wrap="square" lIns="0" tIns="0" rIns="0" bIns="0" rtlCol="0" anchor="ctr"/>
-          <a:lstStyle/>
-          <a:p>
-            <a:pPr algn="ctr" indent="0" marL="0">
-              <a:buNone/>
-            </a:pPr>
-            <a:r>
-              <a:rPr lang="en-US" sz="1150" b="1" dirty="0">
-                <a:solidFill>
-                  <a:srgbClr val="FFFFFF"/>
-                </a:solidFill>
-                <a:latin typeface="Arial" pitchFamily="34" charset="0"/>
-                <a:ea typeface="Arial" pitchFamily="34" charset="-122"/>
-                <a:cs typeface="Arial" pitchFamily="34" charset="-120"/>
-              </a:rPr>
-              <a:t>ML-ВЕТКА</a:t>
-            </a:r>
-            <a:endParaRPr lang="en-US" sz="1150" dirty="0"/>
-          </a:p>
-        </p:txBody>
-      </p:sp>
-      <p:graphicFrame>
-        <p:nvGraphicFramePr>
-          <p:cNvPr id="17" name="Table 1"/>
-          <p:cNvGraphicFramePr>
-            <a:graphicFrameLocks noGrp="1"/>
-          </p:cNvGraphicFramePr>
-          <p:nvPr>
-            <p:extLst>
-              <p:ext uri="{D42A27DB-BD31-4B8C-83A1-F6EECF244321}">
-                <p14:modId xmlns:p14="http://schemas.microsoft.com/office/powerpoint/2010/main" val="1579011935"/>
-              </p:ext>
-            </p:extLst>
-          </p:nvPr>
-        </p:nvGraphicFramePr>
-        <p:xfrm>
-          <a:off x="6199632" y="1609344"/>
-          <a:ext cx="5532120" cy="914400"/>
-        </p:xfrm>
-        <a:graphic>
-          <a:graphicData uri="http://schemas.openxmlformats.org/drawingml/2006/table">
-            <a:tbl>
-              <a:tblPr/>
-              <a:tblGrid>
-                <a:gridCol w="2148840"/>
-                <a:gridCol w="3383280"/>
-              </a:tblGrid>
-              <a:tr h="274320">
-                <a:tc>
-                  <a:txBody>
-                    <a:bodyPr/>
-                    <a:lstStyle/>
-                    <a:p>
-                      <a:pPr indent="0" marL="0">
-                        <a:buNone/>
-                      </a:pPr>
-                      <a:r>
-                        <a:rPr lang="en-US" sz="1000" b="1" dirty="0">
-                          <a:solidFill>
-                            <a:srgbClr val="FFFFFF"/>
-                          </a:solidFill>
-                          <a:latin typeface="Arial" pitchFamily="34" charset="0"/>
-                          <a:ea typeface="Arial" pitchFamily="34" charset="-122"/>
-                          <a:cs typeface="Arial" pitchFamily="34" charset="-120"/>
-                        </a:rPr>
-                        <a:t>Что проверяли</a:t>
-                      </a:r>
-                      <a:endParaRPr lang="en-US" sz="1000" dirty="0">
-                        <a:latin typeface="Arial" charset="0"/>
-                        <a:ea typeface="Arial" charset="0"/>
-                        <a:cs typeface="Arial" charset="0"/>
-                      </a:endParaRPr>
-                    </a:p>
-                  </a:txBody>
-                  <a:tcPr marL="63500" marR="63500" marT="63500" marB="63500" anchor="ctr">
-                    <a:lnL w="6350" cap="flat" cmpd="sng" algn="ctr">
-                      <a:solidFill>
-                        <a:srgbClr val="DCDCDC"/>
-                      </a:solidFill>
-                      <a:prstDash val="solid"/>
-                      <a:round/>
-                      <a:headEnd type="none" w="med" len="med"/>
-                      <a:tailEnd type="none" w="med" len="med"/>
-                    </a:lnL>
-                    <a:lnR w="6350" cap="flat" cmpd="sng" algn="ctr">
-                      <a:solidFill>
-                        <a:srgbClr val="DCDCDC"/>
-                      </a:solidFill>
-                      <a:prstDash val="solid"/>
-                      <a:round/>
-                      <a:headEnd type="none" w="med" len="med"/>
-                      <a:tailEnd type="none" w="med" len="med"/>
-                    </a:lnR>
-                    <a:lnT w="6350" cap="flat" cmpd="sng" algn="ctr">
-                      <a:solidFill>
-                        <a:srgbClr val="DCDCDC"/>
-                      </a:solidFill>
-                      <a:prstDash val="solid"/>
-                      <a:round/>
-                      <a:headEnd type="none" w="med" len="med"/>
-                      <a:tailEnd type="none" w="med" len="med"/>
-                    </a:lnT>
-                    <a:lnB w="6350" cap="flat" cmpd="sng" algn="ctr">
-                      <a:solidFill>
-                        <a:srgbClr val="DCDCDC"/>
-                      </a:solidFill>
-                      <a:prstDash val="solid"/>
-                      <a:round/>
-                      <a:headEnd type="none" w="med" len="med"/>
-                      <a:tailEnd type="none" w="med" len="med"/>
-                    </a:lnB>
-                    <a:solidFill>
-                      <a:srgbClr val="111111"/>
-                    </a:solidFill>
-                  </a:tcPr>
-                </a:tc>
-                <a:tc>
-                  <a:txBody>
-                    <a:bodyPr/>
-                    <a:lstStyle/>
-                    <a:p>
-                      <a:pPr indent="0" marL="0">
-                        <a:buNone/>
-                      </a:pPr>
-                      <a:r>
-                        <a:rPr lang="en-US" sz="1000" b="1" dirty="0">
-                          <a:solidFill>
-                            <a:srgbClr val="FFFFFF"/>
-                          </a:solidFill>
-                          <a:latin typeface="Arial" pitchFamily="34" charset="0"/>
-                          <a:ea typeface="Arial" pitchFamily="34" charset="-122"/>
-                          <a:cs typeface="Arial" pitchFamily="34" charset="-120"/>
-                        </a:rPr>
-                        <a:t>Результат</a:t>
-                      </a:r>
-                      <a:endParaRPr lang="en-US" sz="1000" dirty="0">
-                        <a:latin typeface="Arial" charset="0"/>
-                        <a:ea typeface="Arial" charset="0"/>
-                        <a:cs typeface="Arial" charset="0"/>
-                      </a:endParaRPr>
-                    </a:p>
-                  </a:txBody>
-                  <a:tcPr marL="63500" marR="63500" marT="63500" marB="63500" anchor="ctr">
-                    <a:lnL w="6350" cap="flat" cmpd="sng" algn="ctr">
-                      <a:solidFill>
-                        <a:srgbClr val="DCDCDC"/>
-                      </a:solidFill>
-                      <a:prstDash val="solid"/>
-                      <a:round/>
-                      <a:headEnd type="none" w="med" len="med"/>
-                      <a:tailEnd type="none" w="med" len="med"/>
-                    </a:lnL>
-                    <a:lnR w="6350" cap="flat" cmpd="sng" algn="ctr">
-                      <a:solidFill>
-                        <a:srgbClr val="DCDCDC"/>
-                      </a:solidFill>
-                      <a:prstDash val="solid"/>
-                      <a:round/>
-                      <a:headEnd type="none" w="med" len="med"/>
-                      <a:tailEnd type="none" w="med" len="med"/>
-                    </a:lnR>
-                    <a:lnT w="6350" cap="flat" cmpd="sng" algn="ctr">
-                      <a:solidFill>
-                        <a:srgbClr val="DCDCDC"/>
-                      </a:solidFill>
-                      <a:prstDash val="solid"/>
-                      <a:round/>
-                      <a:headEnd type="none" w="med" len="med"/>
-                      <a:tailEnd type="none" w="med" len="med"/>
-                    </a:lnT>
-                    <a:lnB w="6350" cap="flat" cmpd="sng" algn="ctr">
-                      <a:solidFill>
-                        <a:srgbClr val="DCDCDC"/>
-                      </a:solidFill>
-                      <a:prstDash val="solid"/>
-                      <a:round/>
-                      <a:headEnd type="none" w="med" len="med"/>
-                      <a:tailEnd type="none" w="med" len="med"/>
-                    </a:lnB>
-                    <a:solidFill>
-                      <a:srgbClr val="111111"/>
-                    </a:solidFill>
-                  </a:tcPr>
-                </a:tc>
-              </a:tr>
-              <a:tr h="274320">
-                <a:tc>
-                  <a:txBody>
-                    <a:bodyPr/>
-                    <a:lstStyle/>
-                    <a:p>
-                      <a:pPr indent="0" marL="0">
-                        <a:buNone/>
-                      </a:pPr>
-                      <a:r>
-                        <a:rPr lang="en-US" sz="1000" dirty="0">
-                          <a:solidFill>
-                            <a:srgbClr val="222222"/>
-                          </a:solidFill>
-                          <a:latin typeface="Arial" pitchFamily="34" charset="0"/>
-                          <a:ea typeface="Arial" pitchFamily="34" charset="-122"/>
-                          <a:cs typeface="Arial" pitchFamily="34" charset="-120"/>
-                        </a:rPr>
-                        <a:t>Точный минимум 1/5/20 сессий</a:t>
-                      </a:r>
-                      <a:endParaRPr lang="en-US" sz="1000" dirty="0">
-                        <a:latin typeface="Arial" charset="0"/>
-                        <a:ea typeface="Arial" charset="0"/>
-                        <a:cs typeface="Arial" charset="0"/>
-                      </a:endParaRPr>
-                    </a:p>
-                  </a:txBody>
-                  <a:tcPr marL="63500" marR="63500" marT="63500" marB="63500" anchor="ctr">
-                    <a:lnL w="6350" cap="flat" cmpd="sng" algn="ctr">
-                      <a:solidFill>
-                        <a:srgbClr val="DCDCDC"/>
-                      </a:solidFill>
-                      <a:prstDash val="solid"/>
-                      <a:round/>
-                      <a:headEnd type="none" w="med" len="med"/>
-                      <a:tailEnd type="none" w="med" len="med"/>
-                    </a:lnL>
-                    <a:lnR w="6350" cap="flat" cmpd="sng" algn="ctr">
-                      <a:solidFill>
-                        <a:srgbClr val="DCDCDC"/>
-                      </a:solidFill>
-                      <a:prstDash val="solid"/>
-                      <a:round/>
-                      <a:headEnd type="none" w="med" len="med"/>
-                      <a:tailEnd type="none" w="med" len="med"/>
-                    </a:lnR>
-                    <a:lnT w="6350" cap="flat" cmpd="sng" algn="ctr">
-                      <a:solidFill>
-                        <a:srgbClr val="DCDCDC"/>
-                      </a:solidFill>
-                      <a:prstDash val="solid"/>
-                      <a:round/>
-                      <a:headEnd type="none" w="med" len="med"/>
-                      <a:tailEnd type="none" w="med" len="med"/>
-                    </a:lnT>
-                    <a:lnB w="6350" cap="flat" cmpd="sng" algn="ctr">
-                      <a:solidFill>
-                        <a:srgbClr val="DCDCDC"/>
-                      </a:solidFill>
-                      <a:prstDash val="solid"/>
-                      <a:round/>
-                      <a:headEnd type="none" w="med" len="med"/>
-                      <a:tailEnd type="none" w="med" len="med"/>
-                    </a:lnB>
-                    <a:solidFill>
-                      <a:srgbClr val="FFFFFF"/>
-                    </a:solidFill>
-                  </a:tcPr>
-                </a:tc>
-                <a:tc>
-                  <a:txBody>
-                    <a:bodyPr/>
-                    <a:lstStyle/>
-                    <a:p>
-                      <a:pPr indent="0" marL="0">
-                        <a:buNone/>
-                      </a:pPr>
-                      <a:r>
-                        <a:rPr lang="en-US" sz="1000" dirty="0">
-                          <a:solidFill>
-                            <a:srgbClr val="222222"/>
-                          </a:solidFill>
-                          <a:latin typeface="Arial" pitchFamily="34" charset="0"/>
-                          <a:ea typeface="Arial" pitchFamily="34" charset="-122"/>
-                          <a:cs typeface="Arial" pitchFamily="34" charset="-120"/>
-                        </a:rPr>
-                        <a:t>lift 1,20 / 1,15 / 1,10 — метка не различает ошибку 1 и 100 бп</a:t>
-                      </a:r>
-                      <a:endParaRPr lang="en-US" sz="1000" dirty="0">
-                        <a:latin typeface="Arial" charset="0"/>
-                        <a:ea typeface="Arial" charset="0"/>
-                        <a:cs typeface="Arial" charset="0"/>
-                      </a:endParaRPr>
-                    </a:p>
-                  </a:txBody>
-                  <a:tcPr marL="63500" marR="63500" marT="63500" marB="63500" anchor="ctr">
-                    <a:lnL w="6350" cap="flat" cmpd="sng" algn="ctr">
-                      <a:solidFill>
-                        <a:srgbClr val="DCDCDC"/>
-                      </a:solidFill>
-                      <a:prstDash val="solid"/>
-                      <a:round/>
-                      <a:headEnd type="none" w="med" len="med"/>
-                      <a:tailEnd type="none" w="med" len="med"/>
-                    </a:lnL>
-                    <a:lnR w="6350" cap="flat" cmpd="sng" algn="ctr">
-                      <a:solidFill>
-                        <a:srgbClr val="DCDCDC"/>
-                      </a:solidFill>
-                      <a:prstDash val="solid"/>
-                      <a:round/>
-                      <a:headEnd type="none" w="med" len="med"/>
-                      <a:tailEnd type="none" w="med" len="med"/>
-                    </a:lnR>
-                    <a:lnT w="6350" cap="flat" cmpd="sng" algn="ctr">
-                      <a:solidFill>
-                        <a:srgbClr val="DCDCDC"/>
-                      </a:solidFill>
-                      <a:prstDash val="solid"/>
-                      <a:round/>
-                      <a:headEnd type="none" w="med" len="med"/>
-                      <a:tailEnd type="none" w="med" len="med"/>
-                    </a:lnT>
-                    <a:lnB w="6350" cap="flat" cmpd="sng" algn="ctr">
-                      <a:solidFill>
-                        <a:srgbClr val="DCDCDC"/>
-                      </a:solidFill>
-                      <a:prstDash val="solid"/>
-                      <a:round/>
-                      <a:headEnd type="none" w="med" len="med"/>
-                      <a:tailEnd type="none" w="med" len="med"/>
-                    </a:lnB>
-                    <a:solidFill>
-                      <a:srgbClr val="FFFFFF"/>
-                    </a:solidFill>
-                  </a:tcPr>
-                </a:tc>
-              </a:tr>
-              <a:tr h="274320">
-                <a:tc>
-                  <a:txBody>
-                    <a:bodyPr/>
-                    <a:lstStyle/>
-                    <a:p>
-                      <a:pPr indent="0" marL="0">
-                        <a:buNone/>
-                      </a:pPr>
-                      <a:r>
-                        <a:rPr lang="en-US" sz="1000" dirty="0">
-                          <a:solidFill>
-                            <a:srgbClr val="222222"/>
-                          </a:solidFill>
-                          <a:latin typeface="Arial" pitchFamily="34" charset="0"/>
-                          <a:ea typeface="Arial" pitchFamily="34" charset="-122"/>
-                          <a:cs typeface="Arial" pitchFamily="34" charset="-120"/>
-                        </a:rPr>
-                        <a:t>Regret на 5 сессий</a:t>
-                      </a:r>
-                      <a:endParaRPr lang="en-US" sz="1000" dirty="0">
-                        <a:latin typeface="Arial" charset="0"/>
-                        <a:ea typeface="Arial" charset="0"/>
-                        <a:cs typeface="Arial" charset="0"/>
-                      </a:endParaRPr>
-                    </a:p>
-                  </a:txBody>
-                  <a:tcPr marL="63500" marR="63500" marT="63500" marB="63500" anchor="ctr">
-                    <a:lnL w="6350" cap="flat" cmpd="sng" algn="ctr">
-                      <a:solidFill>
-                        <a:srgbClr val="DCDCDC"/>
-                      </a:solidFill>
-                      <a:prstDash val="solid"/>
-                      <a:round/>
-                      <a:headEnd type="none" w="med" len="med"/>
-                      <a:tailEnd type="none" w="med" len="med"/>
-                    </a:lnL>
-                    <a:lnR w="6350" cap="flat" cmpd="sng" algn="ctr">
-                      <a:solidFill>
-                        <a:srgbClr val="DCDCDC"/>
-                      </a:solidFill>
-                      <a:prstDash val="solid"/>
-                      <a:round/>
-                      <a:headEnd type="none" w="med" len="med"/>
-                      <a:tailEnd type="none" w="med" len="med"/>
-                    </a:lnR>
-                    <a:lnT w="6350" cap="flat" cmpd="sng" algn="ctr">
-                      <a:solidFill>
-                        <a:srgbClr val="DCDCDC"/>
-                      </a:solidFill>
-                      <a:prstDash val="solid"/>
-                      <a:round/>
-                      <a:headEnd type="none" w="med" len="med"/>
-                      <a:tailEnd type="none" w="med" len="med"/>
-                    </a:lnT>
-                    <a:lnB w="6350" cap="flat" cmpd="sng" algn="ctr">
-                      <a:solidFill>
-                        <a:srgbClr val="DCDCDC"/>
-                      </a:solidFill>
-                      <a:prstDash val="solid"/>
-                      <a:round/>
-                      <a:headEnd type="none" w="med" len="med"/>
-                      <a:tailEnd type="none" w="med" len="med"/>
-                    </a:lnB>
-                    <a:solidFill>
-                      <a:srgbClr val="FFFFFF"/>
-                    </a:solidFill>
-                  </a:tcPr>
-                </a:tc>
-                <a:tc>
-                  <a:txBody>
-                    <a:bodyPr/>
-                    <a:lstStyle/>
-                    <a:p>
-                      <a:pPr indent="0" marL="0">
-                        <a:buNone/>
-                      </a:pPr>
-                      <a:r>
-                        <a:rPr lang="en-US" sz="1000" dirty="0">
-                          <a:solidFill>
-                            <a:srgbClr val="222222"/>
-                          </a:solidFill>
-                          <a:latin typeface="Arial" pitchFamily="34" charset="0"/>
-                          <a:ea typeface="Arial" pitchFamily="34" charset="-122"/>
-                          <a:cs typeface="Arial" pitchFamily="34" charset="-120"/>
-                        </a:rPr>
-                        <a:t>lift 1,08–1,18, все bootstrap-интервалы пересекают 1</a:t>
-                      </a:r>
-                      <a:endParaRPr lang="en-US" sz="1000" dirty="0">
-                        <a:latin typeface="Arial" charset="0"/>
-                        <a:ea typeface="Arial" charset="0"/>
-                        <a:cs typeface="Arial" charset="0"/>
-                      </a:endParaRPr>
-                    </a:p>
-                  </a:txBody>
-                  <a:tcPr marL="63500" marR="63500" marT="63500" marB="63500" anchor="ctr">
-                    <a:lnL w="6350" cap="flat" cmpd="sng" algn="ctr">
-                      <a:solidFill>
-                        <a:srgbClr val="DCDCDC"/>
-                      </a:solidFill>
-                      <a:prstDash val="solid"/>
-                      <a:round/>
-                      <a:headEnd type="none" w="med" len="med"/>
-                      <a:tailEnd type="none" w="med" len="med"/>
-                    </a:lnL>
-                    <a:lnR w="6350" cap="flat" cmpd="sng" algn="ctr">
-                      <a:solidFill>
-                        <a:srgbClr val="DCDCDC"/>
-                      </a:solidFill>
-                      <a:prstDash val="solid"/>
-                      <a:round/>
-                      <a:headEnd type="none" w="med" len="med"/>
-                      <a:tailEnd type="none" w="med" len="med"/>
-                    </a:lnR>
-                    <a:lnT w="6350" cap="flat" cmpd="sng" algn="ctr">
-                      <a:solidFill>
-                        <a:srgbClr val="DCDCDC"/>
-                      </a:solidFill>
-                      <a:prstDash val="solid"/>
-                      <a:round/>
-                      <a:headEnd type="none" w="med" len="med"/>
-                      <a:tailEnd type="none" w="med" len="med"/>
-                    </a:lnT>
-                    <a:lnB w="6350" cap="flat" cmpd="sng" algn="ctr">
-                      <a:solidFill>
-                        <a:srgbClr val="DCDCDC"/>
-                      </a:solidFill>
-                      <a:prstDash val="solid"/>
-                      <a:round/>
-                      <a:headEnd type="none" w="med" len="med"/>
-                      <a:tailEnd type="none" w="med" len="med"/>
-                    </a:lnB>
-                    <a:solidFill>
-                      <a:srgbClr val="FFFFFF"/>
-                    </a:solidFill>
-                  </a:tcPr>
-                </a:tc>
-              </a:tr>
-              <a:tr h="274320">
-                <a:tc>
-                  <a:txBody>
-                    <a:bodyPr/>
-                    <a:lstStyle/>
-                    <a:p>
-                      <a:pPr indent="0" marL="0">
-                        <a:buNone/>
-                      </a:pPr>
-                      <a:r>
-                        <a:rPr lang="en-US" sz="1000" dirty="0">
-                          <a:solidFill>
-                            <a:srgbClr val="222222"/>
-                          </a:solidFill>
-                          <a:latin typeface="Arial" pitchFamily="34" charset="0"/>
-                          <a:ea typeface="Arial" pitchFamily="34" charset="-122"/>
-                          <a:cs typeface="Arial" pitchFamily="34" charset="-120"/>
-                        </a:rPr>
-                        <a:t>6 семейств классификаторов</a:t>
-                      </a:r>
-                      <a:endParaRPr lang="en-US" sz="1000" dirty="0">
-                        <a:latin typeface="Arial" charset="0"/>
-                        <a:ea typeface="Arial" charset="0"/>
-                        <a:cs typeface="Arial" charset="0"/>
-                      </a:endParaRPr>
-                    </a:p>
-                  </a:txBody>
-                  <a:tcPr marL="63500" marR="63500" marT="63500" marB="63500" anchor="ctr">
-                    <a:lnL w="6350" cap="flat" cmpd="sng" algn="ctr">
-                      <a:solidFill>
-                        <a:srgbClr val="DCDCDC"/>
-                      </a:solidFill>
-                      <a:prstDash val="solid"/>
-                      <a:round/>
-                      <a:headEnd type="none" w="med" len="med"/>
-                      <a:tailEnd type="none" w="med" len="med"/>
-                    </a:lnL>
-                    <a:lnR w="6350" cap="flat" cmpd="sng" algn="ctr">
-                      <a:solidFill>
-                        <a:srgbClr val="DCDCDC"/>
-                      </a:solidFill>
-                      <a:prstDash val="solid"/>
-                      <a:round/>
-                      <a:headEnd type="none" w="med" len="med"/>
-                      <a:tailEnd type="none" w="med" len="med"/>
-                    </a:lnR>
-                    <a:lnT w="6350" cap="flat" cmpd="sng" algn="ctr">
-                      <a:solidFill>
-                        <a:srgbClr val="DCDCDC"/>
-                      </a:solidFill>
-                      <a:prstDash val="solid"/>
-                      <a:round/>
-                      <a:headEnd type="none" w="med" len="med"/>
-                      <a:tailEnd type="none" w="med" len="med"/>
-                    </a:lnT>
-                    <a:lnB w="6350" cap="flat" cmpd="sng" algn="ctr">
-                      <a:solidFill>
-                        <a:srgbClr val="DCDCDC"/>
-                      </a:solidFill>
-                      <a:prstDash val="solid"/>
-                      <a:round/>
-                      <a:headEnd type="none" w="med" len="med"/>
-                      <a:tailEnd type="none" w="med" len="med"/>
-                    </a:lnB>
-                    <a:solidFill>
-                      <a:srgbClr val="FFFFFF"/>
-                    </a:solidFill>
-                  </a:tcPr>
-                </a:tc>
-                <a:tc>
-                  <a:txBody>
-                    <a:bodyPr/>
-                    <a:lstStyle/>
-                    <a:p>
-                      <a:pPr indent="0" marL="0">
-                        <a:buNone/>
-                      </a:pPr>
-                      <a:r>
-                        <a:rPr lang="en-US" sz="1000" dirty="0">
-                          <a:solidFill>
-                            <a:srgbClr val="222222"/>
-                          </a:solidFill>
-                          <a:latin typeface="Arial" pitchFamily="34" charset="0"/>
-                          <a:ea typeface="Arial" pitchFamily="34" charset="-122"/>
-                          <a:cs typeface="Arial" pitchFamily="34" charset="-120"/>
-                        </a:rPr>
-                        <a:t>устойчивого улучшения не дал ни один</a:t>
-                      </a:r>
-                      <a:endParaRPr lang="en-US" sz="1000" dirty="0">
-                        <a:latin typeface="Arial" charset="0"/>
-                        <a:ea typeface="Arial" charset="0"/>
-                        <a:cs typeface="Arial" charset="0"/>
-                      </a:endParaRPr>
-                    </a:p>
-                  </a:txBody>
-                  <a:tcPr marL="63500" marR="63500" marT="63500" marB="63500" anchor="ctr">
-                    <a:lnL w="6350" cap="flat" cmpd="sng" algn="ctr">
-                      <a:solidFill>
-                        <a:srgbClr val="DCDCDC"/>
-                      </a:solidFill>
-                      <a:prstDash val="solid"/>
-                      <a:round/>
-                      <a:headEnd type="none" w="med" len="med"/>
-                      <a:tailEnd type="none" w="med" len="med"/>
-                    </a:lnL>
-                    <a:lnR w="6350" cap="flat" cmpd="sng" algn="ctr">
-                      <a:solidFill>
-                        <a:srgbClr val="DCDCDC"/>
-                      </a:solidFill>
-                      <a:prstDash val="solid"/>
-                      <a:round/>
-                      <a:headEnd type="none" w="med" len="med"/>
-                      <a:tailEnd type="none" w="med" len="med"/>
-                    </a:lnR>
-                    <a:lnT w="6350" cap="flat" cmpd="sng" algn="ctr">
-                      <a:solidFill>
-                        <a:srgbClr val="DCDCDC"/>
-                      </a:solidFill>
-                      <a:prstDash val="solid"/>
-                      <a:round/>
-                      <a:headEnd type="none" w="med" len="med"/>
-                      <a:tailEnd type="none" w="med" len="med"/>
-                    </a:lnT>
-                    <a:lnB w="6350" cap="flat" cmpd="sng" algn="ctr">
-                      <a:solidFill>
-                        <a:srgbClr val="DCDCDC"/>
-                      </a:solidFill>
-                      <a:prstDash val="solid"/>
-                      <a:round/>
-                      <a:headEnd type="none" w="med" len="med"/>
-                      <a:tailEnd type="none" w="med" len="med"/>
-                    </a:lnB>
-                    <a:solidFill>
-                      <a:srgbClr val="FFFFFF"/>
-                    </a:solidFill>
-                  </a:tcPr>
-                </a:tc>
-              </a:tr>
-              <a:tr h="274320">
-                <a:tc>
-                  <a:txBody>
-                    <a:bodyPr/>
-                    <a:lstStyle/>
-                    <a:p>
-                      <a:pPr indent="0" marL="0">
-                        <a:buNone/>
-                      </a:pPr>
-                      <a:r>
-                        <a:rPr lang="en-US" sz="1000" dirty="0">
-                          <a:solidFill>
-                            <a:srgbClr val="222222"/>
-                          </a:solidFill>
-                          <a:latin typeface="Arial" pitchFamily="34" charset="0"/>
-                          <a:ea typeface="Arial" pitchFamily="34" charset="-122"/>
-                          <a:cs typeface="Arial" pitchFamily="34" charset="-120"/>
-                        </a:rPr>
-                        <a:t>Strict + regret, гибрид</a:t>
-                      </a:r>
-                      <a:endParaRPr lang="en-US" sz="1000" dirty="0">
-                        <a:latin typeface="Arial" charset="0"/>
-                        <a:ea typeface="Arial" charset="0"/>
-                        <a:cs typeface="Arial" charset="0"/>
-                      </a:endParaRPr>
-                    </a:p>
-                  </a:txBody>
-                  <a:tcPr marL="63500" marR="63500" marT="63500" marB="63500" anchor="ctr">
-                    <a:lnL w="6350" cap="flat" cmpd="sng" algn="ctr">
-                      <a:solidFill>
-                        <a:srgbClr val="DCDCDC"/>
-                      </a:solidFill>
-                      <a:prstDash val="solid"/>
-                      <a:round/>
-                      <a:headEnd type="none" w="med" len="med"/>
-                      <a:tailEnd type="none" w="med" len="med"/>
-                    </a:lnL>
-                    <a:lnR w="6350" cap="flat" cmpd="sng" algn="ctr">
-                      <a:solidFill>
-                        <a:srgbClr val="DCDCDC"/>
-                      </a:solidFill>
-                      <a:prstDash val="solid"/>
-                      <a:round/>
-                      <a:headEnd type="none" w="med" len="med"/>
-                      <a:tailEnd type="none" w="med" len="med"/>
-                    </a:lnR>
-                    <a:lnT w="6350" cap="flat" cmpd="sng" algn="ctr">
-                      <a:solidFill>
-                        <a:srgbClr val="DCDCDC"/>
-                      </a:solidFill>
-                      <a:prstDash val="solid"/>
-                      <a:round/>
-                      <a:headEnd type="none" w="med" len="med"/>
-                      <a:tailEnd type="none" w="med" len="med"/>
-                    </a:lnT>
-                    <a:lnB w="6350" cap="flat" cmpd="sng" algn="ctr">
-                      <a:solidFill>
-                        <a:srgbClr val="DCDCDC"/>
-                      </a:solidFill>
-                      <a:prstDash val="solid"/>
-                      <a:round/>
-                      <a:headEnd type="none" w="med" len="med"/>
-                      <a:tailEnd type="none" w="med" len="med"/>
-                    </a:lnB>
-                    <a:solidFill>
-                      <a:srgbClr val="FFFFFF"/>
-                    </a:solidFill>
-                  </a:tcPr>
-                </a:tc>
-                <a:tc>
-                  <a:txBody>
-                    <a:bodyPr/>
-                    <a:lstStyle/>
-                    <a:p>
-                      <a:pPr indent="0" marL="0">
-                        <a:buNone/>
-                      </a:pPr>
-                      <a:r>
-                        <a:rPr lang="en-US" sz="1000" dirty="0">
-                          <a:solidFill>
-                            <a:srgbClr val="222222"/>
-                          </a:solidFill>
-                          <a:latin typeface="Arial" pitchFamily="34" charset="0"/>
-                          <a:ea typeface="Arial" pitchFamily="34" charset="-122"/>
-                          <a:cs typeface="Arial" pitchFamily="34" charset="-120"/>
-                        </a:rPr>
-                        <a:t>pooled 1,45 — но квартал с lift 0 и частота 0,70</a:t>
-                      </a:r>
-                      <a:endParaRPr lang="en-US" sz="1000" dirty="0">
-                        <a:latin typeface="Arial" charset="0"/>
-                        <a:ea typeface="Arial" charset="0"/>
-                        <a:cs typeface="Arial" charset="0"/>
-                      </a:endParaRPr>
-                    </a:p>
-                  </a:txBody>
-                  <a:tcPr marL="63500" marR="63500" marT="63500" marB="63500" anchor="ctr">
-                    <a:lnL w="6350" cap="flat" cmpd="sng" algn="ctr">
-                      <a:solidFill>
-                        <a:srgbClr val="DCDCDC"/>
-                      </a:solidFill>
-                      <a:prstDash val="solid"/>
-                      <a:round/>
-                      <a:headEnd type="none" w="med" len="med"/>
-                      <a:tailEnd type="none" w="med" len="med"/>
-                    </a:lnL>
-                    <a:lnR w="6350" cap="flat" cmpd="sng" algn="ctr">
-                      <a:solidFill>
-                        <a:srgbClr val="DCDCDC"/>
-                      </a:solidFill>
-                      <a:prstDash val="solid"/>
-                      <a:round/>
-                      <a:headEnd type="none" w="med" len="med"/>
-                      <a:tailEnd type="none" w="med" len="med"/>
-                    </a:lnR>
-                    <a:lnT w="6350" cap="flat" cmpd="sng" algn="ctr">
-                      <a:solidFill>
-                        <a:srgbClr val="DCDCDC"/>
-                      </a:solidFill>
-                      <a:prstDash val="solid"/>
-                      <a:round/>
-                      <a:headEnd type="none" w="med" len="med"/>
-                      <a:tailEnd type="none" w="med" len="med"/>
-                    </a:lnT>
-                    <a:lnB w="6350" cap="flat" cmpd="sng" algn="ctr">
-                      <a:solidFill>
-                        <a:srgbClr val="DCDCDC"/>
-                      </a:solidFill>
-                      <a:prstDash val="solid"/>
-                      <a:round/>
-                      <a:headEnd type="none" w="med" len="med"/>
-                      <a:tailEnd type="none" w="med" len="med"/>
-                    </a:lnB>
-                    <a:solidFill>
-                      <a:srgbClr val="FFFFFF"/>
-                    </a:solidFill>
-                  </a:tcPr>
-                </a:tc>
-              </a:tr>
-              <a:tr h="274320">
-                <a:tc>
-                  <a:txBody>
-                    <a:bodyPr/>
-                    <a:lstStyle/>
-                    <a:p>
-                      <a:pPr indent="0" marL="0">
-                        <a:buNone/>
-                      </a:pPr>
-                      <a:r>
-                        <a:rPr lang="en-US" sz="1000" dirty="0">
-                          <a:solidFill>
-                            <a:srgbClr val="222222"/>
-                          </a:solidFill>
-                          <a:latin typeface="Arial" pitchFamily="34" charset="0"/>
-                          <a:ea typeface="Arial" pitchFamily="34" charset="-122"/>
-                          <a:cs typeface="Arial" pitchFamily="34" charset="-120"/>
-                        </a:rPr>
-                        <a:t>Dual-regret, основная</a:t>
-                      </a:r>
-                      <a:endParaRPr lang="en-US" sz="1000" dirty="0">
-                        <a:latin typeface="Arial" charset="0"/>
-                        <a:ea typeface="Arial" charset="0"/>
-                        <a:cs typeface="Arial" charset="0"/>
-                      </a:endParaRPr>
-                    </a:p>
-                  </a:txBody>
-                  <a:tcPr marL="63500" marR="63500" marT="63500" marB="63500" anchor="ctr">
-                    <a:lnL w="6350" cap="flat" cmpd="sng" algn="ctr">
-                      <a:solidFill>
-                        <a:srgbClr val="DCDCDC"/>
-                      </a:solidFill>
-                      <a:prstDash val="solid"/>
-                      <a:round/>
-                      <a:headEnd type="none" w="med" len="med"/>
-                      <a:tailEnd type="none" w="med" len="med"/>
-                    </a:lnL>
-                    <a:lnR w="6350" cap="flat" cmpd="sng" algn="ctr">
-                      <a:solidFill>
-                        <a:srgbClr val="DCDCDC"/>
-                      </a:solidFill>
-                      <a:prstDash val="solid"/>
-                      <a:round/>
-                      <a:headEnd type="none" w="med" len="med"/>
-                      <a:tailEnd type="none" w="med" len="med"/>
-                    </a:lnR>
-                    <a:lnT w="6350" cap="flat" cmpd="sng" algn="ctr">
-                      <a:solidFill>
-                        <a:srgbClr val="DCDCDC"/>
-                      </a:solidFill>
-                      <a:prstDash val="solid"/>
-                      <a:round/>
-                      <a:headEnd type="none" w="med" len="med"/>
-                      <a:tailEnd type="none" w="med" len="med"/>
-                    </a:lnT>
-                    <a:lnB w="6350" cap="flat" cmpd="sng" algn="ctr">
-                      <a:solidFill>
-                        <a:srgbClr val="DCDCDC"/>
-                      </a:solidFill>
-                      <a:prstDash val="solid"/>
-                      <a:round/>
-                      <a:headEnd type="none" w="med" len="med"/>
-                      <a:tailEnd type="none" w="med" len="med"/>
-                    </a:lnB>
-                    <a:solidFill>
-                      <a:srgbClr val="FFFFFF"/>
-                    </a:solidFill>
-                  </a:tcPr>
-                </a:tc>
-                <a:tc>
-                  <a:txBody>
-                    <a:bodyPr/>
-                    <a:lstStyle/>
-                    <a:p>
-                      <a:pPr indent="0" marL="0">
-                        <a:buNone/>
-                      </a:pPr>
-                      <a:r>
-                        <a:rPr lang="en-US" sz="1000" dirty="0">
-                          <a:solidFill>
-                            <a:srgbClr val="222222"/>
-                          </a:solidFill>
-                          <a:latin typeface="Arial" pitchFamily="34" charset="0"/>
-                          <a:ea typeface="Arial" pitchFamily="34" charset="-122"/>
-                          <a:cs typeface="Arial" pitchFamily="34" charset="-120"/>
-                        </a:rPr>
-                        <a:t>lift 1,03, частота 0,59, проиграл случайной политике</a:t>
-                      </a:r>
-                      <a:endParaRPr lang="en-US" sz="1000" dirty="0">
-                        <a:latin typeface="Arial" charset="0"/>
-                        <a:ea typeface="Arial" charset="0"/>
-                        <a:cs typeface="Arial" charset="0"/>
-                      </a:endParaRPr>
-                    </a:p>
-                  </a:txBody>
-                  <a:tcPr marL="63500" marR="63500" marT="63500" marB="63500" anchor="ctr">
-                    <a:lnL w="6350" cap="flat" cmpd="sng" algn="ctr">
-                      <a:solidFill>
-                        <a:srgbClr val="DCDCDC"/>
-                      </a:solidFill>
-                      <a:prstDash val="solid"/>
-                      <a:round/>
-                      <a:headEnd type="none" w="med" len="med"/>
-                      <a:tailEnd type="none" w="med" len="med"/>
-                    </a:lnL>
-                    <a:lnR w="6350" cap="flat" cmpd="sng" algn="ctr">
-                      <a:solidFill>
-                        <a:srgbClr val="DCDCDC"/>
-                      </a:solidFill>
-                      <a:prstDash val="solid"/>
-                      <a:round/>
-                      <a:headEnd type="none" w="med" len="med"/>
-                      <a:tailEnd type="none" w="med" len="med"/>
-                    </a:lnR>
-                    <a:lnT w="6350" cap="flat" cmpd="sng" algn="ctr">
-                      <a:solidFill>
-                        <a:srgbClr val="DCDCDC"/>
-                      </a:solidFill>
-                      <a:prstDash val="solid"/>
-                      <a:round/>
-                      <a:headEnd type="none" w="med" len="med"/>
-                      <a:tailEnd type="none" w="med" len="med"/>
-                    </a:lnT>
-                    <a:lnB w="6350" cap="flat" cmpd="sng" algn="ctr">
-                      <a:solidFill>
-                        <a:srgbClr val="DCDCDC"/>
-                      </a:solidFill>
-                      <a:prstDash val="solid"/>
-                      <a:round/>
-                      <a:headEnd type="none" w="med" len="med"/>
-                      <a:tailEnd type="none" w="med" len="med"/>
-                    </a:lnB>
-                    <a:solidFill>
-                      <a:srgbClr val="FFFFFF"/>
-                    </a:solidFill>
-                  </a:tcPr>
-                </a:tc>
-              </a:tr>
-            </a:tbl>
-          </a:graphicData>
-        </a:graphic>
-      </p:graphicFrame>
-      <p:sp>
-        <p:nvSpPr>
-          <p:cNvPr id="12" name="Shape 8"/>
-          <p:cNvSpPr/>
-          <p:nvPr/>
-        </p:nvSpPr>
-        <p:spPr>
-          <a:xfrm>
-            <a:off x="457200" y="3977640"/>
-            <a:ext cx="11274552" cy="1097280"/>
-          </a:xfrm>
-          <a:prstGeom prst="roundRect">
-            <a:avLst>
-              <a:gd name="adj" fmla="val 11667"/>
-            </a:avLst>
-          </a:prstGeom>
-          <a:solidFill>
-            <a:srgbClr val="FDEAE8"/>
+            <a:srgbClr val="FFFFFF"/>
           </a:solidFill>
           <a:ln/>
           <a:effectLst>
@@ -16397,14 +14998,75 @@
       </p:sp>
       <p:sp>
         <p:nvSpPr>
-          <p:cNvPr id="13" name="Text 9"/>
-          <p:cNvSpPr txBox="1"/>
-          <p:nvPr/>
-        </p:nvSpPr>
-        <p:spPr>
-          <a:xfrm>
-            <a:off x="685800" y="4160520"/>
-            <a:ext cx="10789920" cy="310896"/>
+          <p:cNvPr id="10" name="Shape 7"/>
+          <p:cNvSpPr/>
+          <p:nvPr/>
+        </p:nvSpPr>
+        <p:spPr>
+          <a:xfrm>
+            <a:off x="685800" y="3456432"/>
+            <a:ext cx="2011680" cy="310896"/>
+          </a:xfrm>
+          <a:prstGeom prst="roundRect">
+            <a:avLst>
+              <a:gd name="adj" fmla="val 50000"/>
+            </a:avLst>
+          </a:prstGeom>
+          <a:solidFill>
+            <a:srgbClr val="C3F53C"/>
+          </a:solidFill>
+          <a:ln/>
+        </p:spPr>
+      </p:sp>
+      <p:sp>
+        <p:nvSpPr>
+          <p:cNvPr id="11" name="Text 8"/>
+          <p:cNvSpPr txBox="1"/>
+          <p:nvPr/>
+        </p:nvSpPr>
+        <p:spPr>
+          <a:xfrm>
+            <a:off x="685800" y="3456432"/>
+            <a:ext cx="2011680" cy="310896"/>
+          </a:xfrm>
+          <a:prstGeom prst="rect">
+            <a:avLst/>
+          </a:prstGeom>
+          <a:noFill/>
+          <a:ln/>
+        </p:spPr>
+        <p:txBody>
+          <a:bodyPr wrap="square" lIns="0" tIns="0" rIns="0" bIns="0" rtlCol="0" anchor="ctr"/>
+          <a:lstStyle/>
+          <a:p>
+            <a:pPr algn="ctr" indent="0" marL="0">
+              <a:buNone/>
+            </a:pPr>
+            <a:r>
+              <a:rPr lang="en-US" sz="1150" b="1" dirty="0">
+                <a:solidFill>
+                  <a:srgbClr val="111111"/>
+                </a:solidFill>
+                <a:latin typeface="Arial" pitchFamily="34" charset="0"/>
+                <a:ea typeface="Arial" pitchFamily="34" charset="-122"/>
+                <a:cs typeface="Arial" pitchFamily="34" charset="-120"/>
+              </a:rPr>
+              <a:t>ЧТО СРАБОТАЛО</a:t>
+            </a:r>
+            <a:endParaRPr lang="en-US" sz="1150" dirty="0"/>
+          </a:p>
+        </p:txBody>
+      </p:sp>
+      <p:sp>
+        <p:nvSpPr>
+          <p:cNvPr id="12" name="Text 9"/>
+          <p:cNvSpPr txBox="1"/>
+          <p:nvPr/>
+        </p:nvSpPr>
+        <p:spPr>
+          <a:xfrm>
+            <a:off x="685800" y="3913632"/>
+            <a:ext cx="3154680" cy="310896"/>
           </a:xfrm>
           <a:prstGeom prst="rect">
             <a:avLst/>
@@ -16428,7 +15090,7 @@
                 <a:ea typeface="Arial" pitchFamily="34" charset="-122"/>
                 <a:cs typeface="Arial" pitchFamily="34" charset="-120"/>
               </a:rPr>
-              <a:t>Почему мы не предъявляем лучший результат — pooled lift 1,45</a:t>
+              <a:t>Цель + история + отказ</a:t>
             </a:r>
             <a:endParaRPr lang="en-US" sz="1400" dirty="0"/>
           </a:p>
@@ -16436,14 +15098,14 @@
       </p:sp>
       <p:sp>
         <p:nvSpPr>
-          <p:cNvPr id="14" name="Text 10"/>
-          <p:cNvSpPr txBox="1"/>
-          <p:nvPr/>
-        </p:nvSpPr>
-        <p:spPr>
-          <a:xfrm>
-            <a:off x="685800" y="4462272"/>
-            <a:ext cx="10817352" cy="548640"/>
+          <p:cNvPr id="13" name="Text 10"/>
+          <p:cNvSpPr txBox="1"/>
+          <p:nvPr/>
+        </p:nvSpPr>
+        <p:spPr>
+          <a:xfrm>
+            <a:off x="685800" y="4251960"/>
+            <a:ext cx="3154680" cy="713232"/>
           </a:xfrm>
           <a:prstGeom prst="rect">
             <a:avLst/>
@@ -16462,7 +15124,7 @@
               <a:buNone/>
             </a:pPr>
             <a:r>
-              <a:rPr lang="en-US" sz="1150" dirty="0">
+              <a:rPr lang="en-US" sz="1100" dirty="0">
                 <a:solidFill>
                   <a:srgbClr val="3A3A3A"/>
                 </a:solidFill>
@@ -16470,26 +15132,26 @@
                 <a:ea typeface="Arial" pitchFamily="34" charset="-122"/>
                 <a:cs typeface="Arial" pitchFamily="34" charset="-120"/>
               </a:rPr>
-              <a:t>Хотя бы один квартал с lift 0 — устойчивости нет. Частота 0,70 в неделю — ниже продуктового требования. Проверялись восемь сочетаний «цель × модель», поэтому точечный интервал не доказывает эффект после поправки на множественные сравнения.</a:t>
-            </a:r>
-            <a:endParaRPr lang="en-US" sz="1150" dirty="0"/>
-          </a:p>
-        </p:txBody>
-      </p:sp>
-      <p:sp>
-        <p:nvSpPr>
-          <p:cNvPr id="15" name="Shape 11"/>
+              <a:t>Regret/triple-barrier, история с 2010, бустинг и право модели промолчать. Четыре из пяти коридоров дали raw lift ≥ 1,3 на h = 5/10.</a:t>
+            </a:r>
+            <a:endParaRPr lang="en-US" sz="1100" dirty="0"/>
+          </a:p>
+        </p:txBody>
+      </p:sp>
+      <p:sp>
+        <p:nvSpPr>
+          <p:cNvPr id="14" name="Shape 11"/>
           <p:cNvSpPr/>
           <p:nvPr/>
         </p:nvSpPr>
         <p:spPr>
           <a:xfrm>
-            <a:off x="457200" y="5230368"/>
-            <a:ext cx="11274552" cy="1170432"/>
+            <a:off x="4279392" y="3246120"/>
+            <a:ext cx="3593592" cy="1874520"/>
           </a:xfrm>
           <a:prstGeom prst="roundRect">
             <a:avLst>
-              <a:gd name="adj" fmla="val 10938"/>
+              <a:gd name="adj" fmla="val 6829"/>
             </a:avLst>
           </a:prstGeom>
           <a:solidFill>
@@ -16507,14 +15169,75 @@
       </p:sp>
       <p:sp>
         <p:nvSpPr>
-          <p:cNvPr id="16" name="Text 12"/>
-          <p:cNvSpPr txBox="1"/>
-          <p:nvPr/>
-        </p:nvSpPr>
-        <p:spPr>
-          <a:xfrm>
-            <a:off x="685800" y="5394960"/>
-            <a:ext cx="10789920" cy="310896"/>
+          <p:cNvPr id="15" name="Shape 12"/>
+          <p:cNvSpPr/>
+          <p:nvPr/>
+        </p:nvSpPr>
+        <p:spPr>
+          <a:xfrm>
+            <a:off x="4507992" y="3456432"/>
+            <a:ext cx="1965960" cy="310896"/>
+          </a:xfrm>
+          <a:prstGeom prst="roundRect">
+            <a:avLst>
+              <a:gd name="adj" fmla="val 50000"/>
+            </a:avLst>
+          </a:prstGeom>
+          <a:solidFill>
+            <a:srgbClr val="111111"/>
+          </a:solidFill>
+          <a:ln/>
+        </p:spPr>
+      </p:sp>
+      <p:sp>
+        <p:nvSpPr>
+          <p:cNvPr id="16" name="Text 13"/>
+          <p:cNvSpPr txBox="1"/>
+          <p:nvPr/>
+        </p:nvSpPr>
+        <p:spPr>
+          <a:xfrm>
+            <a:off x="4507992" y="3456432"/>
+            <a:ext cx="1965960" cy="310896"/>
+          </a:xfrm>
+          <a:prstGeom prst="rect">
+            <a:avLst/>
+          </a:prstGeom>
+          <a:noFill/>
+          <a:ln/>
+        </p:spPr>
+        <p:txBody>
+          <a:bodyPr wrap="square" lIns="0" tIns="0" rIns="0" bIns="0" rtlCol="0" anchor="ctr"/>
+          <a:lstStyle/>
+          <a:p>
+            <a:pPr algn="ctr" indent="0" marL="0">
+              <a:buNone/>
+            </a:pPr>
+            <a:r>
+              <a:rPr lang="en-US" sz="1150" b="1" dirty="0">
+                <a:solidFill>
+                  <a:srgbClr val="FFFFFF"/>
+                </a:solidFill>
+                <a:latin typeface="Arial" pitchFamily="34" charset="0"/>
+                <a:ea typeface="Arial" pitchFamily="34" charset="-122"/>
+                <a:cs typeface="Arial" pitchFamily="34" charset="-120"/>
+              </a:rPr>
+              <a:t>МАСШТАБ</a:t>
+            </a:r>
+            <a:endParaRPr lang="en-US" sz="1150" dirty="0"/>
+          </a:p>
+        </p:txBody>
+      </p:sp>
+      <p:sp>
+        <p:nvSpPr>
+          <p:cNvPr id="17" name="Text 14"/>
+          <p:cNvSpPr txBox="1"/>
+          <p:nvPr/>
+        </p:nvSpPr>
+        <p:spPr>
+          <a:xfrm>
+            <a:off x="4507992" y="3913632"/>
+            <a:ext cx="3154680" cy="310896"/>
           </a:xfrm>
           <a:prstGeom prst="rect">
             <a:avLst/>
@@ -16538,7 +15261,7 @@
                 <a:ea typeface="Arial" pitchFamily="34" charset="-122"/>
                 <a:cs typeface="Arial" pitchFamily="34" charset="-120"/>
               </a:rPr>
-              <a:t>И проверка, которую наша лучшая модель не прошла</a:t>
+              <a:t>13 379 вариантов</a:t>
             </a:r>
             <a:endParaRPr lang="en-US" sz="1400" dirty="0"/>
           </a:p>
@@ -16546,14 +15269,14 @@
       </p:sp>
       <p:sp>
         <p:nvSpPr>
-          <p:cNvPr id="17" name="Text 13"/>
-          <p:cNvSpPr txBox="1"/>
-          <p:nvPr/>
-        </p:nvSpPr>
-        <p:spPr>
-          <a:xfrm>
-            <a:off x="685800" y="5696712"/>
-            <a:ext cx="10817352" cy="594360"/>
+          <p:cNvPr id="18" name="Text 15"/>
+          <p:cNvSpPr txBox="1"/>
+          <p:nvPr/>
+        </p:nvSpPr>
+        <p:spPr>
+          <a:xfrm>
+            <a:off x="4507992" y="4251960"/>
+            <a:ext cx="3154680" cy="713232"/>
           </a:xfrm>
           <a:prstGeom prst="rect">
             <a:avLst/>
@@ -16572,6 +15295,287 @@
               <a:buNone/>
             </a:pPr>
             <a:r>
+              <a:rPr lang="en-US" sz="1100" dirty="0">
+                <a:solidFill>
+                  <a:srgbClr val="3A3A3A"/>
+                </a:solidFill>
+                <a:latin typeface="Arial" pitchFamily="34" charset="0"/>
+                <a:ea typeface="Arial" pitchFamily="34" charset="-122"/>
+                <a:cs typeface="Arial" pitchFamily="34" charset="-120"/>
+              </a:rPr>
+              <a:t>39 крупных проверок, пять коридоров, 25 итоговых таблиц. Новости сознательно не использовались.</a:t>
+            </a:r>
+            <a:endParaRPr lang="en-US" sz="1100" dirty="0"/>
+          </a:p>
+        </p:txBody>
+      </p:sp>
+      <p:sp>
+        <p:nvSpPr>
+          <p:cNvPr id="19" name="Shape 16"/>
+          <p:cNvSpPr/>
+          <p:nvPr/>
+        </p:nvSpPr>
+        <p:spPr>
+          <a:xfrm>
+            <a:off x="8110728" y="3246120"/>
+            <a:ext cx="3621024" cy="1874520"/>
+          </a:xfrm>
+          <a:prstGeom prst="roundRect">
+            <a:avLst>
+              <a:gd name="adj" fmla="val 6829"/>
+            </a:avLst>
+          </a:prstGeom>
+          <a:solidFill>
+            <a:srgbClr val="FDEAE8"/>
+          </a:solidFill>
+          <a:ln/>
+          <a:effectLst>
+            <a:outerShdw sx="100000" sy="100000" kx="0" ky="0" algn="bl" rotWithShape="0" blurRad="101600" dist="12700" dir="5400000">
+              <a:srgbClr val="9A9A9A">
+                <a:alpha val="18000"/>
+              </a:srgbClr>
+            </a:outerShdw>
+          </a:effectLst>
+        </p:spPr>
+      </p:sp>
+      <p:sp>
+        <p:nvSpPr>
+          <p:cNvPr id="20" name="Shape 17"/>
+          <p:cNvSpPr/>
+          <p:nvPr/>
+        </p:nvSpPr>
+        <p:spPr>
+          <a:xfrm>
+            <a:off x="8339328" y="3456432"/>
+            <a:ext cx="2240280" cy="310896"/>
+          </a:xfrm>
+          <a:prstGeom prst="roundRect">
+            <a:avLst>
+              <a:gd name="adj" fmla="val 50000"/>
+            </a:avLst>
+          </a:prstGeom>
+          <a:solidFill>
+            <a:srgbClr val="EF3124"/>
+          </a:solidFill>
+          <a:ln/>
+        </p:spPr>
+      </p:sp>
+      <p:sp>
+        <p:nvSpPr>
+          <p:cNvPr id="21" name="Text 18"/>
+          <p:cNvSpPr txBox="1"/>
+          <p:nvPr/>
+        </p:nvSpPr>
+        <p:spPr>
+          <a:xfrm>
+            <a:off x="8339328" y="3456432"/>
+            <a:ext cx="2240280" cy="310896"/>
+          </a:xfrm>
+          <a:prstGeom prst="rect">
+            <a:avLst/>
+          </a:prstGeom>
+          <a:noFill/>
+          <a:ln/>
+        </p:spPr>
+        <p:txBody>
+          <a:bodyPr wrap="square" lIns="0" tIns="0" rIns="0" bIns="0" rtlCol="0" anchor="ctr"/>
+          <a:lstStyle/>
+          <a:p>
+            <a:pPr algn="ctr" indent="0" marL="0">
+              <a:buNone/>
+            </a:pPr>
+            <a:r>
+              <a:rPr lang="en-US" sz="1150" b="1" dirty="0">
+                <a:solidFill>
+                  <a:srgbClr val="FFFFFF"/>
+                </a:solidFill>
+                <a:latin typeface="Arial" pitchFamily="34" charset="0"/>
+                <a:ea typeface="Arial" pitchFamily="34" charset="-122"/>
+                <a:cs typeface="Arial" pitchFamily="34" charset="-120"/>
+              </a:rPr>
+              <a:t>ВАЖНОЕ «НО»</a:t>
+            </a:r>
+            <a:endParaRPr lang="en-US" sz="1150" dirty="0"/>
+          </a:p>
+        </p:txBody>
+      </p:sp>
+      <p:sp>
+        <p:nvSpPr>
+          <p:cNvPr id="22" name="Text 19"/>
+          <p:cNvSpPr txBox="1"/>
+          <p:nvPr/>
+        </p:nvSpPr>
+        <p:spPr>
+          <a:xfrm>
+            <a:off x="8339328" y="3913632"/>
+            <a:ext cx="3154680" cy="310896"/>
+          </a:xfrm>
+          <a:prstGeom prst="rect">
+            <a:avLst/>
+          </a:prstGeom>
+          <a:noFill/>
+          <a:ln/>
+        </p:spPr>
+        <p:txBody>
+          <a:bodyPr wrap="square" lIns="0" tIns="0" rIns="0" bIns="0" rtlCol="0" anchor="ctr"/>
+          <a:lstStyle/>
+          <a:p>
+            <a:pPr indent="0" marL="0">
+              <a:buNone/>
+            </a:pPr>
+            <a:r>
+              <a:rPr lang="en-US" sz="1400" b="1" dirty="0">
+                <a:solidFill>
+                  <a:srgbClr val="111111"/>
+                </a:solidFill>
+                <a:latin typeface="Arial" pitchFamily="34" charset="0"/>
+                <a:ea typeface="Arial" pitchFamily="34" charset="-122"/>
+                <a:cs typeface="Arial" pitchFamily="34" charset="-120"/>
+              </a:rPr>
+              <a:t>Это ещё не доказательство</a:t>
+            </a:r>
+            <a:endParaRPr lang="en-US" sz="1400" dirty="0"/>
+          </a:p>
+        </p:txBody>
+      </p:sp>
+      <p:sp>
+        <p:nvSpPr>
+          <p:cNvPr id="23" name="Text 20"/>
+          <p:cNvSpPr txBox="1"/>
+          <p:nvPr/>
+        </p:nvSpPr>
+        <p:spPr>
+          <a:xfrm>
+            <a:off x="8339328" y="4251960"/>
+            <a:ext cx="3154680" cy="713232"/>
+          </a:xfrm>
+          <a:prstGeom prst="rect">
+            <a:avLst/>
+          </a:prstGeom>
+          <a:noFill/>
+          <a:ln/>
+        </p:spPr>
+        <p:txBody>
+          <a:bodyPr wrap="square" lIns="0" tIns="0" rIns="0" bIns="0" rtlCol="0" anchor="t"/>
+          <a:lstStyle/>
+          <a:p>
+            <a:pPr indent="0" marL="0">
+              <a:lnSpc>
+                <a:spcPct val="116000"/>
+              </a:lnSpc>
+              <a:buNone/>
+            </a:pPr>
+            <a:r>
+              <a:rPr lang="en-US" sz="1100" dirty="0">
+                <a:solidFill>
+                  <a:srgbClr val="3A3A3A"/>
+                </a:solidFill>
+                <a:latin typeface="Arial" pitchFamily="34" charset="0"/>
+                <a:ea typeface="Arial" pitchFamily="34" charset="-122"/>
+                <a:cs typeface="Arial" pitchFamily="34" charset="-120"/>
+              </a:rPr>
+              <a:t>Победителей выбрали после большого перебора на одной OOT-истории. Нужен один заранее замороженный тест на новых данных.</a:t>
+            </a:r>
+            <a:endParaRPr lang="en-US" sz="1100" dirty="0"/>
+          </a:p>
+        </p:txBody>
+      </p:sp>
+      <p:sp>
+        <p:nvSpPr>
+          <p:cNvPr id="24" name="Shape 21"/>
+          <p:cNvSpPr/>
+          <p:nvPr/>
+        </p:nvSpPr>
+        <p:spPr>
+          <a:xfrm>
+            <a:off x="457200" y="5349240"/>
+            <a:ext cx="11274552" cy="1051560"/>
+          </a:xfrm>
+          <a:prstGeom prst="roundRect">
+            <a:avLst>
+              <a:gd name="adj" fmla="val 12174"/>
+            </a:avLst>
+          </a:prstGeom>
+          <a:solidFill>
+            <a:srgbClr val="FDEAE8"/>
+          </a:solidFill>
+          <a:ln/>
+          <a:effectLst>
+            <a:outerShdw sx="100000" sy="100000" kx="0" ky="0" algn="bl" rotWithShape="0" blurRad="101600" dist="12700" dir="5400000">
+              <a:srgbClr val="9A9A9A">
+                <a:alpha val="18000"/>
+              </a:srgbClr>
+            </a:outerShdw>
+          </a:effectLst>
+        </p:spPr>
+      </p:sp>
+      <p:sp>
+        <p:nvSpPr>
+          <p:cNvPr id="25" name="Text 22"/>
+          <p:cNvSpPr txBox="1"/>
+          <p:nvPr/>
+        </p:nvSpPr>
+        <p:spPr>
+          <a:xfrm>
+            <a:off x="685800" y="5532120"/>
+            <a:ext cx="10789920" cy="310896"/>
+          </a:xfrm>
+          <a:prstGeom prst="rect">
+            <a:avLst/>
+          </a:prstGeom>
+          <a:noFill/>
+          <a:ln/>
+        </p:spPr>
+        <p:txBody>
+          <a:bodyPr wrap="square" lIns="0" tIns="0" rIns="0" bIns="0" rtlCol="0" anchor="ctr"/>
+          <a:lstStyle/>
+          <a:p>
+            <a:pPr indent="0" marL="0">
+              <a:buNone/>
+            </a:pPr>
+            <a:r>
+              <a:rPr lang="en-US" sz="1400" b="1" dirty="0">
+                <a:solidFill>
+                  <a:srgbClr val="111111"/>
+                </a:solidFill>
+                <a:latin typeface="Arial" pitchFamily="34" charset="0"/>
+                <a:ea typeface="Arial" pitchFamily="34" charset="-122"/>
+                <a:cs typeface="Arial" pitchFamily="34" charset="-120"/>
+              </a:rPr>
+              <a:t>Цена ожидания тоже измерена</a:t>
+            </a:r>
+            <a:endParaRPr lang="en-US" sz="1400" dirty="0"/>
+          </a:p>
+        </p:txBody>
+      </p:sp>
+      <p:sp>
+        <p:nvSpPr>
+          <p:cNvPr id="26" name="Text 23"/>
+          <p:cNvSpPr txBox="1"/>
+          <p:nvPr/>
+        </p:nvSpPr>
+        <p:spPr>
+          <a:xfrm>
+            <a:off x="685800" y="5852160"/>
+            <a:ext cx="10817352" cy="411480"/>
+          </a:xfrm>
+          <a:prstGeom prst="rect">
+            <a:avLst/>
+          </a:prstGeom>
+          <a:noFill/>
+          <a:ln/>
+        </p:spPr>
+        <p:txBody>
+          <a:bodyPr wrap="square" lIns="0" tIns="0" rIns="0" bIns="0" rtlCol="0" anchor="t"/>
+          <a:lstStyle/>
+          <a:p>
+            <a:pPr indent="0" marL="0">
+              <a:lnSpc>
+                <a:spcPct val="116000"/>
+              </a:lnSpc>
+              <a:buNone/>
+            </a:pPr>
+            <a:r>
               <a:rPr lang="en-US" sz="1150" dirty="0">
                 <a:solidFill>
                   <a:srgbClr val="3A3A3A"/>
@@ -16580,7 +15584,7 @@
                 <a:ea typeface="Arial" pitchFamily="34" charset="-122"/>
                 <a:cs typeface="Arial" pitchFamily="34" charset="-120"/>
               </a:rPr>
-              <a:t>Сравнили XGBoost со случайной политикой, дающей столько же сообщений в тех же неделях. Средний hit rate случайной политики — 23,3 % против 21,8 % у модели, и в 76,6 % случайных прогонов lift оказался не хуже модельного.</a:t>
+              <a:t>Заявка −1 % / 14 дней исполняется в 48 % стартов. Optimal-stopping proxy уменьшает средний regret на 15–35 %, но пока использует искусственный дедлайн.</a:t>
             </a:r>
             <a:endParaRPr lang="en-US" sz="1150" dirty="0"/>
           </a:p>
@@ -16769,7 +15773,7 @@
                 <a:ea typeface="Arial" pitchFamily="34" charset="-122"/>
                 <a:cs typeface="Arial" pitchFamily="34" charset="-120"/>
               </a:rPr>
-              <a:t> частота и точность на этих данных несовместимы</a:t>
+              <a:t> сигнал найден, но продуктовый эффект ещё не доказан</a:t>
             </a:r>
             <a:endParaRPr lang="en-US" sz="3000" dirty="0"/>
           </a:p>
@@ -16813,7 +15817,7 @@
         <p:spPr>
           <a:xfrm>
             <a:off x="685800" y="1444752"/>
-            <a:ext cx="2651760" cy="310896"/>
+            <a:ext cx="2880360" cy="310896"/>
           </a:xfrm>
           <a:prstGeom prst="roundRect">
             <a:avLst>
@@ -16835,7 +15839,7 @@
         <p:spPr>
           <a:xfrm>
             <a:off x="685800" y="1444752"/>
-            <a:ext cx="2651760" cy="310896"/>
+            <a:ext cx="2880360" cy="310896"/>
           </a:xfrm>
           <a:prstGeom prst="rect">
             <a:avLst/>
@@ -16859,7 +15863,7 @@
                 <a:ea typeface="Arial" pitchFamily="34" charset="-122"/>
                 <a:cs typeface="Arial" pitchFamily="34" charset="-120"/>
               </a:rPr>
-              <a:t>ЧАСТЫЙ СИГНАЛ</a:t>
+              <a:t>ИССЛЕДОВАТЕЛЬСКИЙ РЕЗУЛЬТАТ</a:t>
             </a:r>
             <a:endParaRPr lang="en-US" sz="1150" dirty="0"/>
           </a:p>
@@ -16892,13 +15896,13 @@
             <a:r>
               <a:rPr lang="en-US" sz="4000" b="1" dirty="0">
                 <a:solidFill>
-                  <a:srgbClr val="EF3124"/>
-                </a:solidFill>
-                <a:latin typeface="Arial" pitchFamily="34" charset="0"/>
-                <a:ea typeface="Arial" pitchFamily="34" charset="-122"/>
-                <a:cs typeface="Arial" pitchFamily="34" charset="-120"/>
-              </a:rPr>
-              <a:t>+2,6 бп</a:t>
+                  <a:srgbClr val="1B7F3B"/>
+                </a:solidFill>
+                <a:latin typeface="Arial" pitchFamily="34" charset="0"/>
+                <a:ea typeface="Arial" pitchFamily="34" charset="-122"/>
+                <a:cs typeface="Arial" pitchFamily="34" charset="-120"/>
+              </a:rPr>
+              <a:t>1,36–1,45</a:t>
             </a:r>
             <a:endParaRPr lang="en-US" sz="4000" dirty="0"/>
           </a:p>
@@ -16940,7 +15944,7 @@
                 <a:ea typeface="Arial" pitchFamily="34" charset="-122"/>
                 <a:cs typeface="Arial" pitchFamily="34" charset="-120"/>
               </a:rPr>
-              <a:t>при 1,92 сигнала в неделю. Единственная гипотеза, прошедшая требование частоты, — внутридневная. Выгода символическая.</a:t>
+              <a:t>raw lift лучших моделей при 1,02–1,06 сигнала в неделю. Это соответствует требованию по lift и частоте на просмотренной истории.</a:t>
             </a:r>
             <a:endParaRPr lang="en-US" sz="1200" dirty="0"/>
           </a:p>
@@ -16984,7 +15988,7 @@
         <p:spPr>
           <a:xfrm>
             <a:off x="6428232" y="1444752"/>
-            <a:ext cx="2651760" cy="310896"/>
+            <a:ext cx="2880360" cy="310896"/>
           </a:xfrm>
           <a:prstGeom prst="roundRect">
             <a:avLst>
@@ -17006,7 +16010,7 @@
         <p:spPr>
           <a:xfrm>
             <a:off x="6428232" y="1444752"/>
-            <a:ext cx="2651760" cy="310896"/>
+            <a:ext cx="2880360" cy="310896"/>
           </a:xfrm>
           <a:prstGeom prst="rect">
             <a:avLst/>
@@ -17030,7 +16034,7 @@
                 <a:ea typeface="Arial" pitchFamily="34" charset="-122"/>
                 <a:cs typeface="Arial" pitchFamily="34" charset="-120"/>
               </a:rPr>
-              <a:t>ЦЕННЫЙ СИГНАЛ</a:t>
+              <a:t>СТРОГИЙ КОНТРОЛЬ</a:t>
             </a:r>
             <a:endParaRPr lang="en-US" sz="1150" dirty="0"/>
           </a:p>
@@ -17063,13 +16067,13 @@
             <a:r>
               <a:rPr lang="en-US" sz="4000" b="1" dirty="0">
                 <a:solidFill>
-                  <a:srgbClr val="1B7F3B"/>
-                </a:solidFill>
-                <a:latin typeface="Arial" pitchFamily="34" charset="0"/>
-                <a:ea typeface="Arial" pitchFamily="34" charset="-122"/>
-                <a:cs typeface="Arial" pitchFamily="34" charset="-120"/>
-              </a:rPr>
-              <a:t>+83…+192 бп</a:t>
+                  <a:srgbClr val="EF3124"/>
+                </a:solidFill>
+                <a:latin typeface="Arial" pitchFamily="34" charset="0"/>
+                <a:ea typeface="Arial" pitchFamily="34" charset="-122"/>
+                <a:cs typeface="Arial" pitchFamily="34" charset="-120"/>
+              </a:rPr>
+              <a:t>1,18–1,23</a:t>
             </a:r>
             <a:endParaRPr lang="en-US" sz="4000" dirty="0"/>
           </a:p>
@@ -17111,7 +16115,7 @@
                 <a:ea typeface="Arial" pitchFamily="34" charset="-122"/>
                 <a:cs typeface="Arial" pitchFamily="34" charset="-120"/>
               </a:rPr>
-              <a:t>при 0,03–0,19 сигнала в неделю — несколько раз в год. Для пилота столько событий не набрать.</a:t>
+              <a:t>lift против случайного дня той же недели. Худший год: 1,19–1,26. Запаса устойчивости до 1,3 пока нет.</a:t>
             </a:r>
             <a:endParaRPr lang="en-US" sz="1200" dirty="0"/>
           </a:p>
@@ -17179,7 +16183,7 @@
                 <a:ea typeface="Arial" pitchFamily="34" charset="-122"/>
                 <a:cs typeface="Arial" pitchFamily="34" charset="-120"/>
               </a:rPr>
-              <a:t>Это и есть содержательный ответ на вопрос кейса о дефицитном канале</a:t>
+              <a:t>Почему вывод изменился после первого отрицательного прогона</a:t>
             </a:r>
             <a:endParaRPr lang="en-US" sz="1500" dirty="0"/>
           </a:p>
@@ -17221,7 +16225,7 @@
                 <a:ea typeface="Arial" pitchFamily="34" charset="-122"/>
                 <a:cs typeface="Arial" pitchFamily="34" charset="-120"/>
               </a:rPr>
-              <a:t>Кейс построен вокруг того, что пуш — дефицитный ресурс. Мы измерили, где именно дефицит упирается в данные: середины между частым бесполезным и редким ценным сигналом на дневной истории CNY/RUB нет.</a:t>
+              <a:t>Первые модели работали только на CNY/RUB и строгом локальном минимуме. Длинная история, пять коридоров, продуктовая regret-цель, triple barrier и selective prediction создали кандидатов нужной частоты. Отрицательный вывод остаётся верным только для первой постановки.</a:t>
             </a:r>
             <a:endParaRPr lang="en-US" sz="1200" dirty="0"/>
           </a:p>
@@ -17311,7 +16315,7 @@
                 <a:ea typeface="Arial" pitchFamily="34" charset="-122"/>
                 <a:cs typeface="Arial" pitchFamily="34" charset="-120"/>
               </a:rPr>
-              <a:t>ЧТО ПОДТВЕРДИЛОСЬ</a:t>
+              <a:t>ПРОДУКТОВОЕ РЕШЕНИЕ</a:t>
             </a:r>
             <a:endParaRPr lang="en-US" sz="1150" dirty="0"/>
           </a:p>
@@ -17353,7 +16357,7 @@
                 <a:ea typeface="Arial" pitchFamily="34" charset="-122"/>
                 <a:cs typeface="Arial" pitchFamily="34" charset="-120"/>
               </a:rPr>
-              <a:t>Направление сообщения мы определили верно. Все сценарии «окно закрывается» дают положительную выгоду вперёд (+39,8…+91,2 бп), все моментум-сценарии «сейчас выгодно» — отрицательную. Постановка повесила на верную предпосылку неверное сообщение, и мы показали это числами. Не хватило силы: lift 1,09–1,18 при пороге 1,3.</a:t>
+              <a:t>Не отправлять пуши клиентам по exploratory-результату. Заморозить один пайплайн, проверить его на нетронутом периоде, пересчитать выгоду на реальном курсе приложения и только затем запускать ограниченный A/B-пилот.</a:t>
             </a:r>
             <a:endParaRPr lang="en-US" sz="1200" dirty="0"/>
           </a:p>

</xml_diff>

<commit_message>
feat: audit winners and test robust signal ensembles
</commit_message>
<xml_diff>
--- a/docs/presentation/fx-pulse-interim.pptx
+++ b/docs/presentation/fx-pulse-interim.pptx
@@ -2554,7 +2554,7 @@
                 <a:ea typeface="Arial" pitchFamily="34" charset="-122"/>
                 <a:cs typeface="Arial" pitchFamily="34" charset="-120"/>
               </a:rPr>
-              <a:t>Выбор победителя после 13 379 вариантов</a:t>
+              <a:t>История уже много раз просмотрена</a:t>
             </a:r>
             <a:endParaRPr lang="en-US" sz="1400" dirty="0"/>
           </a:p>
@@ -2596,7 +2596,7 @@
                 <a:ea typeface="Arial" pitchFamily="34" charset="-122"/>
                 <a:cs typeface="Arial" pitchFamily="34" charset="-120"/>
               </a:rPr>
-              <a:t>Одна и та же OOT-история использовалась для сравнения моделей. Позиция: считать результат кандидатом, заранее заморозить признаки, модель и порог, а затем один раз проверить на новых датах или внешнем hold-out.</a:t>
+              <a:t>Вложенный выбор снизил h=5 с 1,44 / 1,24 до 1,32 / 1,15. Позиция: прекратить подбор, заморозить две политики и один раз проверить их на новых датах или внешнем hold-out.</a:t>
             </a:r>
             <a:endParaRPr lang="en-US" sz="1150" dirty="0"/>
           </a:p>
@@ -2896,7 +2896,7 @@
                 <a:ea typeface="Arial" pitchFamily="34" charset="-122"/>
                 <a:cs typeface="Arial" pitchFamily="34" charset="-120"/>
               </a:rPr>
-              <a:t>Строгая устойчивость ниже цели</a:t>
+              <a:t>Вложенная оценка ниже максимума</a:t>
             </a:r>
             <a:endParaRPr lang="en-US" sz="1200" dirty="0"/>
           </a:p>
@@ -2938,7 +2938,7 @@
                 <a:ea typeface="Arial" pitchFamily="34" charset="-122"/>
                 <a:cs typeface="Arial" pitchFamily="34" charset="-120"/>
               </a:rPr>
-              <a:t>Same-week lift 1,18–1,23, худший год 1,19–1,26: raw lift выше 1,3 не равен готовому доказательству</a:t>
+              <a:t>Последовательный h=5: raw 1,32, same-week 1,15. Максимум 1,44 / 1,24 не равен готовому доказательству</a:t>
             </a:r>
             <a:endParaRPr lang="en-US" sz="1050" dirty="0"/>
           </a:p>
@@ -3499,7 +3499,7 @@
                 <a:ea typeface="Arial" pitchFamily="34" charset="-122"/>
                 <a:cs typeface="Arial" pitchFamily="34" charset="-120"/>
               </a:rPr>
-              <a:t>Заморозить один пайплайн</a:t>
+              <a:t>Заморозить два h=5 пайплайна</a:t>
             </a:r>
             <a:endParaRPr lang="en-US" sz="1150" dirty="0"/>
           </a:p>
@@ -3577,7 +3577,7 @@
                 <a:ea typeface="Arial" pitchFamily="34" charset="-122"/>
                 <a:cs typeface="Arial" pitchFamily="34" charset="-120"/>
               </a:rPr>
-              <a:t>Цель, признаки, модель, порог и критерии успеха фиксируются до следующего результата</a:t>
+              <a:t>Consensus как основной, rolling-4y CatBoost как контроль; критерии фиксируются до результата</a:t>
             </a:r>
             <a:endParaRPr lang="en-US" sz="1050" dirty="0"/>
           </a:p>
@@ -5684,7 +5684,7 @@
                 <a:ea typeface="Arial" pitchFamily="34" charset="-122"/>
                 <a:cs typeface="Arial" pitchFamily="34" charset="-120"/>
               </a:rPr>
-              <a:t>39 крупных проверок, 25 таблиц и 13 379 вариантов</a:t>
+              <a:t>39 исходных + 21 новая модельная проверка</a:t>
             </a:r>
             <a:endParaRPr lang="en-US" sz="1000" dirty="0"/>
           </a:p>
@@ -5708,7 +5708,7 @@
                 <a:ea typeface="Arial" pitchFamily="34" charset="-122"/>
                 <a:cs typeface="Arial" pitchFamily="34" charset="-120"/>
               </a:rPr>
-              <a:t>Итоговые модели для h = 3/5/10</a:t>
+              <a:t>Seed replay, nested selection, placebo и block bootstrap</a:t>
             </a:r>
             <a:endParaRPr lang="en-US" sz="1000" dirty="0"/>
           </a:p>
@@ -5732,7 +5732,7 @@
                 <a:ea typeface="Arial" pitchFamily="34" charset="-122"/>
                 <a:cs typeface="Arial" pitchFamily="34" charset="-120"/>
               </a:rPr>
-              <a:t>signals_as_of(T), защита от утечки и 101 тест</a:t>
+              <a:t>signals_as_of(T), защита от утечки и 110 тестов</a:t>
             </a:r>
             <a:endParaRPr lang="en-US" sz="1000" dirty="0"/>
           </a:p>
@@ -5796,7 +5796,7 @@
                 <a:ea typeface="Arial" pitchFamily="34" charset="-122"/>
                 <a:cs typeface="Arial" pitchFamily="34" charset="-120"/>
               </a:rPr>
-              <a:t>Полная занятость. Сейчас: заморозка кандидата, hold-out и финальный отчёт</a:t>
+              <a:t>Полная занятость. Сейчас: заморозка h=5 кандидатов, hold-out и финальный отчёт</a:t>
             </a:r>
             <a:endParaRPr lang="en-US" sz="1000" dirty="0"/>
           </a:p>
@@ -10894,7 +10894,7 @@
                 <a:ea typeface="Arial" pitchFamily="34" charset="-122"/>
                 <a:cs typeface="Arial" pitchFamily="34" charset="-120"/>
               </a:rPr>
-              <a:t>50 модулей</a:t>
+              <a:t>52 модуля</a:t>
             </a:r>
             <a:endParaRPr lang="en-US" sz="1900" dirty="0"/>
           </a:p>
@@ -10933,7 +10933,7 @@
                 <a:ea typeface="Arial" pitchFamily="34" charset="-122"/>
                 <a:cs typeface="Arial" pitchFamily="34" charset="-120"/>
               </a:rPr>
-              <a:t>101 тест</a:t>
+              <a:t>110 тестов</a:t>
             </a:r>
             <a:endParaRPr lang="en-US" sz="1900" dirty="0"/>
           </a:p>
@@ -10972,7 +10972,7 @@
                 <a:ea typeface="Arial" pitchFamily="34" charset="-122"/>
                 <a:cs typeface="Arial" pitchFamily="34" charset="-120"/>
               </a:rPr>
-              <a:t>39 проверок</a:t>
+              <a:t>60 идей</a:t>
             </a:r>
             <a:endParaRPr lang="en-US" sz="1900" dirty="0"/>
           </a:p>
@@ -11137,7 +11137,7 @@
                 <a:ea typeface="Arial" pitchFamily="34" charset="-122"/>
                 <a:cs typeface="Arial" pitchFamily="34" charset="-120"/>
               </a:rPr>
-              <a:t>25 таблиц, 13 379 вариантов</a:t>
+              <a:t>39 + 6 robustness + 15 новых</a:t>
             </a:r>
             <a:endParaRPr lang="en-US" sz="1000" dirty="0"/>
           </a:p>
@@ -11179,7 +11179,7 @@
                 <a:ea typeface="Arial" pitchFamily="34" charset="-122"/>
                 <a:cs typeface="Arial" pitchFamily="34" charset="-120"/>
               </a:rPr>
-              <a:t>хеш конфига хранится с результатом</a:t>
+              <a:t>планы зафиксированы до запуска</a:t>
             </a:r>
             <a:endParaRPr lang="en-US" sz="1000" dirty="0"/>
           </a:p>
@@ -12412,7 +12412,7 @@
                 <a:ea typeface="Arial" pitchFamily="34" charset="-122"/>
                 <a:cs typeface="Arial" pitchFamily="34" charset="-120"/>
               </a:rPr>
-              <a:t>Закрыто 39 крупных проверок: 25 таблиц и 13 379 сравнимых вариантов</a:t>
+              <a:t>39 исходных проверок + 6 robustness-проверок + 15 новых модельных идей</a:t>
             </a:r>
             <a:endParaRPr lang="en-US" sz="1150" dirty="0"/>
           </a:p>
@@ -12436,7 +12436,7 @@
                 <a:ea typeface="Arial" pitchFamily="34" charset="-122"/>
                 <a:cs typeface="Arial" pitchFamily="34" charset="-120"/>
               </a:rPr>
-              <a:t>Проверены горизонты 3/5/10 дней, пять коридоров, правила, бустинги, режимы, GARCH и abstention</a:t>
+              <a:t>Новые волны: 1 545 годовых оценок и 352 665 OOT-скоров</a:t>
             </a:r>
             <a:endParaRPr lang="en-US" sz="1150" dirty="0"/>
           </a:p>
@@ -12484,7 +12484,7 @@
                 <a:ea typeface="Arial" pitchFamily="34" charset="-122"/>
                 <a:cs typeface="Arial" pitchFamily="34" charset="-120"/>
               </a:rPr>
-              <a:t>Весь код проходит 101 автоматический тест</a:t>
+              <a:t>Весь код проходит 110 автоматических тестов</a:t>
             </a:r>
             <a:endParaRPr lang="en-US" sz="1150" dirty="0"/>
           </a:p>
@@ -12936,7 +12936,7 @@
                 <a:ea typeface="Arial" pitchFamily="34" charset="-122"/>
                 <a:cs typeface="Arial" pitchFamily="34" charset="-120"/>
               </a:rPr>
-              <a:t>Первые результаты:</a:t>
+              <a:t>Результат перепроверки:</a:t>
             </a:r>
             <a:pPr indent="0" marL="0">
               <a:lnSpc>
@@ -12953,7 +12953,7 @@
                 <a:ea typeface="Arial" pitchFamily="34" charset="-122"/>
                 <a:cs typeface="Arial" pitchFamily="34" charset="-120"/>
               </a:rPr>
-              <a:t> на h = 3/5/10 есть кандидаты с lift ≥ 1,3</a:t>
+              <a:t> главный кандидат — горизонт 5 дней</a:t>
             </a:r>
             <a:endParaRPr lang="en-US" sz="3000" dirty="0"/>
           </a:p>
@@ -13615,7 +13615,7 @@
                           <a:ea typeface="Arial" pitchFamily="34" charset="-122"/>
                           <a:cs typeface="Arial" pitchFamily="34" charset="-120"/>
                         </a:rPr>
-                        <a:t>AMD · XGBoost + явные лаги</a:t>
+                        <a:t>KZT · rolling-4y CatBoost + непрерывный порог</a:t>
                       </a:r>
                       <a:endParaRPr lang="en-US" sz="1050" dirty="0">
                         <a:latin typeface="Arial" charset="0"/>
@@ -13683,7 +13683,7 @@
                           <a:ea typeface="Arial" pitchFamily="34" charset="-122"/>
                           <a:cs typeface="Arial" pitchFamily="34" charset="-120"/>
                         </a:rPr>
-                        <a:t>248</a:t>
+                        <a:t>266</a:t>
                       </a:r>
                       <a:endParaRPr lang="en-US" sz="1050" dirty="0">
                         <a:latin typeface="Arial" charset="0"/>
@@ -13751,7 +13751,7 @@
                           <a:ea typeface="Arial" pitchFamily="34" charset="-122"/>
                           <a:cs typeface="Arial" pitchFamily="34" charset="-120"/>
                         </a:rPr>
-                        <a:t>1,36</a:t>
+                        <a:t>1,32</a:t>
                       </a:r>
                       <a:endParaRPr lang="en-US" sz="1050" dirty="0">
                         <a:latin typeface="Arial" charset="0"/>
@@ -13819,7 +13819,7 @@
                           <a:ea typeface="Arial" pitchFamily="34" charset="-122"/>
                           <a:cs typeface="Arial" pitchFamily="34" charset="-120"/>
                         </a:rPr>
-                        <a:t>1,06</a:t>
+                        <a:t>1,13</a:t>
                       </a:r>
                       <a:endParaRPr lang="en-US" sz="1050" dirty="0">
                         <a:latin typeface="Arial" charset="0"/>
@@ -13887,7 +13887,7 @@
                           <a:ea typeface="Arial" pitchFamily="34" charset="-122"/>
                           <a:cs typeface="Arial" pitchFamily="34" charset="-120"/>
                         </a:rPr>
-                        <a:t>1,18</a:t>
+                        <a:t>1,23</a:t>
                       </a:r>
                       <a:endParaRPr lang="en-US" sz="1050" dirty="0">
                         <a:latin typeface="Arial" charset="0"/>
@@ -13955,7 +13955,7 @@
                           <a:ea typeface="Arial" pitchFamily="34" charset="-122"/>
                           <a:cs typeface="Arial" pitchFamily="34" charset="-120"/>
                         </a:rPr>
-                        <a:t>1,26</a:t>
+                        <a:t>1,23</a:t>
                       </a:r>
                       <a:endParaRPr lang="en-US" sz="1050" dirty="0">
                         <a:latin typeface="Arial" charset="0"/>
@@ -14093,7 +14093,7 @@
                           <a:ea typeface="Arial" pitchFamily="34" charset="-122"/>
                           <a:cs typeface="Arial" pitchFamily="34" charset="-120"/>
                         </a:rPr>
-                        <a:t>AMD · CatBoost + triple barrier + история с 2010</a:t>
+                        <a:t>AMD · собственный скор + согласие коридоров</a:t>
                       </a:r>
                       <a:endParaRPr lang="en-US" sz="1050" dirty="0">
                         <a:latin typeface="Arial" charset="0"/>
@@ -14161,7 +14161,7 @@
                           <a:ea typeface="Arial" pitchFamily="34" charset="-122"/>
                           <a:cs typeface="Arial" pitchFamily="34" charset="-120"/>
                         </a:rPr>
-                        <a:t>240</a:t>
+                        <a:t>255</a:t>
                       </a:r>
                       <a:endParaRPr lang="en-US" sz="1050" dirty="0">
                         <a:latin typeface="Arial" charset="0"/>
@@ -14229,7 +14229,7 @@
                           <a:ea typeface="Arial" pitchFamily="34" charset="-122"/>
                           <a:cs typeface="Arial" pitchFamily="34" charset="-120"/>
                         </a:rPr>
-                        <a:t>1,41</a:t>
+                        <a:t>1,44</a:t>
                       </a:r>
                       <a:endParaRPr lang="en-US" sz="1050" dirty="0">
                         <a:latin typeface="Arial" charset="0"/>
@@ -14297,7 +14297,7 @@
                           <a:ea typeface="Arial" pitchFamily="34" charset="-122"/>
                           <a:cs typeface="Arial" pitchFamily="34" charset="-120"/>
                         </a:rPr>
-                        <a:t>1,02</a:t>
+                        <a:t>1,11</a:t>
                       </a:r>
                       <a:endParaRPr lang="en-US" sz="1050" dirty="0">
                         <a:latin typeface="Arial" charset="0"/>
@@ -14365,7 +14365,7 @@
                           <a:ea typeface="Arial" pitchFamily="34" charset="-122"/>
                           <a:cs typeface="Arial" pitchFamily="34" charset="-120"/>
                         </a:rPr>
-                        <a:t>1,18</a:t>
+                        <a:t>1,24</a:t>
                       </a:r>
                       <a:endParaRPr lang="en-US" sz="1050" dirty="0">
                         <a:latin typeface="Arial" charset="0"/>
@@ -14433,7 +14433,7 @@
                           <a:ea typeface="Arial" pitchFamily="34" charset="-122"/>
                           <a:cs typeface="Arial" pitchFamily="34" charset="-120"/>
                         </a:rPr>
-                        <a:t>1,26</a:t>
+                        <a:t>1,32</a:t>
                       </a:r>
                       <a:endParaRPr lang="en-US" sz="1050" dirty="0">
                         <a:latin typeface="Arial" charset="0"/>
@@ -14571,7 +14571,7 @@
                           <a:ea typeface="Arial" pitchFamily="34" charset="-122"/>
                           <a:cs typeface="Arial" pitchFamily="34" charset="-120"/>
                         </a:rPr>
-                        <a:t>TJS · CatBoost + triple barrier + Brent lag 7d</a:t>
+                        <a:t>KZT · собственный скор + согласие коридоров</a:t>
                       </a:r>
                       <a:endParaRPr lang="en-US" sz="1050" dirty="0">
                         <a:latin typeface="Arial" charset="0"/>
@@ -14639,7 +14639,7 @@
                           <a:ea typeface="Arial" pitchFamily="34" charset="-122"/>
                           <a:cs typeface="Arial" pitchFamily="34" charset="-120"/>
                         </a:rPr>
-                        <a:t>248</a:t>
+                        <a:t>256</a:t>
                       </a:r>
                       <a:endParaRPr lang="en-US" sz="1050" dirty="0">
                         <a:latin typeface="Arial" charset="0"/>
@@ -14707,7 +14707,7 @@
                           <a:ea typeface="Arial" pitchFamily="34" charset="-122"/>
                           <a:cs typeface="Arial" pitchFamily="34" charset="-120"/>
                         </a:rPr>
-                        <a:t>1,45</a:t>
+                        <a:t>1,44</a:t>
                       </a:r>
                       <a:endParaRPr lang="en-US" sz="1050" dirty="0">
                         <a:latin typeface="Arial" charset="0"/>
@@ -14775,7 +14775,7 @@
                           <a:ea typeface="Arial" pitchFamily="34" charset="-122"/>
                           <a:cs typeface="Arial" pitchFamily="34" charset="-120"/>
                         </a:rPr>
-                        <a:t>1,06</a:t>
+                        <a:t>1,12</a:t>
                       </a:r>
                       <a:endParaRPr lang="en-US" sz="1050" dirty="0">
                         <a:latin typeface="Arial" charset="0"/>
@@ -14843,7 +14843,7 @@
                           <a:ea typeface="Arial" pitchFamily="34" charset="-122"/>
                           <a:cs typeface="Arial" pitchFamily="34" charset="-120"/>
                         </a:rPr>
-                        <a:t>1,23</a:t>
+                        <a:t>1,21</a:t>
                       </a:r>
                       <a:endParaRPr lang="en-US" sz="1050" dirty="0">
                         <a:latin typeface="Arial" charset="0"/>
@@ -14911,7 +14911,7 @@
                           <a:ea typeface="Arial" pitchFamily="34" charset="-122"/>
                           <a:cs typeface="Arial" pitchFamily="34" charset="-120"/>
                         </a:rPr>
-                        <a:t>1,19</a:t>
+                        <a:t>1,26</a:t>
                       </a:r>
                       <a:endParaRPr lang="en-US" sz="1050" dirty="0">
                         <a:latin typeface="Arial" charset="0"/>
@@ -15090,7 +15090,7 @@
                 <a:ea typeface="Arial" pitchFamily="34" charset="-122"/>
                 <a:cs typeface="Arial" pitchFamily="34" charset="-120"/>
               </a:rPr>
-              <a:t>Цель + история + отказ</a:t>
+              <a:t>Согласие коридоров</a:t>
             </a:r>
             <a:endParaRPr lang="en-US" sz="1400" dirty="0"/>
           </a:p>
@@ -15132,7 +15132,7 @@
                 <a:ea typeface="Arial" pitchFamily="34" charset="-122"/>
                 <a:cs typeface="Arial" pitchFamily="34" charset="-120"/>
               </a:rPr>
-              <a:t>Regret/triple-barrier, история с 2010, бустинг и право модели промолчать. Четыре из пяти коридоров дали raw lift ≥ 1,3 на h = 5/10.</a:t>
+              <a:t>Для h=5 собственный скор усиливается, если похожее состояние одновременно видят остальные валюты. Это лучший новый механизм.</a:t>
             </a:r>
             <a:endParaRPr lang="en-US" sz="1100" dirty="0"/>
           </a:p>
@@ -15261,7 +15261,7 @@
                 <a:ea typeface="Arial" pitchFamily="34" charset="-122"/>
                 <a:cs typeface="Arial" pitchFamily="34" charset="-120"/>
               </a:rPr>
-              <a:t>13 379 вариантов</a:t>
+              <a:t>Две новые волны</a:t>
             </a:r>
             <a:endParaRPr lang="en-US" sz="1400" dirty="0"/>
           </a:p>
@@ -15303,7 +15303,7 @@
                 <a:ea typeface="Arial" pitchFamily="34" charset="-122"/>
                 <a:cs typeface="Arial" pitchFamily="34" charset="-120"/>
               </a:rPr>
-              <a:t>39 крупных проверок, пять коридоров, 25 итоговых таблиц. Новости сознательно не использовались.</a:t>
+              <a:t>21 фиксированный подход, пять новых seed, вложенный выбор, placebo и четырёхнедельный bootstrap.</a:t>
             </a:r>
             <a:endParaRPr lang="en-US" sz="1100" dirty="0"/>
           </a:p>
@@ -15474,7 +15474,7 @@
                 <a:ea typeface="Arial" pitchFamily="34" charset="-122"/>
                 <a:cs typeface="Arial" pitchFamily="34" charset="-120"/>
               </a:rPr>
-              <a:t>Победителей выбрали после большого перебора на одной OOT-истории. Нужен один заранее замороженный тест на новых данных.</a:t>
+              <a:t>2025–2026 уже видели исследователи. Даже сильный результат требует проверки на будущих или закрытых данных банка.</a:t>
             </a:r>
             <a:endParaRPr lang="en-US" sz="1100" dirty="0"/>
           </a:p>
@@ -15542,7 +15542,7 @@
                 <a:ea typeface="Arial" pitchFamily="34" charset="-122"/>
                 <a:cs typeface="Arial" pitchFamily="34" charset="-120"/>
               </a:rPr>
-              <a:t>Цена ожидания тоже измерена</a:t>
+              <a:t>Стресс-тест h=5 без пересекающихся окон</a:t>
             </a:r>
             <a:endParaRPr lang="en-US" sz="1400" dirty="0"/>
           </a:p>
@@ -15584,7 +15584,7 @@
                 <a:ea typeface="Arial" pitchFamily="34" charset="-122"/>
                 <a:cs typeface="Arial" pitchFamily="34" charset="-120"/>
               </a:rPr>
-              <a:t>Заявка −1 % / 14 дней исполняется в 48 % стартов. Optimal-stopping proxy уменьшает средний regret на 15–35 %, но пока использует искусственный дедлайн.</a:t>
+              <a:t>184 сигнала · raw lift 1,40 · same-week lift 1,26 · 0,80 сигнала в неделю. h=10 в этом тесте падает до 1,18 / 1,08.</a:t>
             </a:r>
             <a:endParaRPr lang="en-US" sz="1150" dirty="0"/>
           </a:p>
@@ -15773,7 +15773,7 @@
                 <a:ea typeface="Arial" pitchFamily="34" charset="-122"/>
                 <a:cs typeface="Arial" pitchFamily="34" charset="-120"/>
               </a:rPr>
-              <a:t> сигнал найден, но продуктовый эффект ещё не доказан</a:t>
+              <a:t> h=5 стоит заморозить и проверить на новых данных</a:t>
             </a:r>
             <a:endParaRPr lang="en-US" sz="3000" dirty="0"/>
           </a:p>
@@ -15902,7 +15902,7 @@
                 <a:ea typeface="Arial" pitchFamily="34" charset="-122"/>
                 <a:cs typeface="Arial" pitchFamily="34" charset="-120"/>
               </a:rPr>
-              <a:t>1,36–1,45</a:t>
+              <a:t>1,44 / 1,24</a:t>
             </a:r>
             <a:endParaRPr lang="en-US" sz="4000" dirty="0"/>
           </a:p>
@@ -15944,7 +15944,7 @@
                 <a:ea typeface="Arial" pitchFamily="34" charset="-122"/>
                 <a:cs typeface="Arial" pitchFamily="34" charset="-120"/>
               </a:rPr>
-              <a:t>raw lift лучших моделей при 1,02–1,06 сигнала в неделю. Это соответствует требованию по lift и частоте на просмотренной истории.</a:t>
+              <a:t>raw / same-week lift основного h=5 кандидата при 1,11 сигнала в неделю. Четырёхнедельный CI same-week: 1,16–1,32.</a:t>
             </a:r>
             <a:endParaRPr lang="en-US" sz="1200" dirty="0"/>
           </a:p>
@@ -16073,7 +16073,7 @@
                 <a:ea typeface="Arial" pitchFamily="34" charset="-122"/>
                 <a:cs typeface="Arial" pitchFamily="34" charset="-120"/>
               </a:rPr>
-              <a:t>1,18–1,23</a:t>
+              <a:t>1,32 / 1,15</a:t>
             </a:r>
             <a:endParaRPr lang="en-US" sz="4000" dirty="0"/>
           </a:p>
@@ -16115,7 +16115,7 @@
                 <a:ea typeface="Arial" pitchFamily="34" charset="-122"/>
                 <a:cs typeface="Arial" pitchFamily="34" charset="-120"/>
               </a:rPr>
-              <a:t>lift против случайного дня той же недели. Худший год: 1,19–1,26. Запаса устойчивости до 1,3 пока нет.</a:t>
+              <a:t>raw / same-week lift h=5 при последовательном выборе только по прошлым годам. Это реалистичнее максимума одной строки.</a:t>
             </a:r>
             <a:endParaRPr lang="en-US" sz="1200" dirty="0"/>
           </a:p>
@@ -16183,7 +16183,7 @@
                 <a:ea typeface="Arial" pitchFamily="34" charset="-122"/>
                 <a:cs typeface="Arial" pitchFamily="34" charset="-120"/>
               </a:rPr>
-              <a:t>Почему вывод изменился после первого отрицательного прогона</a:t>
+              <a:t>Что выдержало перепроверку</a:t>
             </a:r>
             <a:endParaRPr lang="en-US" sz="1500" dirty="0"/>
           </a:p>
@@ -16225,7 +16225,7 @@
                 <a:ea typeface="Arial" pitchFamily="34" charset="-122"/>
                 <a:cs typeface="Arial" pitchFamily="34" charset="-120"/>
               </a:rPr>
-              <a:t>Первые модели работали только на CNY/RUB и строгом локальном минимуме. Длинная история, пять коридоров, продуктовая regret-цель, triple barrier и selective prediction создали кандидатов нужной частоты. Отрицательный вывод остаётся верным только для первой постановки.</a:t>
+              <a:t>Regret/triple barrier вместо точного минимума, rolling-история последних четырёх лет, CatBoost, право модели промолчать и подтверждение общего рублёвого режима другими коридорами. Исторические аналоги и сложные режимные модели не помогли.</a:t>
             </a:r>
             <a:endParaRPr lang="en-US" sz="1200" dirty="0"/>
           </a:p>
@@ -16357,7 +16357,7 @@
                 <a:ea typeface="Arial" pitchFamily="34" charset="-122"/>
                 <a:cs typeface="Arial" pitchFamily="34" charset="-120"/>
               </a:rPr>
-              <a:t>Не отправлять пуши клиентам по exploratory-результату. Заморозить один пайплайн, проверить его на нетронутом периоде, пересчитать выгоду на реальном курсе приложения и только затем запускать ограниченный A/B-пилот.</a:t>
+              <a:t>Не отправлять пуши по exploratory-результату. Заморозить основной h=5 consensus и контрольный rolling-4y CatBoost, проверить на новом периоде, пересчитать выгоду на курсе приложения и только затем запускать ограниченный A/B-пилот.</a:t>
             </a:r>
             <a:endParaRPr lang="en-US" sz="1200" dirty="0"/>
           </a:p>

</xml_diff>